<commit_message>
feat(sih): integrate official mandatory SIH cover template on Slide 1 and official SIH header logos
</commit_message>
<xml_diff>
--- a/docs/sih/SIH2026_ARIES_LIGHT_THEME.pptx
+++ b/docs/sih/SIH2026_ARIES_LIGHT_THEME.pptx
@@ -134,7 +134,7 @@
           <p:cNvPr id="2" name="Title 1">
             <a:extLst>
               <a:ext uri="{FF2B5EF4-FFF2-40B4-BE49-F238E27FC236}">
-                <a16:creationId xmlns:a16="http://schemas.microsoft.com/office/drawing/2014/main" id="{DB97C5BF-FE98-9681-7147-C26878E49782}"/>
+                <a16:creationId xmlns:a16="http://schemas.microsoft.com/office/drawing/2014/main" id="{3C356813-A2A1-A31A-52FA-3C5BB09395CC}"/>
               </a:ext>
             </a:extLst>
           </p:cNvPr>
@@ -172,7 +172,7 @@
           <p:cNvPr id="3" name="Subtitle 2">
             <a:extLst>
               <a:ext uri="{FF2B5EF4-FFF2-40B4-BE49-F238E27FC236}">
-                <a16:creationId xmlns:a16="http://schemas.microsoft.com/office/drawing/2014/main" id="{CAB2D61B-FB8F-75C3-51C1-A42FB4308C0D}"/>
+                <a16:creationId xmlns:a16="http://schemas.microsoft.com/office/drawing/2014/main" id="{94B52E97-1918-199B-EB31-53BE2B0B08B4}"/>
               </a:ext>
             </a:extLst>
           </p:cNvPr>
@@ -243,7 +243,7 @@
           <p:cNvPr id="4" name="Date Placeholder 3">
             <a:extLst>
               <a:ext uri="{FF2B5EF4-FFF2-40B4-BE49-F238E27FC236}">
-                <a16:creationId xmlns:a16="http://schemas.microsoft.com/office/drawing/2014/main" id="{13B7FEAB-4359-A27E-F8DC-E928B47F598A}"/>
+                <a16:creationId xmlns:a16="http://schemas.microsoft.com/office/drawing/2014/main" id="{1CA81B54-F183-2B68-BE3E-A08BBB35A2AF}"/>
               </a:ext>
             </a:extLst>
           </p:cNvPr>
@@ -259,7 +259,7 @@
           <a:bodyPr/>
           <a:lstStyle/>
           <a:p>
-            <a:fld id="{99BF043A-CA38-4ED0-BB8D-C66D150D6DA3}" type="datetimeFigureOut">
+            <a:fld id="{13335322-04FB-414F-B5C5-B62F9051266D}" type="datetimeFigureOut">
               <a:rPr lang="en-IN" smtClean="0"/>
               <a:t>24-09-2026</a:t>
             </a:fld>
@@ -272,7 +272,7 @@
           <p:cNvPr id="5" name="Footer Placeholder 4">
             <a:extLst>
               <a:ext uri="{FF2B5EF4-FFF2-40B4-BE49-F238E27FC236}">
-                <a16:creationId xmlns:a16="http://schemas.microsoft.com/office/drawing/2014/main" id="{CF57DA75-226E-9C21-FE0E-F4F8079D881A}"/>
+                <a16:creationId xmlns:a16="http://schemas.microsoft.com/office/drawing/2014/main" id="{9058A82A-E3D7-3F7B-6D09-19A2E6850A6A}"/>
               </a:ext>
             </a:extLst>
           </p:cNvPr>
@@ -297,7 +297,7 @@
           <p:cNvPr id="6" name="Slide Number Placeholder 5">
             <a:extLst>
               <a:ext uri="{FF2B5EF4-FFF2-40B4-BE49-F238E27FC236}">
-                <a16:creationId xmlns:a16="http://schemas.microsoft.com/office/drawing/2014/main" id="{EF673143-CF06-6403-C44E-B7573B78E5C1}"/>
+                <a16:creationId xmlns:a16="http://schemas.microsoft.com/office/drawing/2014/main" id="{CEAA81C7-4DEE-1F93-FE37-C4F7C12CCBBA}"/>
               </a:ext>
             </a:extLst>
           </p:cNvPr>
@@ -313,7 +313,7 @@
           <a:bodyPr/>
           <a:lstStyle/>
           <a:p>
-            <a:fld id="{47B02238-B2B4-4440-85F4-07CF07CD763B}" type="slidenum">
+            <a:fld id="{33254770-DAD8-4BD1-9C12-9EA3D5037C3F}" type="slidenum">
               <a:rPr lang="en-IN" smtClean="0"/>
               <a:t>‹#›</a:t>
             </a:fld>
@@ -324,7 +324,7 @@
     </p:spTree>
     <p:extLst>
       <p:ext uri="{BB962C8B-B14F-4D97-AF65-F5344CB8AC3E}">
-        <p14:creationId xmlns:p14="http://schemas.microsoft.com/office/powerpoint/2010/main" val="4159638489"/>
+        <p14:creationId xmlns:p14="http://schemas.microsoft.com/office/powerpoint/2010/main" val="2484163866"/>
       </p:ext>
     </p:extLst>
   </p:cSld>
@@ -356,7 +356,7 @@
           <p:cNvPr id="2" name="Title 1">
             <a:extLst>
               <a:ext uri="{FF2B5EF4-FFF2-40B4-BE49-F238E27FC236}">
-                <a16:creationId xmlns:a16="http://schemas.microsoft.com/office/drawing/2014/main" id="{82E99A8F-54CD-FD46-5119-4E5C40204FFB}"/>
+                <a16:creationId xmlns:a16="http://schemas.microsoft.com/office/drawing/2014/main" id="{EB59C4DB-3A2C-2B18-AFE6-EB90448DDBB4}"/>
               </a:ext>
             </a:extLst>
           </p:cNvPr>
@@ -385,7 +385,7 @@
           <p:cNvPr id="3" name="Vertical Text Placeholder 2">
             <a:extLst>
               <a:ext uri="{FF2B5EF4-FFF2-40B4-BE49-F238E27FC236}">
-                <a16:creationId xmlns:a16="http://schemas.microsoft.com/office/drawing/2014/main" id="{33BDD19F-6262-2266-A0E6-826B8ABA7AB7}"/>
+                <a16:creationId xmlns:a16="http://schemas.microsoft.com/office/drawing/2014/main" id="{74347469-F341-1AAC-EECB-C38422AC57B2}"/>
               </a:ext>
             </a:extLst>
           </p:cNvPr>
@@ -443,7 +443,7 @@
           <p:cNvPr id="4" name="Date Placeholder 3">
             <a:extLst>
               <a:ext uri="{FF2B5EF4-FFF2-40B4-BE49-F238E27FC236}">
-                <a16:creationId xmlns:a16="http://schemas.microsoft.com/office/drawing/2014/main" id="{56946E8F-CA50-C62E-07F6-6232965F4531}"/>
+                <a16:creationId xmlns:a16="http://schemas.microsoft.com/office/drawing/2014/main" id="{C60CC343-D772-3A1E-36BC-4E9FAF83ABA6}"/>
               </a:ext>
             </a:extLst>
           </p:cNvPr>
@@ -459,7 +459,7 @@
           <a:bodyPr/>
           <a:lstStyle/>
           <a:p>
-            <a:fld id="{99BF043A-CA38-4ED0-BB8D-C66D150D6DA3}" type="datetimeFigureOut">
+            <a:fld id="{13335322-04FB-414F-B5C5-B62F9051266D}" type="datetimeFigureOut">
               <a:rPr lang="en-IN" smtClean="0"/>
               <a:t>24-09-2026</a:t>
             </a:fld>
@@ -472,7 +472,7 @@
           <p:cNvPr id="5" name="Footer Placeholder 4">
             <a:extLst>
               <a:ext uri="{FF2B5EF4-FFF2-40B4-BE49-F238E27FC236}">
-                <a16:creationId xmlns:a16="http://schemas.microsoft.com/office/drawing/2014/main" id="{C6357749-8287-EA3E-7D49-C8FA83734F20}"/>
+                <a16:creationId xmlns:a16="http://schemas.microsoft.com/office/drawing/2014/main" id="{FECCA1FC-CAB8-E7FD-CD1C-146915318A8D}"/>
               </a:ext>
             </a:extLst>
           </p:cNvPr>
@@ -497,7 +497,7 @@
           <p:cNvPr id="6" name="Slide Number Placeholder 5">
             <a:extLst>
               <a:ext uri="{FF2B5EF4-FFF2-40B4-BE49-F238E27FC236}">
-                <a16:creationId xmlns:a16="http://schemas.microsoft.com/office/drawing/2014/main" id="{FCFD427D-07A1-C3DD-DFF5-FF0088A1333D}"/>
+                <a16:creationId xmlns:a16="http://schemas.microsoft.com/office/drawing/2014/main" id="{4C50C771-2B6F-408C-CB11-77312F764940}"/>
               </a:ext>
             </a:extLst>
           </p:cNvPr>
@@ -513,7 +513,7 @@
           <a:bodyPr/>
           <a:lstStyle/>
           <a:p>
-            <a:fld id="{47B02238-B2B4-4440-85F4-07CF07CD763B}" type="slidenum">
+            <a:fld id="{33254770-DAD8-4BD1-9C12-9EA3D5037C3F}" type="slidenum">
               <a:rPr lang="en-IN" smtClean="0"/>
               <a:t>‹#›</a:t>
             </a:fld>
@@ -524,7 +524,7 @@
     </p:spTree>
     <p:extLst>
       <p:ext uri="{BB962C8B-B14F-4D97-AF65-F5344CB8AC3E}">
-        <p14:creationId xmlns:p14="http://schemas.microsoft.com/office/powerpoint/2010/main" val="3557592606"/>
+        <p14:creationId xmlns:p14="http://schemas.microsoft.com/office/powerpoint/2010/main" val="2853643958"/>
       </p:ext>
     </p:extLst>
   </p:cSld>
@@ -556,7 +556,7 @@
           <p:cNvPr id="2" name="Vertical Title 1">
             <a:extLst>
               <a:ext uri="{FF2B5EF4-FFF2-40B4-BE49-F238E27FC236}">
-                <a16:creationId xmlns:a16="http://schemas.microsoft.com/office/drawing/2014/main" id="{454F3ED5-0AEA-EA73-19AC-E6EA9C3CDE7B}"/>
+                <a16:creationId xmlns:a16="http://schemas.microsoft.com/office/drawing/2014/main" id="{969544CC-0C8E-19D2-198E-35E87250F192}"/>
               </a:ext>
             </a:extLst>
           </p:cNvPr>
@@ -590,7 +590,7 @@
           <p:cNvPr id="3" name="Vertical Text Placeholder 2">
             <a:extLst>
               <a:ext uri="{FF2B5EF4-FFF2-40B4-BE49-F238E27FC236}">
-                <a16:creationId xmlns:a16="http://schemas.microsoft.com/office/drawing/2014/main" id="{52146E03-789F-1D61-791E-CCBA00B2B9C0}"/>
+                <a16:creationId xmlns:a16="http://schemas.microsoft.com/office/drawing/2014/main" id="{C5EAE2D0-6330-80E5-EBDB-2620FA11EE0F}"/>
               </a:ext>
             </a:extLst>
           </p:cNvPr>
@@ -653,7 +653,7 @@
           <p:cNvPr id="4" name="Date Placeholder 3">
             <a:extLst>
               <a:ext uri="{FF2B5EF4-FFF2-40B4-BE49-F238E27FC236}">
-                <a16:creationId xmlns:a16="http://schemas.microsoft.com/office/drawing/2014/main" id="{9003BC38-941D-1D01-9C0A-B68D3488A434}"/>
+                <a16:creationId xmlns:a16="http://schemas.microsoft.com/office/drawing/2014/main" id="{6EC2DA01-09D1-6564-3844-DF60602E130D}"/>
               </a:ext>
             </a:extLst>
           </p:cNvPr>
@@ -669,7 +669,7 @@
           <a:bodyPr/>
           <a:lstStyle/>
           <a:p>
-            <a:fld id="{99BF043A-CA38-4ED0-BB8D-C66D150D6DA3}" type="datetimeFigureOut">
+            <a:fld id="{13335322-04FB-414F-B5C5-B62F9051266D}" type="datetimeFigureOut">
               <a:rPr lang="en-IN" smtClean="0"/>
               <a:t>24-09-2026</a:t>
             </a:fld>
@@ -682,7 +682,7 @@
           <p:cNvPr id="5" name="Footer Placeholder 4">
             <a:extLst>
               <a:ext uri="{FF2B5EF4-FFF2-40B4-BE49-F238E27FC236}">
-                <a16:creationId xmlns:a16="http://schemas.microsoft.com/office/drawing/2014/main" id="{37F47B33-FD16-4DF1-FBE6-B1308606C106}"/>
+                <a16:creationId xmlns:a16="http://schemas.microsoft.com/office/drawing/2014/main" id="{3A2FED82-4E27-827B-6B01-3B0EE88D3217}"/>
               </a:ext>
             </a:extLst>
           </p:cNvPr>
@@ -707,7 +707,7 @@
           <p:cNvPr id="6" name="Slide Number Placeholder 5">
             <a:extLst>
               <a:ext uri="{FF2B5EF4-FFF2-40B4-BE49-F238E27FC236}">
-                <a16:creationId xmlns:a16="http://schemas.microsoft.com/office/drawing/2014/main" id="{229F8434-B022-CCD4-DB5C-AC6757BFC49F}"/>
+                <a16:creationId xmlns:a16="http://schemas.microsoft.com/office/drawing/2014/main" id="{17681005-561E-A65B-EA53-2B610F7C5CC1}"/>
               </a:ext>
             </a:extLst>
           </p:cNvPr>
@@ -723,7 +723,7 @@
           <a:bodyPr/>
           <a:lstStyle/>
           <a:p>
-            <a:fld id="{47B02238-B2B4-4440-85F4-07CF07CD763B}" type="slidenum">
+            <a:fld id="{33254770-DAD8-4BD1-9C12-9EA3D5037C3F}" type="slidenum">
               <a:rPr lang="en-IN" smtClean="0"/>
               <a:t>‹#›</a:t>
             </a:fld>
@@ -734,7 +734,7 @@
     </p:spTree>
     <p:extLst>
       <p:ext uri="{BB962C8B-B14F-4D97-AF65-F5344CB8AC3E}">
-        <p14:creationId xmlns:p14="http://schemas.microsoft.com/office/powerpoint/2010/main" val="3901066481"/>
+        <p14:creationId xmlns:p14="http://schemas.microsoft.com/office/powerpoint/2010/main" val="2507134671"/>
       </p:ext>
     </p:extLst>
   </p:cSld>
@@ -766,7 +766,7 @@
           <p:cNvPr id="2" name="Title 1">
             <a:extLst>
               <a:ext uri="{FF2B5EF4-FFF2-40B4-BE49-F238E27FC236}">
-                <a16:creationId xmlns:a16="http://schemas.microsoft.com/office/drawing/2014/main" id="{64B3E17D-AB4E-0327-E2ED-062093BB3B20}"/>
+                <a16:creationId xmlns:a16="http://schemas.microsoft.com/office/drawing/2014/main" id="{591D6CD1-445C-7C1B-FA11-18B99EACDC26}"/>
               </a:ext>
             </a:extLst>
           </p:cNvPr>
@@ -795,7 +795,7 @@
           <p:cNvPr id="3" name="Content Placeholder 2">
             <a:extLst>
               <a:ext uri="{FF2B5EF4-FFF2-40B4-BE49-F238E27FC236}">
-                <a16:creationId xmlns:a16="http://schemas.microsoft.com/office/drawing/2014/main" id="{6BFE17E2-C818-E81D-0900-0857C41496B0}"/>
+                <a16:creationId xmlns:a16="http://schemas.microsoft.com/office/drawing/2014/main" id="{BDF144AF-CF16-298E-3E7E-4BBD536FCB4D}"/>
               </a:ext>
             </a:extLst>
           </p:cNvPr>
@@ -853,7 +853,7 @@
           <p:cNvPr id="4" name="Date Placeholder 3">
             <a:extLst>
               <a:ext uri="{FF2B5EF4-FFF2-40B4-BE49-F238E27FC236}">
-                <a16:creationId xmlns:a16="http://schemas.microsoft.com/office/drawing/2014/main" id="{E908B597-DD34-5F33-3820-C296F66AC7E5}"/>
+                <a16:creationId xmlns:a16="http://schemas.microsoft.com/office/drawing/2014/main" id="{EF63DEB4-2008-05A4-A476-1553190136D1}"/>
               </a:ext>
             </a:extLst>
           </p:cNvPr>
@@ -869,7 +869,7 @@
           <a:bodyPr/>
           <a:lstStyle/>
           <a:p>
-            <a:fld id="{99BF043A-CA38-4ED0-BB8D-C66D150D6DA3}" type="datetimeFigureOut">
+            <a:fld id="{13335322-04FB-414F-B5C5-B62F9051266D}" type="datetimeFigureOut">
               <a:rPr lang="en-IN" smtClean="0"/>
               <a:t>24-09-2026</a:t>
             </a:fld>
@@ -882,7 +882,7 @@
           <p:cNvPr id="5" name="Footer Placeholder 4">
             <a:extLst>
               <a:ext uri="{FF2B5EF4-FFF2-40B4-BE49-F238E27FC236}">
-                <a16:creationId xmlns:a16="http://schemas.microsoft.com/office/drawing/2014/main" id="{03A9114D-15F0-A9B5-29FE-3A9C8D2BF28A}"/>
+                <a16:creationId xmlns:a16="http://schemas.microsoft.com/office/drawing/2014/main" id="{FAA88012-EA5B-25F1-0594-B2929B248A47}"/>
               </a:ext>
             </a:extLst>
           </p:cNvPr>
@@ -907,7 +907,7 @@
           <p:cNvPr id="6" name="Slide Number Placeholder 5">
             <a:extLst>
               <a:ext uri="{FF2B5EF4-FFF2-40B4-BE49-F238E27FC236}">
-                <a16:creationId xmlns:a16="http://schemas.microsoft.com/office/drawing/2014/main" id="{2926B64E-8DC6-39C3-D1DD-59AC27B3E693}"/>
+                <a16:creationId xmlns:a16="http://schemas.microsoft.com/office/drawing/2014/main" id="{5352F43A-37CC-2D55-97CC-B6BBE0E1F39B}"/>
               </a:ext>
             </a:extLst>
           </p:cNvPr>
@@ -923,7 +923,7 @@
           <a:bodyPr/>
           <a:lstStyle/>
           <a:p>
-            <a:fld id="{47B02238-B2B4-4440-85F4-07CF07CD763B}" type="slidenum">
+            <a:fld id="{33254770-DAD8-4BD1-9C12-9EA3D5037C3F}" type="slidenum">
               <a:rPr lang="en-IN" smtClean="0"/>
               <a:t>‹#›</a:t>
             </a:fld>
@@ -934,7 +934,7 @@
     </p:spTree>
     <p:extLst>
       <p:ext uri="{BB962C8B-B14F-4D97-AF65-F5344CB8AC3E}">
-        <p14:creationId xmlns:p14="http://schemas.microsoft.com/office/powerpoint/2010/main" val="1338180853"/>
+        <p14:creationId xmlns:p14="http://schemas.microsoft.com/office/powerpoint/2010/main" val="1132463312"/>
       </p:ext>
     </p:extLst>
   </p:cSld>
@@ -966,7 +966,7 @@
           <p:cNvPr id="2" name="Title 1">
             <a:extLst>
               <a:ext uri="{FF2B5EF4-FFF2-40B4-BE49-F238E27FC236}">
-                <a16:creationId xmlns:a16="http://schemas.microsoft.com/office/drawing/2014/main" id="{51A1E9B5-8A13-D988-F3B1-73A5167FC408}"/>
+                <a16:creationId xmlns:a16="http://schemas.microsoft.com/office/drawing/2014/main" id="{070B9FFF-EC26-0997-45C6-E6C353B36933}"/>
               </a:ext>
             </a:extLst>
           </p:cNvPr>
@@ -1004,7 +1004,7 @@
           <p:cNvPr id="3" name="Text Placeholder 2">
             <a:extLst>
               <a:ext uri="{FF2B5EF4-FFF2-40B4-BE49-F238E27FC236}">
-                <a16:creationId xmlns:a16="http://schemas.microsoft.com/office/drawing/2014/main" id="{21084878-F2BB-461E-FF65-940DF6EEC7C1}"/>
+                <a16:creationId xmlns:a16="http://schemas.microsoft.com/office/drawing/2014/main" id="{4A90EC45-71FF-D688-7F22-A6B15D1C25B0}"/>
               </a:ext>
             </a:extLst>
           </p:cNvPr>
@@ -1129,7 +1129,7 @@
           <p:cNvPr id="4" name="Date Placeholder 3">
             <a:extLst>
               <a:ext uri="{FF2B5EF4-FFF2-40B4-BE49-F238E27FC236}">
-                <a16:creationId xmlns:a16="http://schemas.microsoft.com/office/drawing/2014/main" id="{8B06DDE2-4BD4-FAF1-F51E-4EB755955EC3}"/>
+                <a16:creationId xmlns:a16="http://schemas.microsoft.com/office/drawing/2014/main" id="{ACA8F593-5A7F-E63B-80F5-721D4627C9EB}"/>
               </a:ext>
             </a:extLst>
           </p:cNvPr>
@@ -1145,7 +1145,7 @@
           <a:bodyPr/>
           <a:lstStyle/>
           <a:p>
-            <a:fld id="{99BF043A-CA38-4ED0-BB8D-C66D150D6DA3}" type="datetimeFigureOut">
+            <a:fld id="{13335322-04FB-414F-B5C5-B62F9051266D}" type="datetimeFigureOut">
               <a:rPr lang="en-IN" smtClean="0"/>
               <a:t>24-09-2026</a:t>
             </a:fld>
@@ -1158,7 +1158,7 @@
           <p:cNvPr id="5" name="Footer Placeholder 4">
             <a:extLst>
               <a:ext uri="{FF2B5EF4-FFF2-40B4-BE49-F238E27FC236}">
-                <a16:creationId xmlns:a16="http://schemas.microsoft.com/office/drawing/2014/main" id="{2428D45D-C68B-0079-C736-405A1F9054A2}"/>
+                <a16:creationId xmlns:a16="http://schemas.microsoft.com/office/drawing/2014/main" id="{600EC9A4-4597-FDAC-D266-52E957FF3C41}"/>
               </a:ext>
             </a:extLst>
           </p:cNvPr>
@@ -1183,7 +1183,7 @@
           <p:cNvPr id="6" name="Slide Number Placeholder 5">
             <a:extLst>
               <a:ext uri="{FF2B5EF4-FFF2-40B4-BE49-F238E27FC236}">
-                <a16:creationId xmlns:a16="http://schemas.microsoft.com/office/drawing/2014/main" id="{FC7AD7BC-8A0B-9759-C4B5-8AE166A2ECFD}"/>
+                <a16:creationId xmlns:a16="http://schemas.microsoft.com/office/drawing/2014/main" id="{F1BF1BDF-8E34-4956-B720-B9DFEA05DFE4}"/>
               </a:ext>
             </a:extLst>
           </p:cNvPr>
@@ -1199,7 +1199,7 @@
           <a:bodyPr/>
           <a:lstStyle/>
           <a:p>
-            <a:fld id="{47B02238-B2B4-4440-85F4-07CF07CD763B}" type="slidenum">
+            <a:fld id="{33254770-DAD8-4BD1-9C12-9EA3D5037C3F}" type="slidenum">
               <a:rPr lang="en-IN" smtClean="0"/>
               <a:t>‹#›</a:t>
             </a:fld>
@@ -1210,7 +1210,7 @@
     </p:spTree>
     <p:extLst>
       <p:ext uri="{BB962C8B-B14F-4D97-AF65-F5344CB8AC3E}">
-        <p14:creationId xmlns:p14="http://schemas.microsoft.com/office/powerpoint/2010/main" val="1758555049"/>
+        <p14:creationId xmlns:p14="http://schemas.microsoft.com/office/powerpoint/2010/main" val="60320974"/>
       </p:ext>
     </p:extLst>
   </p:cSld>
@@ -1242,7 +1242,7 @@
           <p:cNvPr id="2" name="Title 1">
             <a:extLst>
               <a:ext uri="{FF2B5EF4-FFF2-40B4-BE49-F238E27FC236}">
-                <a16:creationId xmlns:a16="http://schemas.microsoft.com/office/drawing/2014/main" id="{DB029495-9455-18FA-93AC-EDA276DEAFC9}"/>
+                <a16:creationId xmlns:a16="http://schemas.microsoft.com/office/drawing/2014/main" id="{C0BB9672-A845-DF25-9C91-D7D59D791F6D}"/>
               </a:ext>
             </a:extLst>
           </p:cNvPr>
@@ -1271,7 +1271,7 @@
           <p:cNvPr id="3" name="Content Placeholder 2">
             <a:extLst>
               <a:ext uri="{FF2B5EF4-FFF2-40B4-BE49-F238E27FC236}">
-                <a16:creationId xmlns:a16="http://schemas.microsoft.com/office/drawing/2014/main" id="{458DA2D5-1BA3-AC10-0DDF-8A24C2BE7FEA}"/>
+                <a16:creationId xmlns:a16="http://schemas.microsoft.com/office/drawing/2014/main" id="{0A9AAFBE-BC8D-839B-B581-C62A9E32CFA4}"/>
               </a:ext>
             </a:extLst>
           </p:cNvPr>
@@ -1334,7 +1334,7 @@
           <p:cNvPr id="4" name="Content Placeholder 3">
             <a:extLst>
               <a:ext uri="{FF2B5EF4-FFF2-40B4-BE49-F238E27FC236}">
-                <a16:creationId xmlns:a16="http://schemas.microsoft.com/office/drawing/2014/main" id="{60CBCE96-100A-A734-CC49-7C255B408362}"/>
+                <a16:creationId xmlns:a16="http://schemas.microsoft.com/office/drawing/2014/main" id="{B34050F3-16EC-139A-099B-9A2AFBD57441}"/>
               </a:ext>
             </a:extLst>
           </p:cNvPr>
@@ -1397,7 +1397,7 @@
           <p:cNvPr id="5" name="Date Placeholder 4">
             <a:extLst>
               <a:ext uri="{FF2B5EF4-FFF2-40B4-BE49-F238E27FC236}">
-                <a16:creationId xmlns:a16="http://schemas.microsoft.com/office/drawing/2014/main" id="{14EA858F-DADA-8846-DF73-6E1881C11FC8}"/>
+                <a16:creationId xmlns:a16="http://schemas.microsoft.com/office/drawing/2014/main" id="{028B1169-5D05-656D-36F0-39BD4F31236F}"/>
               </a:ext>
             </a:extLst>
           </p:cNvPr>
@@ -1413,7 +1413,7 @@
           <a:bodyPr/>
           <a:lstStyle/>
           <a:p>
-            <a:fld id="{99BF043A-CA38-4ED0-BB8D-C66D150D6DA3}" type="datetimeFigureOut">
+            <a:fld id="{13335322-04FB-414F-B5C5-B62F9051266D}" type="datetimeFigureOut">
               <a:rPr lang="en-IN" smtClean="0"/>
               <a:t>24-09-2026</a:t>
             </a:fld>
@@ -1426,7 +1426,7 @@
           <p:cNvPr id="6" name="Footer Placeholder 5">
             <a:extLst>
               <a:ext uri="{FF2B5EF4-FFF2-40B4-BE49-F238E27FC236}">
-                <a16:creationId xmlns:a16="http://schemas.microsoft.com/office/drawing/2014/main" id="{A15BE5E4-85DD-1E38-4CC0-984E2A460CAE}"/>
+                <a16:creationId xmlns:a16="http://schemas.microsoft.com/office/drawing/2014/main" id="{46F6CCA0-8803-BBBE-3564-DFB1AF3ABF89}"/>
               </a:ext>
             </a:extLst>
           </p:cNvPr>
@@ -1451,7 +1451,7 @@
           <p:cNvPr id="7" name="Slide Number Placeholder 6">
             <a:extLst>
               <a:ext uri="{FF2B5EF4-FFF2-40B4-BE49-F238E27FC236}">
-                <a16:creationId xmlns:a16="http://schemas.microsoft.com/office/drawing/2014/main" id="{BE85DB7B-0B6A-7682-FA11-C52E58B74786}"/>
+                <a16:creationId xmlns:a16="http://schemas.microsoft.com/office/drawing/2014/main" id="{4D41E4B3-2F40-A1F6-8188-87380655D2B5}"/>
               </a:ext>
             </a:extLst>
           </p:cNvPr>
@@ -1467,7 +1467,7 @@
           <a:bodyPr/>
           <a:lstStyle/>
           <a:p>
-            <a:fld id="{47B02238-B2B4-4440-85F4-07CF07CD763B}" type="slidenum">
+            <a:fld id="{33254770-DAD8-4BD1-9C12-9EA3D5037C3F}" type="slidenum">
               <a:rPr lang="en-IN" smtClean="0"/>
               <a:t>‹#›</a:t>
             </a:fld>
@@ -1478,7 +1478,7 @@
     </p:spTree>
     <p:extLst>
       <p:ext uri="{BB962C8B-B14F-4D97-AF65-F5344CB8AC3E}">
-        <p14:creationId xmlns:p14="http://schemas.microsoft.com/office/powerpoint/2010/main" val="4103629897"/>
+        <p14:creationId xmlns:p14="http://schemas.microsoft.com/office/powerpoint/2010/main" val="1503102472"/>
       </p:ext>
     </p:extLst>
   </p:cSld>
@@ -1510,7 +1510,7 @@
           <p:cNvPr id="2" name="Title 1">
             <a:extLst>
               <a:ext uri="{FF2B5EF4-FFF2-40B4-BE49-F238E27FC236}">
-                <a16:creationId xmlns:a16="http://schemas.microsoft.com/office/drawing/2014/main" id="{2EA65D5A-A4D9-E9CD-5B54-CB4447A5F1F8}"/>
+                <a16:creationId xmlns:a16="http://schemas.microsoft.com/office/drawing/2014/main" id="{269F1435-5B39-F8DE-65DB-042DDE5FE089}"/>
               </a:ext>
             </a:extLst>
           </p:cNvPr>
@@ -1544,7 +1544,7 @@
           <p:cNvPr id="3" name="Text Placeholder 2">
             <a:extLst>
               <a:ext uri="{FF2B5EF4-FFF2-40B4-BE49-F238E27FC236}">
-                <a16:creationId xmlns:a16="http://schemas.microsoft.com/office/drawing/2014/main" id="{76318AA7-F25A-3190-AF55-7D3E814E83EF}"/>
+                <a16:creationId xmlns:a16="http://schemas.microsoft.com/office/drawing/2014/main" id="{6D8EF54A-F4BC-649E-95C3-EE24574F8F57}"/>
               </a:ext>
             </a:extLst>
           </p:cNvPr>
@@ -1615,7 +1615,7 @@
           <p:cNvPr id="4" name="Content Placeholder 3">
             <a:extLst>
               <a:ext uri="{FF2B5EF4-FFF2-40B4-BE49-F238E27FC236}">
-                <a16:creationId xmlns:a16="http://schemas.microsoft.com/office/drawing/2014/main" id="{4EC925ED-C818-E7E0-98EC-F1DE820430BB}"/>
+                <a16:creationId xmlns:a16="http://schemas.microsoft.com/office/drawing/2014/main" id="{F4E9499C-247A-AAFF-F491-70A755E4C854}"/>
               </a:ext>
             </a:extLst>
           </p:cNvPr>
@@ -1678,7 +1678,7 @@
           <p:cNvPr id="5" name="Text Placeholder 4">
             <a:extLst>
               <a:ext uri="{FF2B5EF4-FFF2-40B4-BE49-F238E27FC236}">
-                <a16:creationId xmlns:a16="http://schemas.microsoft.com/office/drawing/2014/main" id="{812EDE87-BF6D-68A4-5F06-770AE152FB82}"/>
+                <a16:creationId xmlns:a16="http://schemas.microsoft.com/office/drawing/2014/main" id="{993AA694-78C7-FC99-D3EC-1C105C004816}"/>
               </a:ext>
             </a:extLst>
           </p:cNvPr>
@@ -1749,7 +1749,7 @@
           <p:cNvPr id="6" name="Content Placeholder 5">
             <a:extLst>
               <a:ext uri="{FF2B5EF4-FFF2-40B4-BE49-F238E27FC236}">
-                <a16:creationId xmlns:a16="http://schemas.microsoft.com/office/drawing/2014/main" id="{9524B3A8-952B-1886-C5FA-F9AB6140FAD3}"/>
+                <a16:creationId xmlns:a16="http://schemas.microsoft.com/office/drawing/2014/main" id="{87728749-4358-9D34-44AE-3BAE7674D176}"/>
               </a:ext>
             </a:extLst>
           </p:cNvPr>
@@ -1812,7 +1812,7 @@
           <p:cNvPr id="7" name="Date Placeholder 6">
             <a:extLst>
               <a:ext uri="{FF2B5EF4-FFF2-40B4-BE49-F238E27FC236}">
-                <a16:creationId xmlns:a16="http://schemas.microsoft.com/office/drawing/2014/main" id="{C7667394-BA1F-56A5-1D4C-F304D40E1753}"/>
+                <a16:creationId xmlns:a16="http://schemas.microsoft.com/office/drawing/2014/main" id="{A8F51246-92D8-F2CA-7402-6E1A286C063A}"/>
               </a:ext>
             </a:extLst>
           </p:cNvPr>
@@ -1828,7 +1828,7 @@
           <a:bodyPr/>
           <a:lstStyle/>
           <a:p>
-            <a:fld id="{99BF043A-CA38-4ED0-BB8D-C66D150D6DA3}" type="datetimeFigureOut">
+            <a:fld id="{13335322-04FB-414F-B5C5-B62F9051266D}" type="datetimeFigureOut">
               <a:rPr lang="en-IN" smtClean="0"/>
               <a:t>24-09-2026</a:t>
             </a:fld>
@@ -1841,7 +1841,7 @@
           <p:cNvPr id="8" name="Footer Placeholder 7">
             <a:extLst>
               <a:ext uri="{FF2B5EF4-FFF2-40B4-BE49-F238E27FC236}">
-                <a16:creationId xmlns:a16="http://schemas.microsoft.com/office/drawing/2014/main" id="{DD3E2866-C6FF-FFFD-F707-26C8FF6925B3}"/>
+                <a16:creationId xmlns:a16="http://schemas.microsoft.com/office/drawing/2014/main" id="{3D5FC62B-F68C-9F58-1526-D651269DE456}"/>
               </a:ext>
             </a:extLst>
           </p:cNvPr>
@@ -1866,7 +1866,7 @@
           <p:cNvPr id="9" name="Slide Number Placeholder 8">
             <a:extLst>
               <a:ext uri="{FF2B5EF4-FFF2-40B4-BE49-F238E27FC236}">
-                <a16:creationId xmlns:a16="http://schemas.microsoft.com/office/drawing/2014/main" id="{5B2388D8-8312-BE1F-297E-CCF535CE000E}"/>
+                <a16:creationId xmlns:a16="http://schemas.microsoft.com/office/drawing/2014/main" id="{E6841CBD-6030-ED14-B43E-13BCA9F7B0FC}"/>
               </a:ext>
             </a:extLst>
           </p:cNvPr>
@@ -1882,7 +1882,7 @@
           <a:bodyPr/>
           <a:lstStyle/>
           <a:p>
-            <a:fld id="{47B02238-B2B4-4440-85F4-07CF07CD763B}" type="slidenum">
+            <a:fld id="{33254770-DAD8-4BD1-9C12-9EA3D5037C3F}" type="slidenum">
               <a:rPr lang="en-IN" smtClean="0"/>
               <a:t>‹#›</a:t>
             </a:fld>
@@ -1893,7 +1893,7 @@
     </p:spTree>
     <p:extLst>
       <p:ext uri="{BB962C8B-B14F-4D97-AF65-F5344CB8AC3E}">
-        <p14:creationId xmlns:p14="http://schemas.microsoft.com/office/powerpoint/2010/main" val="636952216"/>
+        <p14:creationId xmlns:p14="http://schemas.microsoft.com/office/powerpoint/2010/main" val="1878434239"/>
       </p:ext>
     </p:extLst>
   </p:cSld>
@@ -1925,7 +1925,7 @@
           <p:cNvPr id="2" name="Title 1">
             <a:extLst>
               <a:ext uri="{FF2B5EF4-FFF2-40B4-BE49-F238E27FC236}">
-                <a16:creationId xmlns:a16="http://schemas.microsoft.com/office/drawing/2014/main" id="{7531375A-4BF4-1F91-8AFA-0358CD8716AD}"/>
+                <a16:creationId xmlns:a16="http://schemas.microsoft.com/office/drawing/2014/main" id="{D369C6F3-13C6-AAD9-50FF-897F254D48CF}"/>
               </a:ext>
             </a:extLst>
           </p:cNvPr>
@@ -1954,7 +1954,7 @@
           <p:cNvPr id="3" name="Date Placeholder 2">
             <a:extLst>
               <a:ext uri="{FF2B5EF4-FFF2-40B4-BE49-F238E27FC236}">
-                <a16:creationId xmlns:a16="http://schemas.microsoft.com/office/drawing/2014/main" id="{9B240130-3502-ACAB-17C5-021789145E96}"/>
+                <a16:creationId xmlns:a16="http://schemas.microsoft.com/office/drawing/2014/main" id="{1CB15934-08CC-666A-3976-599A65ED0F4A}"/>
               </a:ext>
             </a:extLst>
           </p:cNvPr>
@@ -1970,7 +1970,7 @@
           <a:bodyPr/>
           <a:lstStyle/>
           <a:p>
-            <a:fld id="{99BF043A-CA38-4ED0-BB8D-C66D150D6DA3}" type="datetimeFigureOut">
+            <a:fld id="{13335322-04FB-414F-B5C5-B62F9051266D}" type="datetimeFigureOut">
               <a:rPr lang="en-IN" smtClean="0"/>
               <a:t>24-09-2026</a:t>
             </a:fld>
@@ -1983,7 +1983,7 @@
           <p:cNvPr id="4" name="Footer Placeholder 3">
             <a:extLst>
               <a:ext uri="{FF2B5EF4-FFF2-40B4-BE49-F238E27FC236}">
-                <a16:creationId xmlns:a16="http://schemas.microsoft.com/office/drawing/2014/main" id="{6C5E5D87-89E1-28BF-7ED1-B6E0F46A598D}"/>
+                <a16:creationId xmlns:a16="http://schemas.microsoft.com/office/drawing/2014/main" id="{EF5CE7E0-7EDB-2E04-76DC-E4E32A7C1236}"/>
               </a:ext>
             </a:extLst>
           </p:cNvPr>
@@ -2008,7 +2008,7 @@
           <p:cNvPr id="5" name="Slide Number Placeholder 4">
             <a:extLst>
               <a:ext uri="{FF2B5EF4-FFF2-40B4-BE49-F238E27FC236}">
-                <a16:creationId xmlns:a16="http://schemas.microsoft.com/office/drawing/2014/main" id="{9CCBC77F-D1F7-2002-A52D-D28F07E23D0D}"/>
+                <a16:creationId xmlns:a16="http://schemas.microsoft.com/office/drawing/2014/main" id="{D5E2718E-D4A7-28B6-BEED-D77C6220ADF5}"/>
               </a:ext>
             </a:extLst>
           </p:cNvPr>
@@ -2024,7 +2024,7 @@
           <a:bodyPr/>
           <a:lstStyle/>
           <a:p>
-            <a:fld id="{47B02238-B2B4-4440-85F4-07CF07CD763B}" type="slidenum">
+            <a:fld id="{33254770-DAD8-4BD1-9C12-9EA3D5037C3F}" type="slidenum">
               <a:rPr lang="en-IN" smtClean="0"/>
               <a:t>‹#›</a:t>
             </a:fld>
@@ -2035,7 +2035,7 @@
     </p:spTree>
     <p:extLst>
       <p:ext uri="{BB962C8B-B14F-4D97-AF65-F5344CB8AC3E}">
-        <p14:creationId xmlns:p14="http://schemas.microsoft.com/office/powerpoint/2010/main" val="1359554190"/>
+        <p14:creationId xmlns:p14="http://schemas.microsoft.com/office/powerpoint/2010/main" val="3911052764"/>
       </p:ext>
     </p:extLst>
   </p:cSld>
@@ -2067,7 +2067,7 @@
           <p:cNvPr id="2" name="Date Placeholder 1">
             <a:extLst>
               <a:ext uri="{FF2B5EF4-FFF2-40B4-BE49-F238E27FC236}">
-                <a16:creationId xmlns:a16="http://schemas.microsoft.com/office/drawing/2014/main" id="{C0B1DDBF-A931-8135-62AD-16DD1F393785}"/>
+                <a16:creationId xmlns:a16="http://schemas.microsoft.com/office/drawing/2014/main" id="{04ED16F7-26E1-07A4-7089-83117546B887}"/>
               </a:ext>
             </a:extLst>
           </p:cNvPr>
@@ -2083,7 +2083,7 @@
           <a:bodyPr/>
           <a:lstStyle/>
           <a:p>
-            <a:fld id="{99BF043A-CA38-4ED0-BB8D-C66D150D6DA3}" type="datetimeFigureOut">
+            <a:fld id="{13335322-04FB-414F-B5C5-B62F9051266D}" type="datetimeFigureOut">
               <a:rPr lang="en-IN" smtClean="0"/>
               <a:t>24-09-2026</a:t>
             </a:fld>
@@ -2096,7 +2096,7 @@
           <p:cNvPr id="3" name="Footer Placeholder 2">
             <a:extLst>
               <a:ext uri="{FF2B5EF4-FFF2-40B4-BE49-F238E27FC236}">
-                <a16:creationId xmlns:a16="http://schemas.microsoft.com/office/drawing/2014/main" id="{350D38A7-9E46-A494-CFB3-DEE0DD0439DB}"/>
+                <a16:creationId xmlns:a16="http://schemas.microsoft.com/office/drawing/2014/main" id="{8668252D-66F8-2DE4-9F16-E87BBBC99D4D}"/>
               </a:ext>
             </a:extLst>
           </p:cNvPr>
@@ -2121,7 +2121,7 @@
           <p:cNvPr id="4" name="Slide Number Placeholder 3">
             <a:extLst>
               <a:ext uri="{FF2B5EF4-FFF2-40B4-BE49-F238E27FC236}">
-                <a16:creationId xmlns:a16="http://schemas.microsoft.com/office/drawing/2014/main" id="{07A7ED10-2995-38BA-03E8-76C605505965}"/>
+                <a16:creationId xmlns:a16="http://schemas.microsoft.com/office/drawing/2014/main" id="{43B9DDA5-60F2-FB63-04EC-DEB1E5CBE005}"/>
               </a:ext>
             </a:extLst>
           </p:cNvPr>
@@ -2137,7 +2137,7 @@
           <a:bodyPr/>
           <a:lstStyle/>
           <a:p>
-            <a:fld id="{47B02238-B2B4-4440-85F4-07CF07CD763B}" type="slidenum">
+            <a:fld id="{33254770-DAD8-4BD1-9C12-9EA3D5037C3F}" type="slidenum">
               <a:rPr lang="en-IN" smtClean="0"/>
               <a:t>‹#›</a:t>
             </a:fld>
@@ -2148,7 +2148,7 @@
     </p:spTree>
     <p:extLst>
       <p:ext uri="{BB962C8B-B14F-4D97-AF65-F5344CB8AC3E}">
-        <p14:creationId xmlns:p14="http://schemas.microsoft.com/office/powerpoint/2010/main" val="701430202"/>
+        <p14:creationId xmlns:p14="http://schemas.microsoft.com/office/powerpoint/2010/main" val="1976473133"/>
       </p:ext>
     </p:extLst>
   </p:cSld>
@@ -2180,7 +2180,7 @@
           <p:cNvPr id="2" name="Title 1">
             <a:extLst>
               <a:ext uri="{FF2B5EF4-FFF2-40B4-BE49-F238E27FC236}">
-                <a16:creationId xmlns:a16="http://schemas.microsoft.com/office/drawing/2014/main" id="{02BBF3ED-CEAC-59A7-1512-09E1D213FCC7}"/>
+                <a16:creationId xmlns:a16="http://schemas.microsoft.com/office/drawing/2014/main" id="{43E9B15E-602A-0C0D-2C39-254F0CD714E7}"/>
               </a:ext>
             </a:extLst>
           </p:cNvPr>
@@ -2218,7 +2218,7 @@
           <p:cNvPr id="3" name="Content Placeholder 2">
             <a:extLst>
               <a:ext uri="{FF2B5EF4-FFF2-40B4-BE49-F238E27FC236}">
-                <a16:creationId xmlns:a16="http://schemas.microsoft.com/office/drawing/2014/main" id="{4385FE4D-640E-C91F-822F-570EF977DE49}"/>
+                <a16:creationId xmlns:a16="http://schemas.microsoft.com/office/drawing/2014/main" id="{A4471044-A5F2-5A53-FF2C-505218BCB343}"/>
               </a:ext>
             </a:extLst>
           </p:cNvPr>
@@ -2309,7 +2309,7 @@
           <p:cNvPr id="4" name="Text Placeholder 3">
             <a:extLst>
               <a:ext uri="{FF2B5EF4-FFF2-40B4-BE49-F238E27FC236}">
-                <a16:creationId xmlns:a16="http://schemas.microsoft.com/office/drawing/2014/main" id="{B1FB5DF3-46C2-B45B-1672-C4FCAA7D7471}"/>
+                <a16:creationId xmlns:a16="http://schemas.microsoft.com/office/drawing/2014/main" id="{7EBA24A1-271A-FF71-FAE4-9936678D78A1}"/>
               </a:ext>
             </a:extLst>
           </p:cNvPr>
@@ -2380,7 +2380,7 @@
           <p:cNvPr id="5" name="Date Placeholder 4">
             <a:extLst>
               <a:ext uri="{FF2B5EF4-FFF2-40B4-BE49-F238E27FC236}">
-                <a16:creationId xmlns:a16="http://schemas.microsoft.com/office/drawing/2014/main" id="{82B3CCF5-B7C7-6F23-4050-50E3E8AB6D13}"/>
+                <a16:creationId xmlns:a16="http://schemas.microsoft.com/office/drawing/2014/main" id="{5EA04CA3-6C30-FA14-14DF-0CF3E947794D}"/>
               </a:ext>
             </a:extLst>
           </p:cNvPr>
@@ -2396,7 +2396,7 @@
           <a:bodyPr/>
           <a:lstStyle/>
           <a:p>
-            <a:fld id="{99BF043A-CA38-4ED0-BB8D-C66D150D6DA3}" type="datetimeFigureOut">
+            <a:fld id="{13335322-04FB-414F-B5C5-B62F9051266D}" type="datetimeFigureOut">
               <a:rPr lang="en-IN" smtClean="0"/>
               <a:t>24-09-2026</a:t>
             </a:fld>
@@ -2409,7 +2409,7 @@
           <p:cNvPr id="6" name="Footer Placeholder 5">
             <a:extLst>
               <a:ext uri="{FF2B5EF4-FFF2-40B4-BE49-F238E27FC236}">
-                <a16:creationId xmlns:a16="http://schemas.microsoft.com/office/drawing/2014/main" id="{A302236F-7B3B-D308-2FE2-F0BF089E48C6}"/>
+                <a16:creationId xmlns:a16="http://schemas.microsoft.com/office/drawing/2014/main" id="{9ADC8206-9410-0175-BEBD-20C234526FC5}"/>
               </a:ext>
             </a:extLst>
           </p:cNvPr>
@@ -2434,7 +2434,7 @@
           <p:cNvPr id="7" name="Slide Number Placeholder 6">
             <a:extLst>
               <a:ext uri="{FF2B5EF4-FFF2-40B4-BE49-F238E27FC236}">
-                <a16:creationId xmlns:a16="http://schemas.microsoft.com/office/drawing/2014/main" id="{5AD16E13-4E42-E96D-9192-77C537CDC061}"/>
+                <a16:creationId xmlns:a16="http://schemas.microsoft.com/office/drawing/2014/main" id="{EE711C8F-A55D-6796-F59C-509B01D6982D}"/>
               </a:ext>
             </a:extLst>
           </p:cNvPr>
@@ -2450,7 +2450,7 @@
           <a:bodyPr/>
           <a:lstStyle/>
           <a:p>
-            <a:fld id="{47B02238-B2B4-4440-85F4-07CF07CD763B}" type="slidenum">
+            <a:fld id="{33254770-DAD8-4BD1-9C12-9EA3D5037C3F}" type="slidenum">
               <a:rPr lang="en-IN" smtClean="0"/>
               <a:t>‹#›</a:t>
             </a:fld>
@@ -2461,7 +2461,7 @@
     </p:spTree>
     <p:extLst>
       <p:ext uri="{BB962C8B-B14F-4D97-AF65-F5344CB8AC3E}">
-        <p14:creationId xmlns:p14="http://schemas.microsoft.com/office/powerpoint/2010/main" val="2571879492"/>
+        <p14:creationId xmlns:p14="http://schemas.microsoft.com/office/powerpoint/2010/main" val="3098091149"/>
       </p:ext>
     </p:extLst>
   </p:cSld>
@@ -2493,7 +2493,7 @@
           <p:cNvPr id="2" name="Title 1">
             <a:extLst>
               <a:ext uri="{FF2B5EF4-FFF2-40B4-BE49-F238E27FC236}">
-                <a16:creationId xmlns:a16="http://schemas.microsoft.com/office/drawing/2014/main" id="{91C2966D-4CA1-A894-50C5-064738EDBCAA}"/>
+                <a16:creationId xmlns:a16="http://schemas.microsoft.com/office/drawing/2014/main" id="{4FF80452-9170-DF22-8F51-E00DE98D8F51}"/>
               </a:ext>
             </a:extLst>
           </p:cNvPr>
@@ -2531,7 +2531,7 @@
           <p:cNvPr id="3" name="Picture Placeholder 2">
             <a:extLst>
               <a:ext uri="{FF2B5EF4-FFF2-40B4-BE49-F238E27FC236}">
-                <a16:creationId xmlns:a16="http://schemas.microsoft.com/office/drawing/2014/main" id="{F314ADB9-9B4E-0AE2-924C-5FAC589AEB84}"/>
+                <a16:creationId xmlns:a16="http://schemas.microsoft.com/office/drawing/2014/main" id="{CC09ED3F-FE10-037A-4D35-E518523D902F}"/>
               </a:ext>
             </a:extLst>
           </p:cNvPr>
@@ -2598,7 +2598,7 @@
           <p:cNvPr id="4" name="Text Placeholder 3">
             <a:extLst>
               <a:ext uri="{FF2B5EF4-FFF2-40B4-BE49-F238E27FC236}">
-                <a16:creationId xmlns:a16="http://schemas.microsoft.com/office/drawing/2014/main" id="{A9EC2183-C5EA-7699-A0BB-E0744DD88D9C}"/>
+                <a16:creationId xmlns:a16="http://schemas.microsoft.com/office/drawing/2014/main" id="{F91D22EA-EAFB-571A-323E-83C1CD763C3B}"/>
               </a:ext>
             </a:extLst>
           </p:cNvPr>
@@ -2669,7 +2669,7 @@
           <p:cNvPr id="5" name="Date Placeholder 4">
             <a:extLst>
               <a:ext uri="{FF2B5EF4-FFF2-40B4-BE49-F238E27FC236}">
-                <a16:creationId xmlns:a16="http://schemas.microsoft.com/office/drawing/2014/main" id="{45D0983E-F245-EA24-8B38-631ECBD401B4}"/>
+                <a16:creationId xmlns:a16="http://schemas.microsoft.com/office/drawing/2014/main" id="{813362CB-4034-6A96-5244-AB327D5173D5}"/>
               </a:ext>
             </a:extLst>
           </p:cNvPr>
@@ -2685,7 +2685,7 @@
           <a:bodyPr/>
           <a:lstStyle/>
           <a:p>
-            <a:fld id="{99BF043A-CA38-4ED0-BB8D-C66D150D6DA3}" type="datetimeFigureOut">
+            <a:fld id="{13335322-04FB-414F-B5C5-B62F9051266D}" type="datetimeFigureOut">
               <a:rPr lang="en-IN" smtClean="0"/>
               <a:t>24-09-2026</a:t>
             </a:fld>
@@ -2698,7 +2698,7 @@
           <p:cNvPr id="6" name="Footer Placeholder 5">
             <a:extLst>
               <a:ext uri="{FF2B5EF4-FFF2-40B4-BE49-F238E27FC236}">
-                <a16:creationId xmlns:a16="http://schemas.microsoft.com/office/drawing/2014/main" id="{8F6B9815-8DAC-CA30-EE67-7010923449C6}"/>
+                <a16:creationId xmlns:a16="http://schemas.microsoft.com/office/drawing/2014/main" id="{5362DC5F-5C7C-FFA1-B154-B6A7EBA0CBA8}"/>
               </a:ext>
             </a:extLst>
           </p:cNvPr>
@@ -2723,7 +2723,7 @@
           <p:cNvPr id="7" name="Slide Number Placeholder 6">
             <a:extLst>
               <a:ext uri="{FF2B5EF4-FFF2-40B4-BE49-F238E27FC236}">
-                <a16:creationId xmlns:a16="http://schemas.microsoft.com/office/drawing/2014/main" id="{F20173D7-00DE-8C97-1ED2-6E699B5ACFA9}"/>
+                <a16:creationId xmlns:a16="http://schemas.microsoft.com/office/drawing/2014/main" id="{C657920C-7174-9C77-DE69-A5C4C1A9FB34}"/>
               </a:ext>
             </a:extLst>
           </p:cNvPr>
@@ -2739,7 +2739,7 @@
           <a:bodyPr/>
           <a:lstStyle/>
           <a:p>
-            <a:fld id="{47B02238-B2B4-4440-85F4-07CF07CD763B}" type="slidenum">
+            <a:fld id="{33254770-DAD8-4BD1-9C12-9EA3D5037C3F}" type="slidenum">
               <a:rPr lang="en-IN" smtClean="0"/>
               <a:t>‹#›</a:t>
             </a:fld>
@@ -2750,7 +2750,7 @@
     </p:spTree>
     <p:extLst>
       <p:ext uri="{BB962C8B-B14F-4D97-AF65-F5344CB8AC3E}">
-        <p14:creationId xmlns:p14="http://schemas.microsoft.com/office/powerpoint/2010/main" val="840590876"/>
+        <p14:creationId xmlns:p14="http://schemas.microsoft.com/office/powerpoint/2010/main" val="419654450"/>
       </p:ext>
     </p:extLst>
   </p:cSld>
@@ -2787,7 +2787,7 @@
           <p:cNvPr id="2" name="Title Placeholder 1">
             <a:extLst>
               <a:ext uri="{FF2B5EF4-FFF2-40B4-BE49-F238E27FC236}">
-                <a16:creationId xmlns:a16="http://schemas.microsoft.com/office/drawing/2014/main" id="{59D43CF3-A499-B7F2-F983-02022957A5D2}"/>
+                <a16:creationId xmlns:a16="http://schemas.microsoft.com/office/drawing/2014/main" id="{8AB5FBA0-DEBC-80D5-061A-8DC59561C28C}"/>
               </a:ext>
             </a:extLst>
           </p:cNvPr>
@@ -2826,7 +2826,7 @@
           <p:cNvPr id="3" name="Text Placeholder 2">
             <a:extLst>
               <a:ext uri="{FF2B5EF4-FFF2-40B4-BE49-F238E27FC236}">
-                <a16:creationId xmlns:a16="http://schemas.microsoft.com/office/drawing/2014/main" id="{F263982E-C503-5835-8D9D-12FC03F925C5}"/>
+                <a16:creationId xmlns:a16="http://schemas.microsoft.com/office/drawing/2014/main" id="{C752527C-1F68-49B0-A07F-D0B906619384}"/>
               </a:ext>
             </a:extLst>
           </p:cNvPr>
@@ -2894,7 +2894,7 @@
           <p:cNvPr id="4" name="Date Placeholder 3">
             <a:extLst>
               <a:ext uri="{FF2B5EF4-FFF2-40B4-BE49-F238E27FC236}">
-                <a16:creationId xmlns:a16="http://schemas.microsoft.com/office/drawing/2014/main" id="{637C7A4A-33CD-17D9-36A0-074087B064CC}"/>
+                <a16:creationId xmlns:a16="http://schemas.microsoft.com/office/drawing/2014/main" id="{838CF8BC-23C0-42AC-C21A-29E1705D0C1F}"/>
               </a:ext>
             </a:extLst>
           </p:cNvPr>
@@ -2928,7 +2928,7 @@
             </a:lvl1pPr>
           </a:lstStyle>
           <a:p>
-            <a:fld id="{99BF043A-CA38-4ED0-BB8D-C66D150D6DA3}" type="datetimeFigureOut">
+            <a:fld id="{13335322-04FB-414F-B5C5-B62F9051266D}" type="datetimeFigureOut">
               <a:rPr lang="en-IN" smtClean="0"/>
               <a:t>24-09-2026</a:t>
             </a:fld>
@@ -2941,7 +2941,7 @@
           <p:cNvPr id="5" name="Footer Placeholder 4">
             <a:extLst>
               <a:ext uri="{FF2B5EF4-FFF2-40B4-BE49-F238E27FC236}">
-                <a16:creationId xmlns:a16="http://schemas.microsoft.com/office/drawing/2014/main" id="{0BC69A1D-9335-84BF-E64D-C66EC70264D6}"/>
+                <a16:creationId xmlns:a16="http://schemas.microsoft.com/office/drawing/2014/main" id="{E1F37BFB-EA66-E6B6-88C6-DB60465961B1}"/>
               </a:ext>
             </a:extLst>
           </p:cNvPr>
@@ -2984,7 +2984,7 @@
           <p:cNvPr id="6" name="Slide Number Placeholder 5">
             <a:extLst>
               <a:ext uri="{FF2B5EF4-FFF2-40B4-BE49-F238E27FC236}">
-                <a16:creationId xmlns:a16="http://schemas.microsoft.com/office/drawing/2014/main" id="{87DD7137-8D3F-5948-F5BD-000DB71EF693}"/>
+                <a16:creationId xmlns:a16="http://schemas.microsoft.com/office/drawing/2014/main" id="{4BB1881E-9C56-7E5A-7B7D-AA2EFB042EDA}"/>
               </a:ext>
             </a:extLst>
           </p:cNvPr>
@@ -3018,7 +3018,7 @@
             </a:lvl1pPr>
           </a:lstStyle>
           <a:p>
-            <a:fld id="{47B02238-B2B4-4440-85F4-07CF07CD763B}" type="slidenum">
+            <a:fld id="{33254770-DAD8-4BD1-9C12-9EA3D5037C3F}" type="slidenum">
               <a:rPr lang="en-IN" smtClean="0"/>
               <a:t>‹#›</a:t>
             </a:fld>
@@ -3029,7 +3029,7 @@
     </p:spTree>
     <p:extLst>
       <p:ext uri="{BB962C8B-B14F-4D97-AF65-F5344CB8AC3E}">
-        <p14:creationId xmlns:p14="http://schemas.microsoft.com/office/powerpoint/2010/main" val="1910482094"/>
+        <p14:creationId xmlns:p14="http://schemas.microsoft.com/office/powerpoint/2010/main" val="671996651"/>
       </p:ext>
     </p:extLst>
   </p:cSld>
@@ -3347,970 +3347,12 @@
           <a:chExt cx="0" cy="0"/>
         </a:xfrm>
       </p:grpSpPr>
-      <p:sp>
-        <p:nvSpPr>
-          <p:cNvPr id="2" name="Rectangle 1">
-            <a:extLst>
-              <a:ext uri="{FF2B5EF4-FFF2-40B4-BE49-F238E27FC236}">
-                <a16:creationId xmlns:a16="http://schemas.microsoft.com/office/drawing/2014/main" id="{EE1290B2-F520-B72C-8DB6-0F0B6B206D31}"/>
-              </a:ext>
-            </a:extLst>
-          </p:cNvPr>
-          <p:cNvSpPr/>
-          <p:nvPr/>
-        </p:nvSpPr>
-        <p:spPr>
-          <a:xfrm>
-            <a:off x="0" y="0"/>
-            <a:ext cx="12192000" cy="6858000"/>
-          </a:xfrm>
-          <a:prstGeom prst="rect">
-            <a:avLst/>
-          </a:prstGeom>
-          <a:solidFill>
-            <a:srgbClr val="F8FAFC"/>
-          </a:solidFill>
-          <a:ln w="12700" cap="flat" cmpd="sng" algn="ctr">
-            <a:noFill/>
-            <a:prstDash val="solid"/>
-            <a:miter lim="800000"/>
-          </a:ln>
-          <a:effectLst/>
-          <a:extLst>
-            <a:ext uri="{91240B29-F687-4F45-9708-019B960494DF}">
-              <a14:hiddenLine xmlns:a14="http://schemas.microsoft.com/office/drawing/2010/main" w="12700" cap="flat" cmpd="sng" algn="ctr">
-                <a:solidFill>
-                  <a:schemeClr val="accent1">
-                    <a:shade val="15000"/>
-                  </a:schemeClr>
-                </a:solidFill>
-                <a:prstDash val="solid"/>
-                <a:miter lim="800000"/>
-              </a14:hiddenLine>
-            </a:ext>
-          </a:extLst>
-        </p:spPr>
-        <p:style>
-          <a:lnRef idx="2">
-            <a:schemeClr val="accent1">
-              <a:shade val="15000"/>
-            </a:schemeClr>
-          </a:lnRef>
-          <a:fillRef idx="1">
-            <a:schemeClr val="accent1"/>
-          </a:fillRef>
-          <a:effectRef idx="0">
-            <a:schemeClr val="accent1"/>
-          </a:effectRef>
-          <a:fontRef idx="minor">
-            <a:schemeClr val="lt1"/>
-          </a:fontRef>
-        </p:style>
-        <p:txBody>
-          <a:bodyPr rtlCol="0" anchor="ctr"/>
-          <a:lstStyle/>
-          <a:p>
-            <a:pPr algn="ctr"/>
-            <a:endParaRPr lang="en-IN"/>
-          </a:p>
-        </p:txBody>
-      </p:sp>
-      <p:sp>
-        <p:nvSpPr>
-          <p:cNvPr id="3" name="Rectangle 2">
-            <a:extLst>
-              <a:ext uri="{FF2B5EF4-FFF2-40B4-BE49-F238E27FC236}">
-                <a16:creationId xmlns:a16="http://schemas.microsoft.com/office/drawing/2014/main" id="{65D1D049-6BDB-F355-9D92-7AA3ED1BBE59}"/>
-              </a:ext>
-            </a:extLst>
-          </p:cNvPr>
-          <p:cNvSpPr/>
-          <p:nvPr/>
-        </p:nvSpPr>
-        <p:spPr>
-          <a:xfrm>
-            <a:off x="0" y="0"/>
-            <a:ext cx="12192000" cy="609600"/>
-          </a:xfrm>
-          <a:prstGeom prst="rect">
-            <a:avLst/>
-          </a:prstGeom>
-          <a:solidFill>
-            <a:srgbClr val="FFFFFF"/>
-          </a:solidFill>
-          <a:ln w="12700">
-            <a:solidFill>
-              <a:srgbClr val="F0E8E2"/>
-            </a:solidFill>
-          </a:ln>
-        </p:spPr>
-        <p:style>
-          <a:lnRef idx="2">
-            <a:schemeClr val="accent1">
-              <a:shade val="15000"/>
-            </a:schemeClr>
-          </a:lnRef>
-          <a:fillRef idx="1">
-            <a:schemeClr val="accent1"/>
-          </a:fillRef>
-          <a:effectRef idx="0">
-            <a:schemeClr val="accent1"/>
-          </a:effectRef>
-          <a:fontRef idx="minor">
-            <a:schemeClr val="lt1"/>
-          </a:fontRef>
-        </p:style>
-        <p:txBody>
-          <a:bodyPr rtlCol="0" anchor="ctr"/>
-          <a:lstStyle/>
-          <a:p>
-            <a:pPr algn="ctr"/>
-            <a:endParaRPr lang="en-IN"/>
-          </a:p>
-        </p:txBody>
-      </p:sp>
-      <p:sp>
-        <p:nvSpPr>
-          <p:cNvPr id="4" name="Rectangle: Rounded Corners 3">
-            <a:extLst>
-              <a:ext uri="{FF2B5EF4-FFF2-40B4-BE49-F238E27FC236}">
-                <a16:creationId xmlns:a16="http://schemas.microsoft.com/office/drawing/2014/main" id="{1CFDF671-F595-562C-FDF5-B193496256D4}"/>
-              </a:ext>
-            </a:extLst>
-          </p:cNvPr>
-          <p:cNvSpPr/>
-          <p:nvPr/>
-        </p:nvSpPr>
-        <p:spPr>
-          <a:xfrm>
-            <a:off x="254000" y="114300"/>
-            <a:ext cx="1778000" cy="381000"/>
-          </a:xfrm>
-          <a:prstGeom prst="roundRect">
-            <a:avLst/>
-          </a:prstGeom>
-          <a:solidFill>
-            <a:srgbClr val="EA580C"/>
-          </a:solidFill>
-          <a:ln w="12700" cap="flat" cmpd="sng" algn="ctr">
-            <a:noFill/>
-            <a:prstDash val="solid"/>
-            <a:miter lim="800000"/>
-          </a:ln>
-          <a:effectLst/>
-          <a:extLst>
-            <a:ext uri="{91240B29-F687-4F45-9708-019B960494DF}">
-              <a14:hiddenLine xmlns:a14="http://schemas.microsoft.com/office/drawing/2010/main" w="12700" cap="flat" cmpd="sng" algn="ctr">
-                <a:solidFill>
-                  <a:schemeClr val="accent1">
-                    <a:shade val="15000"/>
-                  </a:schemeClr>
-                </a:solidFill>
-                <a:prstDash val="solid"/>
-                <a:miter lim="800000"/>
-              </a14:hiddenLine>
-            </a:ext>
-          </a:extLst>
-        </p:spPr>
-        <p:style>
-          <a:lnRef idx="2">
-            <a:schemeClr val="accent1">
-              <a:shade val="15000"/>
-            </a:schemeClr>
-          </a:lnRef>
-          <a:fillRef idx="1">
-            <a:schemeClr val="accent1"/>
-          </a:fillRef>
-          <a:effectRef idx="0">
-            <a:schemeClr val="accent1"/>
-          </a:effectRef>
-          <a:fontRef idx="minor">
-            <a:schemeClr val="lt1"/>
-          </a:fontRef>
-        </p:style>
-        <p:txBody>
-          <a:bodyPr rtlCol="0" anchor="ctr"/>
-          <a:lstStyle/>
-          <a:p>
-            <a:pPr algn="ctr"/>
-            <a:r>
-              <a:rPr lang="en-IN" sz="1150" b="1">
-                <a:solidFill>
-                  <a:srgbClr val="FFFFFF"/>
-                </a:solidFill>
-              </a:rPr>
-              <a:t>ALPHA-X | SIH_1186</a:t>
-            </a:r>
-          </a:p>
-        </p:txBody>
-      </p:sp>
-      <p:sp>
-        <p:nvSpPr>
-          <p:cNvPr id="5" name="TextBox 4">
-            <a:extLst>
-              <a:ext uri="{FF2B5EF4-FFF2-40B4-BE49-F238E27FC236}">
-                <a16:creationId xmlns:a16="http://schemas.microsoft.com/office/drawing/2014/main" id="{2CEFF5B6-F123-43AC-3233-E2D70949761F}"/>
-              </a:ext>
-            </a:extLst>
-          </p:cNvPr>
-          <p:cNvSpPr txBox="1"/>
-          <p:nvPr/>
-        </p:nvSpPr>
-        <p:spPr>
-          <a:xfrm>
-            <a:off x="2133600" y="101600"/>
-            <a:ext cx="6096000" cy="307777"/>
-          </a:xfrm>
-          <a:prstGeom prst="rect">
-            <a:avLst/>
-          </a:prstGeom>
-          <a:noFill/>
-        </p:spPr>
-        <p:txBody>
-          <a:bodyPr vert="horz" rtlCol="0">
-            <a:spAutoFit/>
-          </a:bodyPr>
-          <a:lstStyle/>
-          <a:p>
-            <a:r>
-              <a:rPr lang="en-IN" sz="1400" b="1">
-                <a:solidFill>
-                  <a:srgbClr val="0F172A"/>
-                </a:solidFill>
-              </a:rPr>
-              <a:t>SMART INDIA HACKATHON 2026</a:t>
-            </a:r>
-          </a:p>
-        </p:txBody>
-      </p:sp>
-      <p:sp>
-        <p:nvSpPr>
-          <p:cNvPr id="6" name="Rectangle: Rounded Corners 5">
-            <a:extLst>
-              <a:ext uri="{FF2B5EF4-FFF2-40B4-BE49-F238E27FC236}">
-                <a16:creationId xmlns:a16="http://schemas.microsoft.com/office/drawing/2014/main" id="{7DF56C91-1638-489F-C122-F3037E5619C8}"/>
-              </a:ext>
-            </a:extLst>
-          </p:cNvPr>
-          <p:cNvSpPr/>
-          <p:nvPr/>
-        </p:nvSpPr>
-        <p:spPr>
-          <a:xfrm>
-            <a:off x="8318500" y="114300"/>
-            <a:ext cx="2667000" cy="381000"/>
-          </a:xfrm>
-          <a:prstGeom prst="roundRect">
-            <a:avLst/>
-          </a:prstGeom>
-          <a:solidFill>
-            <a:srgbClr val="F0F9FF"/>
-          </a:solidFill>
-          <a:ln w="15240">
-            <a:solidFill>
-              <a:srgbClr val="0284C7"/>
-            </a:solidFill>
-          </a:ln>
-        </p:spPr>
-        <p:style>
-          <a:lnRef idx="2">
-            <a:schemeClr val="accent1">
-              <a:shade val="15000"/>
-            </a:schemeClr>
-          </a:lnRef>
-          <a:fillRef idx="1">
-            <a:schemeClr val="accent1"/>
-          </a:fillRef>
-          <a:effectRef idx="0">
-            <a:schemeClr val="accent1"/>
-          </a:effectRef>
-          <a:fontRef idx="minor">
-            <a:schemeClr val="lt1"/>
-          </a:fontRef>
-        </p:style>
-        <p:txBody>
-          <a:bodyPr rtlCol="0" anchor="ctr"/>
-          <a:lstStyle/>
-          <a:p>
-            <a:pPr algn="ctr"/>
-            <a:r>
-              <a:rPr lang="en-IN" sz="1000" b="1">
-                <a:solidFill>
-                  <a:srgbClr val="0284C7"/>
-                </a:solidFill>
-              </a:rPr>
-              <a:t>PS ID: SIH26223 | HARDWARE</a:t>
-            </a:r>
-          </a:p>
-        </p:txBody>
-      </p:sp>
-      <p:sp>
-        <p:nvSpPr>
-          <p:cNvPr id="7" name="Rectangle: Rounded Corners 6">
-            <a:extLst>
-              <a:ext uri="{FF2B5EF4-FFF2-40B4-BE49-F238E27FC236}">
-                <a16:creationId xmlns:a16="http://schemas.microsoft.com/office/drawing/2014/main" id="{E9C9D714-EEAD-89F6-771A-5142AB5F39B5}"/>
-              </a:ext>
-            </a:extLst>
-          </p:cNvPr>
-          <p:cNvSpPr/>
-          <p:nvPr/>
-        </p:nvSpPr>
-        <p:spPr>
-          <a:xfrm>
-            <a:off x="11112500" y="88900"/>
-            <a:ext cx="825500" cy="431800"/>
-          </a:xfrm>
-          <a:prstGeom prst="roundRect">
-            <a:avLst/>
-          </a:prstGeom>
-          <a:solidFill>
-            <a:srgbClr val="FFFBEB"/>
-          </a:solidFill>
-          <a:ln w="19050">
-            <a:solidFill>
-              <a:srgbClr val="D97706"/>
-            </a:solidFill>
-          </a:ln>
-        </p:spPr>
-        <p:style>
-          <a:lnRef idx="2">
-            <a:schemeClr val="accent1">
-              <a:shade val="15000"/>
-            </a:schemeClr>
-          </a:lnRef>
-          <a:fillRef idx="1">
-            <a:schemeClr val="accent1"/>
-          </a:fillRef>
-          <a:effectRef idx="0">
-            <a:schemeClr val="accent1"/>
-          </a:effectRef>
-          <a:fontRef idx="minor">
-            <a:schemeClr val="lt1"/>
-          </a:fontRef>
-        </p:style>
-        <p:txBody>
-          <a:bodyPr rtlCol="0" anchor="ctr"/>
-          <a:lstStyle/>
-          <a:p>
-            <a:pPr algn="ctr"/>
-            <a:r>
-              <a:rPr lang="en-IN" sz="800" b="1">
-                <a:solidFill>
-                  <a:srgbClr val="D97706"/>
-                </a:solidFill>
-              </a:rPr>
-              <a:t>[SIH LOGO]</a:t>
-            </a:r>
-          </a:p>
-        </p:txBody>
-      </p:sp>
-      <p:sp>
-        <p:nvSpPr>
-          <p:cNvPr id="8" name="Rectangle: Rounded Corners 7">
-            <a:extLst>
-              <a:ext uri="{FF2B5EF4-FFF2-40B4-BE49-F238E27FC236}">
-                <a16:creationId xmlns:a16="http://schemas.microsoft.com/office/drawing/2014/main" id="{51B9A10B-086F-FBEC-D410-1FAD45E41042}"/>
-              </a:ext>
-            </a:extLst>
-          </p:cNvPr>
-          <p:cNvSpPr/>
-          <p:nvPr/>
-        </p:nvSpPr>
-        <p:spPr>
-          <a:xfrm>
-            <a:off x="254000" y="762000"/>
-            <a:ext cx="6096000" cy="5270500"/>
-          </a:xfrm>
-          <a:prstGeom prst="roundRect">
-            <a:avLst/>
-          </a:prstGeom>
-          <a:solidFill>
-            <a:srgbClr val="FFFFFF"/>
-          </a:solidFill>
-          <a:ln w="19050">
-            <a:solidFill>
-              <a:srgbClr val="F0E8E2"/>
-            </a:solidFill>
-          </a:ln>
-        </p:spPr>
-        <p:style>
-          <a:lnRef idx="2">
-            <a:schemeClr val="accent1">
-              <a:shade val="15000"/>
-            </a:schemeClr>
-          </a:lnRef>
-          <a:fillRef idx="1">
-            <a:schemeClr val="accent1"/>
-          </a:fillRef>
-          <a:effectRef idx="0">
-            <a:schemeClr val="accent1"/>
-          </a:effectRef>
-          <a:fontRef idx="minor">
-            <a:schemeClr val="lt1"/>
-          </a:fontRef>
-        </p:style>
-        <p:txBody>
-          <a:bodyPr rtlCol="0" anchor="ctr"/>
-          <a:lstStyle/>
-          <a:p>
-            <a:pPr algn="ctr"/>
-            <a:endParaRPr lang="en-IN"/>
-          </a:p>
-        </p:txBody>
-      </p:sp>
-      <p:sp>
-        <p:nvSpPr>
-          <p:cNvPr id="9" name="Rectangle: Rounded Corners 8">
-            <a:extLst>
-              <a:ext uri="{FF2B5EF4-FFF2-40B4-BE49-F238E27FC236}">
-                <a16:creationId xmlns:a16="http://schemas.microsoft.com/office/drawing/2014/main" id="{64D4115A-086A-DBA0-5158-02A0A0213B5D}"/>
-              </a:ext>
-            </a:extLst>
-          </p:cNvPr>
-          <p:cNvSpPr/>
-          <p:nvPr/>
-        </p:nvSpPr>
-        <p:spPr>
-          <a:xfrm>
-            <a:off x="457200" y="939800"/>
-            <a:ext cx="3302000" cy="304800"/>
-          </a:xfrm>
-          <a:prstGeom prst="roundRect">
-            <a:avLst/>
-          </a:prstGeom>
-          <a:solidFill>
-            <a:srgbClr val="F0F9FF"/>
-          </a:solidFill>
-          <a:ln w="12700">
-            <a:solidFill>
-              <a:srgbClr val="0284C7"/>
-            </a:solidFill>
-          </a:ln>
-        </p:spPr>
-        <p:style>
-          <a:lnRef idx="2">
-            <a:schemeClr val="accent1">
-              <a:shade val="15000"/>
-            </a:schemeClr>
-          </a:lnRef>
-          <a:fillRef idx="1">
-            <a:schemeClr val="accent1"/>
-          </a:fillRef>
-          <a:effectRef idx="0">
-            <a:schemeClr val="accent1"/>
-          </a:effectRef>
-          <a:fontRef idx="minor">
-            <a:schemeClr val="lt1"/>
-          </a:fontRef>
-        </p:style>
-        <p:txBody>
-          <a:bodyPr rtlCol="0" anchor="ctr"/>
-          <a:lstStyle/>
-          <a:p>
-            <a:pPr algn="ctr"/>
-            <a:r>
-              <a:rPr lang="en-IN" sz="850" b="1">
-                <a:solidFill>
-                  <a:srgbClr val="0284C7"/>
-                </a:solidFill>
-              </a:rPr>
-              <a:t>AICTE STUDENT INNOVATION (DISASTER MGMT)</a:t>
-            </a:r>
-          </a:p>
-        </p:txBody>
-      </p:sp>
-      <p:sp>
-        <p:nvSpPr>
-          <p:cNvPr id="10" name="TextBox 9">
-            <a:extLst>
-              <a:ext uri="{FF2B5EF4-FFF2-40B4-BE49-F238E27FC236}">
-                <a16:creationId xmlns:a16="http://schemas.microsoft.com/office/drawing/2014/main" id="{BEF3DFDD-420C-3939-E50E-1FB639513BEC}"/>
-              </a:ext>
-            </a:extLst>
-          </p:cNvPr>
-          <p:cNvSpPr txBox="1"/>
-          <p:nvPr/>
-        </p:nvSpPr>
-        <p:spPr>
-          <a:xfrm>
-            <a:off x="406400" y="1295400"/>
-            <a:ext cx="5715000" cy="769441"/>
-          </a:xfrm>
-          <a:prstGeom prst="rect">
-            <a:avLst/>
-          </a:prstGeom>
-          <a:noFill/>
-        </p:spPr>
-        <p:txBody>
-          <a:bodyPr vert="horz" rtlCol="0">
-            <a:spAutoFit/>
-          </a:bodyPr>
-          <a:lstStyle/>
-          <a:p>
-            <a:r>
-              <a:rPr lang="en-IN" sz="4400" b="1">
-                <a:solidFill>
-                  <a:srgbClr val="EA580C"/>
-                </a:solidFill>
-              </a:rPr>
-              <a:t>ARIES 2.0</a:t>
-            </a:r>
-          </a:p>
-        </p:txBody>
-      </p:sp>
-      <p:sp>
-        <p:nvSpPr>
-          <p:cNvPr id="11" name="TextBox 10">
-            <a:extLst>
-              <a:ext uri="{FF2B5EF4-FFF2-40B4-BE49-F238E27FC236}">
-                <a16:creationId xmlns:a16="http://schemas.microsoft.com/office/drawing/2014/main" id="{BEC4E962-AD44-2ACD-52A1-1544467F5A1D}"/>
-              </a:ext>
-            </a:extLst>
-          </p:cNvPr>
-          <p:cNvSpPr txBox="1"/>
-          <p:nvPr/>
-        </p:nvSpPr>
-        <p:spPr>
-          <a:xfrm>
-            <a:off x="431800" y="1955800"/>
-            <a:ext cx="5715000" cy="300082"/>
-          </a:xfrm>
-          <a:prstGeom prst="rect">
-            <a:avLst/>
-          </a:prstGeom>
-          <a:noFill/>
-        </p:spPr>
-        <p:txBody>
-          <a:bodyPr vert="horz" rtlCol="0">
-            <a:spAutoFit/>
-          </a:bodyPr>
-          <a:lstStyle/>
-          <a:p>
-            <a:r>
-              <a:rPr lang="en-US" sz="1350" b="1">
-                <a:solidFill>
-                  <a:srgbClr val="0F172A"/>
-                </a:solidFill>
-              </a:rPr>
-              <a:t>Tri-Phibian All-Domain Autonomous Search-and-Rescue Robot</a:t>
-            </a:r>
-            <a:endParaRPr lang="en-IN" sz="1350" b="1">
-              <a:solidFill>
-                <a:srgbClr val="0F172A"/>
-              </a:solidFill>
-            </a:endParaRPr>
-          </a:p>
-        </p:txBody>
-      </p:sp>
-      <p:sp>
-        <p:nvSpPr>
-          <p:cNvPr id="12" name="Rectangle: Rounded Corners 11">
-            <a:extLst>
-              <a:ext uri="{FF2B5EF4-FFF2-40B4-BE49-F238E27FC236}">
-                <a16:creationId xmlns:a16="http://schemas.microsoft.com/office/drawing/2014/main" id="{33D2C4AD-7423-F167-F7E4-BB3B071C5BA6}"/>
-              </a:ext>
-            </a:extLst>
-          </p:cNvPr>
-          <p:cNvSpPr/>
-          <p:nvPr/>
-        </p:nvSpPr>
-        <p:spPr>
-          <a:xfrm>
-            <a:off x="457200" y="2489200"/>
-            <a:ext cx="2717800" cy="787400"/>
-          </a:xfrm>
-          <a:prstGeom prst="roundRect">
-            <a:avLst/>
-          </a:prstGeom>
-          <a:solidFill>
-            <a:srgbClr val="ECFDF5"/>
-          </a:solidFill>
-          <a:ln w="15240">
-            <a:solidFill>
-              <a:srgbClr val="059669"/>
-            </a:solidFill>
-          </a:ln>
-        </p:spPr>
-        <p:style>
-          <a:lnRef idx="2">
-            <a:schemeClr val="accent1">
-              <a:shade val="15000"/>
-            </a:schemeClr>
-          </a:lnRef>
-          <a:fillRef idx="1">
-            <a:schemeClr val="accent1"/>
-          </a:fillRef>
-          <a:effectRef idx="0">
-            <a:schemeClr val="accent1"/>
-          </a:effectRef>
-          <a:fontRef idx="minor">
-            <a:schemeClr val="lt1"/>
-          </a:fontRef>
-        </p:style>
-        <p:txBody>
-          <a:bodyPr rtlCol="0" anchor="ctr"/>
-          <a:lstStyle/>
-          <a:p>
-            <a:pPr algn="ctr"/>
-            <a:r>
-              <a:rPr lang="en-US" sz="1050" b="1">
-                <a:solidFill>
-                  <a:srgbClr val="059669"/>
-                </a:solidFill>
-              </a:rPr>
-              <a:t>🚜 Tank Treads</a:t>
-            </a:r>
-          </a:p>
-          <a:p>
-            <a:pPr algn="ctr"/>
-            <a:r>
-              <a:rPr lang="en-US" sz="800">
-                <a:solidFill>
-                  <a:srgbClr val="1E3347"/>
-                </a:solidFill>
-              </a:rPr>
-              <a:t>Climb 45° collapsed debris</a:t>
-            </a:r>
-            <a:endParaRPr lang="en-IN" sz="800">
-              <a:solidFill>
-                <a:srgbClr val="1E3347"/>
-              </a:solidFill>
-            </a:endParaRPr>
-          </a:p>
-        </p:txBody>
-      </p:sp>
-      <p:sp>
-        <p:nvSpPr>
-          <p:cNvPr id="13" name="Rectangle: Rounded Corners 12">
-            <a:extLst>
-              <a:ext uri="{FF2B5EF4-FFF2-40B4-BE49-F238E27FC236}">
-                <a16:creationId xmlns:a16="http://schemas.microsoft.com/office/drawing/2014/main" id="{2BAD8E52-B6E2-D87B-4A92-1904130A352D}"/>
-              </a:ext>
-            </a:extLst>
-          </p:cNvPr>
-          <p:cNvSpPr/>
-          <p:nvPr/>
-        </p:nvSpPr>
-        <p:spPr>
-          <a:xfrm>
-            <a:off x="3302000" y="2489200"/>
-            <a:ext cx="2717800" cy="787400"/>
-          </a:xfrm>
-          <a:prstGeom prst="roundRect">
-            <a:avLst/>
-          </a:prstGeom>
-          <a:solidFill>
-            <a:srgbClr val="F0F9FF"/>
-          </a:solidFill>
-          <a:ln w="15240">
-            <a:solidFill>
-              <a:srgbClr val="0284C7"/>
-            </a:solidFill>
-          </a:ln>
-        </p:spPr>
-        <p:style>
-          <a:lnRef idx="2">
-            <a:schemeClr val="accent1">
-              <a:shade val="15000"/>
-            </a:schemeClr>
-          </a:lnRef>
-          <a:fillRef idx="1">
-            <a:schemeClr val="accent1"/>
-          </a:fillRef>
-          <a:effectRef idx="0">
-            <a:schemeClr val="accent1"/>
-          </a:effectRef>
-          <a:fontRef idx="minor">
-            <a:schemeClr val="lt1"/>
-          </a:fontRef>
-        </p:style>
-        <p:txBody>
-          <a:bodyPr rtlCol="0" anchor="ctr"/>
-          <a:lstStyle/>
-          <a:p>
-            <a:pPr algn="ctr"/>
-            <a:r>
-              <a:rPr lang="en-US" sz="1050" b="1">
-                <a:solidFill>
-                  <a:srgbClr val="0284C7"/>
-                </a:solidFill>
-              </a:rPr>
-              <a:t>🚁 Octocopter Drone</a:t>
-            </a:r>
-          </a:p>
-          <a:p>
-            <a:pPr algn="ctr"/>
-            <a:r>
-              <a:rPr lang="en-US" sz="800">
-                <a:solidFill>
-                  <a:srgbClr val="1E3347"/>
-                </a:solidFill>
-              </a:rPr>
-              <a:t>8 rotors hop over deep trenches</a:t>
-            </a:r>
-            <a:endParaRPr lang="en-IN" sz="800">
-              <a:solidFill>
-                <a:srgbClr val="1E3347"/>
-              </a:solidFill>
-            </a:endParaRPr>
-          </a:p>
-        </p:txBody>
-      </p:sp>
-      <p:sp>
-        <p:nvSpPr>
-          <p:cNvPr id="14" name="Rectangle: Rounded Corners 13">
-            <a:extLst>
-              <a:ext uri="{FF2B5EF4-FFF2-40B4-BE49-F238E27FC236}">
-                <a16:creationId xmlns:a16="http://schemas.microsoft.com/office/drawing/2014/main" id="{784D9714-4809-3D00-30CD-C2E8843F2788}"/>
-              </a:ext>
-            </a:extLst>
-          </p:cNvPr>
-          <p:cNvSpPr/>
-          <p:nvPr/>
-        </p:nvSpPr>
-        <p:spPr>
-          <a:xfrm>
-            <a:off x="457200" y="3403600"/>
-            <a:ext cx="2717800" cy="787400"/>
-          </a:xfrm>
-          <a:prstGeom prst="roundRect">
-            <a:avLst/>
-          </a:prstGeom>
-          <a:solidFill>
-            <a:srgbClr val="F0FDFA"/>
-          </a:solidFill>
-          <a:ln w="15240">
-            <a:solidFill>
-              <a:srgbClr val="0D9488"/>
-            </a:solidFill>
-          </a:ln>
-        </p:spPr>
-        <p:style>
-          <a:lnRef idx="2">
-            <a:schemeClr val="accent1">
-              <a:shade val="15000"/>
-            </a:schemeClr>
-          </a:lnRef>
-          <a:fillRef idx="1">
-            <a:schemeClr val="accent1"/>
-          </a:fillRef>
-          <a:effectRef idx="0">
-            <a:schemeClr val="accent1"/>
-          </a:effectRef>
-          <a:fontRef idx="minor">
-            <a:schemeClr val="lt1"/>
-          </a:fontRef>
-        </p:style>
-        <p:txBody>
-          <a:bodyPr rtlCol="0" anchor="ctr"/>
-          <a:lstStyle/>
-          <a:p>
-            <a:pPr algn="ctr"/>
-            <a:r>
-              <a:rPr lang="en-US" sz="1050" b="1">
-                <a:solidFill>
-                  <a:srgbClr val="0D9488"/>
-                </a:solidFill>
-              </a:rPr>
-              <a:t>🚢 Amphibious Hull</a:t>
-            </a:r>
-          </a:p>
-          <a:p>
-            <a:pPr algn="ctr"/>
-            <a:r>
-              <a:rPr lang="en-US" sz="800">
-                <a:solidFill>
-                  <a:srgbClr val="1E3347"/>
-                </a:solidFill>
-              </a:rPr>
-              <a:t>IP68 pontoon floats &amp; steers</a:t>
-            </a:r>
-            <a:endParaRPr lang="en-IN" sz="800">
-              <a:solidFill>
-                <a:srgbClr val="1E3347"/>
-              </a:solidFill>
-            </a:endParaRPr>
-          </a:p>
-        </p:txBody>
-      </p:sp>
-      <p:sp>
-        <p:nvSpPr>
-          <p:cNvPr id="15" name="Rectangle: Rounded Corners 14">
-            <a:extLst>
-              <a:ext uri="{FF2B5EF4-FFF2-40B4-BE49-F238E27FC236}">
-                <a16:creationId xmlns:a16="http://schemas.microsoft.com/office/drawing/2014/main" id="{BB8FB2C3-ED57-055A-8C08-2D8F07DEE586}"/>
-              </a:ext>
-            </a:extLst>
-          </p:cNvPr>
-          <p:cNvSpPr/>
-          <p:nvPr/>
-        </p:nvSpPr>
-        <p:spPr>
-          <a:xfrm>
-            <a:off x="3302000" y="3403600"/>
-            <a:ext cx="2717800" cy="787400"/>
-          </a:xfrm>
-          <a:prstGeom prst="roundRect">
-            <a:avLst/>
-          </a:prstGeom>
-          <a:solidFill>
-            <a:srgbClr val="FFF1F2"/>
-          </a:solidFill>
-          <a:ln w="15240">
-            <a:solidFill>
-              <a:srgbClr val="E11D48"/>
-            </a:solidFill>
-          </a:ln>
-        </p:spPr>
-        <p:style>
-          <a:lnRef idx="2">
-            <a:schemeClr val="accent1">
-              <a:shade val="15000"/>
-            </a:schemeClr>
-          </a:lnRef>
-          <a:fillRef idx="1">
-            <a:schemeClr val="accent1"/>
-          </a:fillRef>
-          <a:effectRef idx="0">
-            <a:schemeClr val="accent1"/>
-          </a:effectRef>
-          <a:fontRef idx="minor">
-            <a:schemeClr val="lt1"/>
-          </a:fontRef>
-        </p:style>
-        <p:txBody>
-          <a:bodyPr rtlCol="0" anchor="ctr"/>
-          <a:lstStyle/>
-          <a:p>
-            <a:pPr algn="ctr"/>
-            <a:r>
-              <a:rPr lang="en-US" sz="1050" b="1">
-                <a:solidFill>
-                  <a:srgbClr val="E11D48"/>
-                </a:solidFill>
-              </a:rPr>
-              <a:t>🦾 Bionic SpO2 Arm</a:t>
-            </a:r>
-          </a:p>
-          <a:p>
-            <a:pPr algn="ctr"/>
-            <a:r>
-              <a:rPr lang="en-US" sz="800">
-                <a:solidFill>
-                  <a:srgbClr val="1E3347"/>
-                </a:solidFill>
-              </a:rPr>
-              <a:t>Scans pulse &amp; SpO2 in 10cm voids</a:t>
-            </a:r>
-            <a:endParaRPr lang="en-IN" sz="800">
-              <a:solidFill>
-                <a:srgbClr val="1E3347"/>
-              </a:solidFill>
-            </a:endParaRPr>
-          </a:p>
-        </p:txBody>
-      </p:sp>
-      <p:sp>
-        <p:nvSpPr>
-          <p:cNvPr id="16" name="Rectangle: Rounded Corners 15">
-            <a:extLst>
-              <a:ext uri="{FF2B5EF4-FFF2-40B4-BE49-F238E27FC236}">
-                <a16:creationId xmlns:a16="http://schemas.microsoft.com/office/drawing/2014/main" id="{F4E7FDCF-5962-8BF4-23FF-AE47571EAD1F}"/>
-              </a:ext>
-            </a:extLst>
-          </p:cNvPr>
-          <p:cNvSpPr/>
-          <p:nvPr/>
-        </p:nvSpPr>
-        <p:spPr>
-          <a:xfrm>
-            <a:off x="457200" y="4419600"/>
-            <a:ext cx="5689600" cy="1333500"/>
-          </a:xfrm>
-          <a:prstGeom prst="roundRect">
-            <a:avLst/>
-          </a:prstGeom>
-          <a:solidFill>
-            <a:srgbClr val="FFF7ED"/>
-          </a:solidFill>
-          <a:ln w="19050">
-            <a:solidFill>
-              <a:srgbClr val="EA580C"/>
-            </a:solidFill>
-          </a:ln>
-        </p:spPr>
-        <p:style>
-          <a:lnRef idx="2">
-            <a:schemeClr val="accent1">
-              <a:shade val="15000"/>
-            </a:schemeClr>
-          </a:lnRef>
-          <a:fillRef idx="1">
-            <a:schemeClr val="accent1"/>
-          </a:fillRef>
-          <a:effectRef idx="0">
-            <a:schemeClr val="accent1"/>
-          </a:effectRef>
-          <a:fontRef idx="minor">
-            <a:schemeClr val="lt1"/>
-          </a:fontRef>
-        </p:style>
-        <p:txBody>
-          <a:bodyPr rtlCol="0" anchor="ctr"/>
-          <a:lstStyle/>
-          <a:p>
-            <a:pPr algn="ctr"/>
-            <a:r>
-              <a:rPr lang="en-IN" sz="1000" b="1">
-                <a:solidFill>
-                  <a:srgbClr val="0F172A"/>
-                </a:solidFill>
-              </a:rPr>
-              <a:t>Team Leader: Harshit Sharma  |  Team: ALPHA-X (ID: SIH_1186)</a:t>
-            </a:r>
-          </a:p>
-          <a:p>
-            <a:pPr algn="ctr"/>
-            <a:r>
-              <a:rPr lang="en-IN" sz="850">
-                <a:solidFill>
-                  <a:srgbClr val="475569"/>
-                </a:solidFill>
-              </a:rPr>
-              <a:t>Institute: Poornima University, Jaipur  |  Category: Hardware &amp; Edge AI</a:t>
-            </a:r>
-          </a:p>
-          <a:p>
-            <a:pPr algn="ctr"/>
-            <a:r>
-              <a:rPr lang="en-IN" sz="850" b="1">
-                <a:solidFill>
-                  <a:srgbClr val="7C3AED"/>
-                </a:solidFill>
-              </a:rPr>
-              <a:t>Key Novelty: Autonomous 3D Rescue Blueprint &amp; Vitals Triage for NDRF</a:t>
-            </a:r>
-          </a:p>
-          <a:p>
-            <a:pPr algn="ctr"/>
-            <a:r>
-              <a:rPr lang="en-IN" sz="950" b="1">
-                <a:solidFill>
-                  <a:srgbClr val="EA580C"/>
-                </a:solidFill>
-              </a:rPr>
-              <a:t>'We don't just build robots, we build hope.'</a:t>
-            </a:r>
-          </a:p>
-        </p:txBody>
-      </p:sp>
       <p:pic>
         <p:nvPicPr>
-          <p:cNvPr id="18" name="Picture 17">
-            <a:extLst>
-              <a:ext uri="{FF2B5EF4-FFF2-40B4-BE49-F238E27FC236}">
-                <a16:creationId xmlns:a16="http://schemas.microsoft.com/office/drawing/2014/main" id="{42DECF9A-A9B2-08D9-54AE-5F14B2D4FEBE}"/>
+          <p:cNvPr id="3" name="Picture 2">
+            <a:extLst>
+              <a:ext uri="{FF2B5EF4-FFF2-40B4-BE49-F238E27FC236}">
+                <a16:creationId xmlns:a16="http://schemas.microsoft.com/office/drawing/2014/main" id="{AFB0A52A-17C0-01AB-33BC-3B5178174C24}"/>
               </a:ext>
             </a:extLst>
           </p:cNvPr>
@@ -4333,116 +3375,18 @@
         </p:blipFill>
         <p:spPr>
           <a:xfrm>
-            <a:off x="6540500" y="762000"/>
-            <a:ext cx="5397500" cy="5270500"/>
+            <a:off x="0" y="0"/>
+            <a:ext cx="12192000" cy="6858000"/>
           </a:xfrm>
           <a:prstGeom prst="rect">
             <a:avLst/>
           </a:prstGeom>
-          <a:ln w="25400">
-            <a:solidFill>
-              <a:schemeClr val="tx1"/>
-            </a:solidFill>
-          </a:ln>
         </p:spPr>
       </p:pic>
-      <p:sp>
-        <p:nvSpPr>
-          <p:cNvPr id="19" name="Rectangle 18">
-            <a:extLst>
-              <a:ext uri="{FF2B5EF4-FFF2-40B4-BE49-F238E27FC236}">
-                <a16:creationId xmlns:a16="http://schemas.microsoft.com/office/drawing/2014/main" id="{E5396065-A1DD-AD0E-F182-EB532FB2D841}"/>
-              </a:ext>
-            </a:extLst>
-          </p:cNvPr>
-          <p:cNvSpPr/>
-          <p:nvPr/>
-        </p:nvSpPr>
-        <p:spPr>
-          <a:xfrm>
-            <a:off x="0" y="6159500"/>
-            <a:ext cx="12192000" cy="698500"/>
-          </a:xfrm>
-          <a:prstGeom prst="rect">
-            <a:avLst/>
-          </a:prstGeom>
-          <a:solidFill>
-            <a:srgbClr val="FFFFFF"/>
-          </a:solidFill>
-          <a:ln w="12700">
-            <a:solidFill>
-              <a:srgbClr val="F0E8E2"/>
-            </a:solidFill>
-          </a:ln>
-        </p:spPr>
-        <p:style>
-          <a:lnRef idx="2">
-            <a:schemeClr val="accent1">
-              <a:shade val="15000"/>
-            </a:schemeClr>
-          </a:lnRef>
-          <a:fillRef idx="1">
-            <a:schemeClr val="accent1"/>
-          </a:fillRef>
-          <a:effectRef idx="0">
-            <a:schemeClr val="accent1"/>
-          </a:effectRef>
-          <a:fontRef idx="minor">
-            <a:schemeClr val="lt1"/>
-          </a:fontRef>
-        </p:style>
-        <p:txBody>
-          <a:bodyPr rtlCol="0" anchor="ctr"/>
-          <a:lstStyle/>
-          <a:p>
-            <a:pPr algn="ctr"/>
-            <a:endParaRPr lang="en-IN"/>
-          </a:p>
-        </p:txBody>
-      </p:sp>
-      <p:sp>
-        <p:nvSpPr>
-          <p:cNvPr id="20" name="TextBox 19">
-            <a:extLst>
-              <a:ext uri="{FF2B5EF4-FFF2-40B4-BE49-F238E27FC236}">
-                <a16:creationId xmlns:a16="http://schemas.microsoft.com/office/drawing/2014/main" id="{E0B2B85E-62B5-B26F-461C-4C3FD20BD144}"/>
-              </a:ext>
-            </a:extLst>
-          </p:cNvPr>
-          <p:cNvSpPr txBox="1"/>
-          <p:nvPr/>
-        </p:nvSpPr>
-        <p:spPr>
-          <a:xfrm>
-            <a:off x="254000" y="6248400"/>
-            <a:ext cx="11684000" cy="253916"/>
-          </a:xfrm>
-          <a:prstGeom prst="rect">
-            <a:avLst/>
-          </a:prstGeom>
-          <a:noFill/>
-        </p:spPr>
-        <p:txBody>
-          <a:bodyPr vert="horz" rtlCol="0">
-            <a:spAutoFit/>
-          </a:bodyPr>
-          <a:lstStyle/>
-          <a:p>
-            <a:r>
-              <a:rPr lang="en-IN" sz="1050" b="1">
-                <a:solidFill>
-                  <a:srgbClr val="EA580C"/>
-                </a:solidFill>
-              </a:rPr>
-              <a:t>Poornima University Internal Hackathon RANK 5 Finalist   |   Theme: Disaster Management   |   GitHub: github.com/harshitsharma120109-web/ARIES-Search-Rescue-Rover</a:t>
-            </a:r>
-          </a:p>
-        </p:txBody>
-      </p:sp>
     </p:spTree>
     <p:extLst>
       <p:ext uri="{BB962C8B-B14F-4D97-AF65-F5344CB8AC3E}">
-        <p14:creationId xmlns:p14="http://schemas.microsoft.com/office/powerpoint/2010/main" val="4075298568"/>
+        <p14:creationId xmlns:p14="http://schemas.microsoft.com/office/powerpoint/2010/main" val="275923079"/>
       </p:ext>
     </p:extLst>
   </p:cSld>
@@ -4474,7 +3418,7 @@
           <p:cNvPr id="2" name="Rectangle 1">
             <a:extLst>
               <a:ext uri="{FF2B5EF4-FFF2-40B4-BE49-F238E27FC236}">
-                <a16:creationId xmlns:a16="http://schemas.microsoft.com/office/drawing/2014/main" id="{59368BB6-992F-0692-40B7-627AC25C7A40}"/>
+                <a16:creationId xmlns:a16="http://schemas.microsoft.com/office/drawing/2014/main" id="{E3F7FEE2-1971-D3D9-CEB9-6927E916FE80}"/>
               </a:ext>
             </a:extLst>
           </p:cNvPr>
@@ -4542,7 +3486,7 @@
           <p:cNvPr id="3" name="Rectangle 2">
             <a:extLst>
               <a:ext uri="{FF2B5EF4-FFF2-40B4-BE49-F238E27FC236}">
-                <a16:creationId xmlns:a16="http://schemas.microsoft.com/office/drawing/2014/main" id="{8879B3FB-7747-A00C-96C2-5EFEE5A6F4E9}"/>
+                <a16:creationId xmlns:a16="http://schemas.microsoft.com/office/drawing/2014/main" id="{235B77DD-0924-034F-AE11-163C1DA3D5B7}"/>
               </a:ext>
             </a:extLst>
           </p:cNvPr>
@@ -4596,7 +3540,7 @@
           <p:cNvPr id="4" name="Rectangle: Rounded Corners 3">
             <a:extLst>
               <a:ext uri="{FF2B5EF4-FFF2-40B4-BE49-F238E27FC236}">
-                <a16:creationId xmlns:a16="http://schemas.microsoft.com/office/drawing/2014/main" id="{29BEBB84-1731-EE75-E6C9-7AF98433CEE7}"/>
+                <a16:creationId xmlns:a16="http://schemas.microsoft.com/office/drawing/2014/main" id="{32B72BEF-F928-CCD7-727A-286726F57E32}"/>
               </a:ext>
             </a:extLst>
           </p:cNvPr>
@@ -4671,7 +3615,7 @@
           <p:cNvPr id="5" name="TextBox 4">
             <a:extLst>
               <a:ext uri="{FF2B5EF4-FFF2-40B4-BE49-F238E27FC236}">
-                <a16:creationId xmlns:a16="http://schemas.microsoft.com/office/drawing/2014/main" id="{83E1290F-BC3C-FF02-58FC-F9B2FB0816C5}"/>
+                <a16:creationId xmlns:a16="http://schemas.microsoft.com/office/drawing/2014/main" id="{DD4ADECA-1338-A49D-2FDC-48A677A3047F}"/>
               </a:ext>
             </a:extLst>
           </p:cNvPr>
@@ -4710,7 +3654,7 @@
           <p:cNvPr id="6" name="Rectangle: Rounded Corners 5">
             <a:extLst>
               <a:ext uri="{FF2B5EF4-FFF2-40B4-BE49-F238E27FC236}">
-                <a16:creationId xmlns:a16="http://schemas.microsoft.com/office/drawing/2014/main" id="{CECB9735-3064-8E8B-7F07-0A6DEBDB8EF6}"/>
+                <a16:creationId xmlns:a16="http://schemas.microsoft.com/office/drawing/2014/main" id="{F8CF6D71-6057-DF16-22FC-DDF33C2CED3E}"/>
               </a:ext>
             </a:extLst>
           </p:cNvPr>
@@ -4766,73 +3710,48 @@
           </a:p>
         </p:txBody>
       </p:sp>
-      <p:sp>
-        <p:nvSpPr>
-          <p:cNvPr id="7" name="Rectangle: Rounded Corners 6">
-            <a:extLst>
-              <a:ext uri="{FF2B5EF4-FFF2-40B4-BE49-F238E27FC236}">
-                <a16:creationId xmlns:a16="http://schemas.microsoft.com/office/drawing/2014/main" id="{E52CC7AD-F9D1-6530-C514-C8D1F8011305}"/>
-              </a:ext>
-            </a:extLst>
-          </p:cNvPr>
-          <p:cNvSpPr/>
-          <p:nvPr/>
-        </p:nvSpPr>
-        <p:spPr>
-          <a:xfrm>
-            <a:off x="11112500" y="88900"/>
-            <a:ext cx="825500" cy="431800"/>
-          </a:xfrm>
-          <a:prstGeom prst="roundRect">
-            <a:avLst/>
-          </a:prstGeom>
-          <a:solidFill>
-            <a:srgbClr val="FFFBEB"/>
-          </a:solidFill>
-          <a:ln w="19050">
-            <a:solidFill>
-              <a:srgbClr val="D97706"/>
-            </a:solidFill>
-          </a:ln>
-        </p:spPr>
-        <p:style>
-          <a:lnRef idx="2">
-            <a:schemeClr val="accent1">
-              <a:shade val="15000"/>
-            </a:schemeClr>
-          </a:lnRef>
-          <a:fillRef idx="1">
-            <a:schemeClr val="accent1"/>
-          </a:fillRef>
-          <a:effectRef idx="0">
-            <a:schemeClr val="accent1"/>
-          </a:effectRef>
-          <a:fontRef idx="minor">
-            <a:schemeClr val="lt1"/>
-          </a:fontRef>
-        </p:style>
-        <p:txBody>
-          <a:bodyPr rtlCol="0" anchor="ctr"/>
-          <a:lstStyle/>
-          <a:p>
-            <a:pPr algn="ctr"/>
-            <a:r>
-              <a:rPr lang="en-IN" sz="800" b="1">
-                <a:solidFill>
-                  <a:srgbClr val="D97706"/>
-                </a:solidFill>
-              </a:rPr>
-              <a:t>[SIH LOGO]</a:t>
-            </a:r>
-          </a:p>
-        </p:txBody>
-      </p:sp>
-      <p:sp>
-        <p:nvSpPr>
-          <p:cNvPr id="8" name="Rectangle: Rounded Corners 7">
-            <a:extLst>
-              <a:ext uri="{FF2B5EF4-FFF2-40B4-BE49-F238E27FC236}">
-                <a16:creationId xmlns:a16="http://schemas.microsoft.com/office/drawing/2014/main" id="{3713B0DB-EF11-837B-EDBE-531A8B572664}"/>
+      <p:pic>
+        <p:nvPicPr>
+          <p:cNvPr id="8" name="Picture 7">
+            <a:extLst>
+              <a:ext uri="{FF2B5EF4-FFF2-40B4-BE49-F238E27FC236}">
+                <a16:creationId xmlns:a16="http://schemas.microsoft.com/office/drawing/2014/main" id="{6D1DE833-A238-BCF7-0BF6-C6D6EC53F041}"/>
+              </a:ext>
+            </a:extLst>
+          </p:cNvPr>
+          <p:cNvPicPr>
+            <a:picLocks/>
+          </p:cNvPicPr>
+          <p:nvPr/>
+        </p:nvPicPr>
+        <p:blipFill>
+          <a:blip r:embed="rId2">
+            <a:extLst>
+              <a:ext uri="{28A0092B-C50C-407E-A947-70E740481C1C}">
+                <a14:useLocalDpi xmlns:a14="http://schemas.microsoft.com/office/drawing/2010/main" val="0"/>
+              </a:ext>
+            </a:extLst>
+          </a:blip>
+          <a:stretch>
+            <a:fillRect/>
+          </a:stretch>
+        </p:blipFill>
+        <p:spPr>
+          <a:xfrm>
+            <a:off x="11023600" y="76200"/>
+            <a:ext cx="965200" cy="457200"/>
+          </a:xfrm>
+          <a:prstGeom prst="rect">
+            <a:avLst/>
+          </a:prstGeom>
+        </p:spPr>
+      </p:pic>
+      <p:sp>
+        <p:nvSpPr>
+          <p:cNvPr id="9" name="Rectangle: Rounded Corners 8">
+            <a:extLst>
+              <a:ext uri="{FF2B5EF4-FFF2-40B4-BE49-F238E27FC236}">
+                <a16:creationId xmlns:a16="http://schemas.microsoft.com/office/drawing/2014/main" id="{B77BC9A0-A2FA-A756-CFC1-C9E31EF2C143}"/>
               </a:ext>
             </a:extLst>
           </p:cNvPr>
@@ -4906,10 +3825,10 @@
       </p:sp>
       <p:sp>
         <p:nvSpPr>
-          <p:cNvPr id="9" name="Rectangle: Rounded Corners 8">
-            <a:extLst>
-              <a:ext uri="{FF2B5EF4-FFF2-40B4-BE49-F238E27FC236}">
-                <a16:creationId xmlns:a16="http://schemas.microsoft.com/office/drawing/2014/main" id="{B0E9822E-F4C0-9FBC-A7C6-4172C717E6AB}"/>
+          <p:cNvPr id="10" name="Rectangle: Rounded Corners 9">
+            <a:extLst>
+              <a:ext uri="{FF2B5EF4-FFF2-40B4-BE49-F238E27FC236}">
+                <a16:creationId xmlns:a16="http://schemas.microsoft.com/office/drawing/2014/main" id="{9C9D6044-FF71-F278-B7C5-A318DEFFE588}"/>
               </a:ext>
             </a:extLst>
           </p:cNvPr>
@@ -4983,10 +3902,10 @@
       </p:sp>
       <p:sp>
         <p:nvSpPr>
-          <p:cNvPr id="10" name="Rectangle: Rounded Corners 9">
-            <a:extLst>
-              <a:ext uri="{FF2B5EF4-FFF2-40B4-BE49-F238E27FC236}">
-                <a16:creationId xmlns:a16="http://schemas.microsoft.com/office/drawing/2014/main" id="{6CA66F16-CAFD-6A5C-8B94-C281C40D5B87}"/>
+          <p:cNvPr id="11" name="Rectangle: Rounded Corners 10">
+            <a:extLst>
+              <a:ext uri="{FF2B5EF4-FFF2-40B4-BE49-F238E27FC236}">
+                <a16:creationId xmlns:a16="http://schemas.microsoft.com/office/drawing/2014/main" id="{4687B7E4-BE69-8498-EC3D-EE0C68439E07}"/>
               </a:ext>
             </a:extLst>
           </p:cNvPr>
@@ -5060,10 +3979,10 @@
       </p:sp>
       <p:sp>
         <p:nvSpPr>
-          <p:cNvPr id="11" name="Rectangle: Rounded Corners 10">
-            <a:extLst>
-              <a:ext uri="{FF2B5EF4-FFF2-40B4-BE49-F238E27FC236}">
-                <a16:creationId xmlns:a16="http://schemas.microsoft.com/office/drawing/2014/main" id="{BB1DA25E-07B5-39F9-ABE0-5C8FD915E088}"/>
+          <p:cNvPr id="12" name="Rectangle: Rounded Corners 11">
+            <a:extLst>
+              <a:ext uri="{FF2B5EF4-FFF2-40B4-BE49-F238E27FC236}">
+                <a16:creationId xmlns:a16="http://schemas.microsoft.com/office/drawing/2014/main" id="{4EC743B2-1FEA-CACD-6E59-3315272D09D5}"/>
               </a:ext>
             </a:extLst>
           </p:cNvPr>
@@ -5137,10 +4056,10 @@
       </p:sp>
       <p:sp>
         <p:nvSpPr>
-          <p:cNvPr id="12" name="Rectangle: Rounded Corners 11">
-            <a:extLst>
-              <a:ext uri="{FF2B5EF4-FFF2-40B4-BE49-F238E27FC236}">
-                <a16:creationId xmlns:a16="http://schemas.microsoft.com/office/drawing/2014/main" id="{CE857BED-C40D-A6DF-9B9D-2254D73DADC7}"/>
+          <p:cNvPr id="13" name="Rectangle: Rounded Corners 12">
+            <a:extLst>
+              <a:ext uri="{FF2B5EF4-FFF2-40B4-BE49-F238E27FC236}">
+                <a16:creationId xmlns:a16="http://schemas.microsoft.com/office/drawing/2014/main" id="{0F48826B-F1D1-1EDC-39CA-48BA608D98E8}"/>
               </a:ext>
             </a:extLst>
           </p:cNvPr>
@@ -5191,10 +4110,10 @@
       </p:sp>
       <p:sp>
         <p:nvSpPr>
-          <p:cNvPr id="13" name="TextBox 12">
-            <a:extLst>
-              <a:ext uri="{FF2B5EF4-FFF2-40B4-BE49-F238E27FC236}">
-                <a16:creationId xmlns:a16="http://schemas.microsoft.com/office/drawing/2014/main" id="{856A423D-AF61-D847-A7A3-8CAADE77A1B9}"/>
+          <p:cNvPr id="14" name="TextBox 13">
+            <a:extLst>
+              <a:ext uri="{FF2B5EF4-FFF2-40B4-BE49-F238E27FC236}">
+                <a16:creationId xmlns:a16="http://schemas.microsoft.com/office/drawing/2014/main" id="{0033AC97-E27F-2223-66BD-CE0C7FA80243}"/>
               </a:ext>
             </a:extLst>
           </p:cNvPr>
@@ -5235,10 +4154,10 @@
       </p:sp>
       <p:sp>
         <p:nvSpPr>
-          <p:cNvPr id="14" name="Rectangle: Rounded Corners 13">
-            <a:extLst>
-              <a:ext uri="{FF2B5EF4-FFF2-40B4-BE49-F238E27FC236}">
-                <a16:creationId xmlns:a16="http://schemas.microsoft.com/office/drawing/2014/main" id="{681FF341-56B0-07F4-E64E-91D31A30C79F}"/>
+          <p:cNvPr id="15" name="Rectangle: Rounded Corners 14">
+            <a:extLst>
+              <a:ext uri="{FF2B5EF4-FFF2-40B4-BE49-F238E27FC236}">
+                <a16:creationId xmlns:a16="http://schemas.microsoft.com/office/drawing/2014/main" id="{30003712-ECFE-CEFF-B1C2-7D9099A26387}"/>
               </a:ext>
             </a:extLst>
           </p:cNvPr>
@@ -5289,10 +4208,10 @@
       </p:sp>
       <p:sp>
         <p:nvSpPr>
-          <p:cNvPr id="15" name="Rectangle: Rounded Corners 14">
-            <a:extLst>
-              <a:ext uri="{FF2B5EF4-FFF2-40B4-BE49-F238E27FC236}">
-                <a16:creationId xmlns:a16="http://schemas.microsoft.com/office/drawing/2014/main" id="{1256AFC1-D36D-7B02-0D12-E04A13DF67D0}"/>
+          <p:cNvPr id="16" name="Rectangle: Rounded Corners 15">
+            <a:extLst>
+              <a:ext uri="{FF2B5EF4-FFF2-40B4-BE49-F238E27FC236}">
+                <a16:creationId xmlns:a16="http://schemas.microsoft.com/office/drawing/2014/main" id="{C7A41084-7B02-615D-E110-AE82CC4FA18D}"/>
               </a:ext>
             </a:extLst>
           </p:cNvPr>
@@ -5364,10 +4283,10 @@
       </p:sp>
       <p:sp>
         <p:nvSpPr>
-          <p:cNvPr id="16" name="TextBox 15">
-            <a:extLst>
-              <a:ext uri="{FF2B5EF4-FFF2-40B4-BE49-F238E27FC236}">
-                <a16:creationId xmlns:a16="http://schemas.microsoft.com/office/drawing/2014/main" id="{19987207-596A-E976-B8DA-AA7C8D9FEE53}"/>
+          <p:cNvPr id="17" name="TextBox 16">
+            <a:extLst>
+              <a:ext uri="{FF2B5EF4-FFF2-40B4-BE49-F238E27FC236}">
+                <a16:creationId xmlns:a16="http://schemas.microsoft.com/office/drawing/2014/main" id="{523FCC16-10D1-6C1E-4EDE-ECE5A5D2D8F5}"/>
               </a:ext>
             </a:extLst>
           </p:cNvPr>
@@ -5413,10 +4332,10 @@
       </p:sp>
       <p:sp>
         <p:nvSpPr>
-          <p:cNvPr id="17" name="Rectangle: Rounded Corners 16">
-            <a:extLst>
-              <a:ext uri="{FF2B5EF4-FFF2-40B4-BE49-F238E27FC236}">
-                <a16:creationId xmlns:a16="http://schemas.microsoft.com/office/drawing/2014/main" id="{D373ECB1-5738-278F-C2D3-566829B32A35}"/>
+          <p:cNvPr id="18" name="Rectangle: Rounded Corners 17">
+            <a:extLst>
+              <a:ext uri="{FF2B5EF4-FFF2-40B4-BE49-F238E27FC236}">
+                <a16:creationId xmlns:a16="http://schemas.microsoft.com/office/drawing/2014/main" id="{D93D1ECB-34D5-09DB-728C-EAD429108BB8}"/>
               </a:ext>
             </a:extLst>
           </p:cNvPr>
@@ -5467,10 +4386,10 @@
       </p:sp>
       <p:sp>
         <p:nvSpPr>
-          <p:cNvPr id="18" name="Rectangle: Rounded Corners 17">
-            <a:extLst>
-              <a:ext uri="{FF2B5EF4-FFF2-40B4-BE49-F238E27FC236}">
-                <a16:creationId xmlns:a16="http://schemas.microsoft.com/office/drawing/2014/main" id="{BE2E9EFB-9386-1515-0B84-EA0A37BD5E01}"/>
+          <p:cNvPr id="19" name="Rectangle: Rounded Corners 18">
+            <a:extLst>
+              <a:ext uri="{FF2B5EF4-FFF2-40B4-BE49-F238E27FC236}">
+                <a16:creationId xmlns:a16="http://schemas.microsoft.com/office/drawing/2014/main" id="{3B2D8EE7-258F-AFB8-F124-C6F3272DCA54}"/>
               </a:ext>
             </a:extLst>
           </p:cNvPr>
@@ -5542,10 +4461,10 @@
       </p:sp>
       <p:sp>
         <p:nvSpPr>
-          <p:cNvPr id="19" name="TextBox 18">
-            <a:extLst>
-              <a:ext uri="{FF2B5EF4-FFF2-40B4-BE49-F238E27FC236}">
-                <a16:creationId xmlns:a16="http://schemas.microsoft.com/office/drawing/2014/main" id="{7AB8B2F6-1DA5-D29C-B630-D14BF0E892D3}"/>
+          <p:cNvPr id="20" name="TextBox 19">
+            <a:extLst>
+              <a:ext uri="{FF2B5EF4-FFF2-40B4-BE49-F238E27FC236}">
+                <a16:creationId xmlns:a16="http://schemas.microsoft.com/office/drawing/2014/main" id="{C5DEE35D-52AA-A4C4-6345-D5026476393B}"/>
               </a:ext>
             </a:extLst>
           </p:cNvPr>
@@ -5596,10 +4515,10 @@
       </p:sp>
       <p:sp>
         <p:nvSpPr>
-          <p:cNvPr id="20" name="Rectangle: Rounded Corners 19">
-            <a:extLst>
-              <a:ext uri="{FF2B5EF4-FFF2-40B4-BE49-F238E27FC236}">
-                <a16:creationId xmlns:a16="http://schemas.microsoft.com/office/drawing/2014/main" id="{CD0C68ED-E337-8A29-41D7-0B72976BACF5}"/>
+          <p:cNvPr id="21" name="Rectangle: Rounded Corners 20">
+            <a:extLst>
+              <a:ext uri="{FF2B5EF4-FFF2-40B4-BE49-F238E27FC236}">
+                <a16:creationId xmlns:a16="http://schemas.microsoft.com/office/drawing/2014/main" id="{61D04669-62AE-616F-27EF-B215A487291B}"/>
               </a:ext>
             </a:extLst>
           </p:cNvPr>
@@ -5650,10 +4569,10 @@
       </p:sp>
       <p:sp>
         <p:nvSpPr>
-          <p:cNvPr id="21" name="Rectangle: Rounded Corners 20">
-            <a:extLst>
-              <a:ext uri="{FF2B5EF4-FFF2-40B4-BE49-F238E27FC236}">
-                <a16:creationId xmlns:a16="http://schemas.microsoft.com/office/drawing/2014/main" id="{110B0D78-02B1-7479-193C-1CAF19AAA44F}"/>
+          <p:cNvPr id="22" name="Rectangle: Rounded Corners 21">
+            <a:extLst>
+              <a:ext uri="{FF2B5EF4-FFF2-40B4-BE49-F238E27FC236}">
+                <a16:creationId xmlns:a16="http://schemas.microsoft.com/office/drawing/2014/main" id="{F6E9AA74-87E6-F8CF-7CF8-53EC2355FE9A}"/>
               </a:ext>
             </a:extLst>
           </p:cNvPr>
@@ -5725,10 +4644,10 @@
       </p:sp>
       <p:sp>
         <p:nvSpPr>
-          <p:cNvPr id="22" name="TextBox 21">
-            <a:extLst>
-              <a:ext uri="{FF2B5EF4-FFF2-40B4-BE49-F238E27FC236}">
-                <a16:creationId xmlns:a16="http://schemas.microsoft.com/office/drawing/2014/main" id="{529CED0E-AE39-7B96-8280-FF781FB9B65F}"/>
+          <p:cNvPr id="23" name="TextBox 22">
+            <a:extLst>
+              <a:ext uri="{FF2B5EF4-FFF2-40B4-BE49-F238E27FC236}">
+                <a16:creationId xmlns:a16="http://schemas.microsoft.com/office/drawing/2014/main" id="{A06D1688-098F-438E-0A2E-3B67ECFC3297}"/>
               </a:ext>
             </a:extLst>
           </p:cNvPr>
@@ -5774,10 +4693,10 @@
       </p:sp>
       <p:sp>
         <p:nvSpPr>
-          <p:cNvPr id="23" name="Rectangle: Rounded Corners 22">
-            <a:extLst>
-              <a:ext uri="{FF2B5EF4-FFF2-40B4-BE49-F238E27FC236}">
-                <a16:creationId xmlns:a16="http://schemas.microsoft.com/office/drawing/2014/main" id="{110B52C6-DD47-1EC2-86CE-6F82E0060674}"/>
+          <p:cNvPr id="24" name="Rectangle: Rounded Corners 23">
+            <a:extLst>
+              <a:ext uri="{FF2B5EF4-FFF2-40B4-BE49-F238E27FC236}">
+                <a16:creationId xmlns:a16="http://schemas.microsoft.com/office/drawing/2014/main" id="{FEE36107-C1EE-95CF-A340-BB3F7B55694C}"/>
               </a:ext>
             </a:extLst>
           </p:cNvPr>
@@ -5828,10 +4747,10 @@
       </p:sp>
       <p:sp>
         <p:nvSpPr>
-          <p:cNvPr id="24" name="Rectangle: Rounded Corners 23">
-            <a:extLst>
-              <a:ext uri="{FF2B5EF4-FFF2-40B4-BE49-F238E27FC236}">
-                <a16:creationId xmlns:a16="http://schemas.microsoft.com/office/drawing/2014/main" id="{E6C5A19F-F44D-FD68-CED2-F62ED1D2D191}"/>
+          <p:cNvPr id="25" name="Rectangle: Rounded Corners 24">
+            <a:extLst>
+              <a:ext uri="{FF2B5EF4-FFF2-40B4-BE49-F238E27FC236}">
+                <a16:creationId xmlns:a16="http://schemas.microsoft.com/office/drawing/2014/main" id="{664A61E9-EADF-4FBA-3F41-2F2F31523C7E}"/>
               </a:ext>
             </a:extLst>
           </p:cNvPr>
@@ -5903,10 +4822,10 @@
       </p:sp>
       <p:sp>
         <p:nvSpPr>
-          <p:cNvPr id="25" name="TextBox 24">
-            <a:extLst>
-              <a:ext uri="{FF2B5EF4-FFF2-40B4-BE49-F238E27FC236}">
-                <a16:creationId xmlns:a16="http://schemas.microsoft.com/office/drawing/2014/main" id="{C0905BDF-7CA7-EC92-1128-1D918275F73F}"/>
+          <p:cNvPr id="26" name="TextBox 25">
+            <a:extLst>
+              <a:ext uri="{FF2B5EF4-FFF2-40B4-BE49-F238E27FC236}">
+                <a16:creationId xmlns:a16="http://schemas.microsoft.com/office/drawing/2014/main" id="{9F64C6BB-9DC4-7F55-383D-886C277EDEBD}"/>
               </a:ext>
             </a:extLst>
           </p:cNvPr>
@@ -5952,10 +4871,10 @@
       </p:sp>
       <p:sp>
         <p:nvSpPr>
-          <p:cNvPr id="26" name="Rectangle: Rounded Corners 25">
-            <a:extLst>
-              <a:ext uri="{FF2B5EF4-FFF2-40B4-BE49-F238E27FC236}">
-                <a16:creationId xmlns:a16="http://schemas.microsoft.com/office/drawing/2014/main" id="{74C47C6F-E36A-E788-3CF5-32197D1606B7}"/>
+          <p:cNvPr id="27" name="Rectangle: Rounded Corners 26">
+            <a:extLst>
+              <a:ext uri="{FF2B5EF4-FFF2-40B4-BE49-F238E27FC236}">
+                <a16:creationId xmlns:a16="http://schemas.microsoft.com/office/drawing/2014/main" id="{7EE48E7B-86ED-3FAD-5592-74129086CA0E}"/>
               </a:ext>
             </a:extLst>
           </p:cNvPr>
@@ -6006,10 +4925,10 @@
       </p:sp>
       <p:sp>
         <p:nvSpPr>
-          <p:cNvPr id="27" name="Rectangle: Rounded Corners 26">
-            <a:extLst>
-              <a:ext uri="{FF2B5EF4-FFF2-40B4-BE49-F238E27FC236}">
-                <a16:creationId xmlns:a16="http://schemas.microsoft.com/office/drawing/2014/main" id="{63396D29-41CF-1C16-79FE-CFB0A46999BF}"/>
+          <p:cNvPr id="28" name="Rectangle: Rounded Corners 27">
+            <a:extLst>
+              <a:ext uri="{FF2B5EF4-FFF2-40B4-BE49-F238E27FC236}">
+                <a16:creationId xmlns:a16="http://schemas.microsoft.com/office/drawing/2014/main" id="{0FD10D29-0633-01E8-E5FD-2637BE5ACFFB}"/>
               </a:ext>
             </a:extLst>
           </p:cNvPr>
@@ -6081,10 +5000,10 @@
       </p:sp>
       <p:sp>
         <p:nvSpPr>
-          <p:cNvPr id="28" name="TextBox 27">
-            <a:extLst>
-              <a:ext uri="{FF2B5EF4-FFF2-40B4-BE49-F238E27FC236}">
-                <a16:creationId xmlns:a16="http://schemas.microsoft.com/office/drawing/2014/main" id="{051676B4-FBBB-505E-53C8-7F76E4331DC1}"/>
+          <p:cNvPr id="29" name="TextBox 28">
+            <a:extLst>
+              <a:ext uri="{FF2B5EF4-FFF2-40B4-BE49-F238E27FC236}">
+                <a16:creationId xmlns:a16="http://schemas.microsoft.com/office/drawing/2014/main" id="{85F57D64-6DB2-87B9-9B5B-3F83879608BF}"/>
               </a:ext>
             </a:extLst>
           </p:cNvPr>
@@ -6135,10 +5054,10 @@
       </p:sp>
       <p:pic>
         <p:nvPicPr>
-          <p:cNvPr id="30" name="Picture 29">
-            <a:extLst>
-              <a:ext uri="{FF2B5EF4-FFF2-40B4-BE49-F238E27FC236}">
-                <a16:creationId xmlns:a16="http://schemas.microsoft.com/office/drawing/2014/main" id="{046EFC6E-8D79-1216-11C2-D1BB58F85AFA}"/>
+          <p:cNvPr id="31" name="Picture 30">
+            <a:extLst>
+              <a:ext uri="{FF2B5EF4-FFF2-40B4-BE49-F238E27FC236}">
+                <a16:creationId xmlns:a16="http://schemas.microsoft.com/office/drawing/2014/main" id="{AC722DB0-F2E4-2224-CD27-A77D2DA8C04E}"/>
               </a:ext>
             </a:extLst>
           </p:cNvPr>
@@ -6148,7 +5067,7 @@
           <p:nvPr/>
         </p:nvPicPr>
         <p:blipFill>
-          <a:blip r:embed="rId2">
+          <a:blip r:embed="rId3">
             <a:extLst>
               <a:ext uri="{28A0092B-C50C-407E-A947-70E740481C1C}">
                 <a14:useLocalDpi xmlns:a14="http://schemas.microsoft.com/office/drawing/2010/main" val="0"/>
@@ -6176,10 +5095,10 @@
       </p:pic>
       <p:sp>
         <p:nvSpPr>
-          <p:cNvPr id="31" name="Rectangle: Rounded Corners 30">
-            <a:extLst>
-              <a:ext uri="{FF2B5EF4-FFF2-40B4-BE49-F238E27FC236}">
-                <a16:creationId xmlns:a16="http://schemas.microsoft.com/office/drawing/2014/main" id="{835D65AD-AB3C-C3D5-9D88-FCCA6A3BB79F}"/>
+          <p:cNvPr id="32" name="Rectangle: Rounded Corners 31">
+            <a:extLst>
+              <a:ext uri="{FF2B5EF4-FFF2-40B4-BE49-F238E27FC236}">
+                <a16:creationId xmlns:a16="http://schemas.microsoft.com/office/drawing/2014/main" id="{8CBABF71-67AB-DC96-DBC9-375AA987E8BA}"/>
               </a:ext>
             </a:extLst>
           </p:cNvPr>
@@ -6281,10 +5200,10 @@
       </p:sp>
       <p:sp>
         <p:nvSpPr>
-          <p:cNvPr id="32" name="Rectangle 31">
-            <a:extLst>
-              <a:ext uri="{FF2B5EF4-FFF2-40B4-BE49-F238E27FC236}">
-                <a16:creationId xmlns:a16="http://schemas.microsoft.com/office/drawing/2014/main" id="{AB94C29E-EA3F-960D-29F0-F0A69DC3C8F4}"/>
+          <p:cNvPr id="33" name="Rectangle 32">
+            <a:extLst>
+              <a:ext uri="{FF2B5EF4-FFF2-40B4-BE49-F238E27FC236}">
+                <a16:creationId xmlns:a16="http://schemas.microsoft.com/office/drawing/2014/main" id="{994ECB85-AF54-45BD-38DC-E56A60A43C6D}"/>
               </a:ext>
             </a:extLst>
           </p:cNvPr>
@@ -6335,10 +5254,10 @@
       </p:sp>
       <p:sp>
         <p:nvSpPr>
-          <p:cNvPr id="33" name="TextBox 32">
-            <a:extLst>
-              <a:ext uri="{FF2B5EF4-FFF2-40B4-BE49-F238E27FC236}">
-                <a16:creationId xmlns:a16="http://schemas.microsoft.com/office/drawing/2014/main" id="{45202B9F-4E7B-E2F2-6138-F2919C9B336D}"/>
+          <p:cNvPr id="34" name="TextBox 33">
+            <a:extLst>
+              <a:ext uri="{FF2B5EF4-FFF2-40B4-BE49-F238E27FC236}">
+                <a16:creationId xmlns:a16="http://schemas.microsoft.com/office/drawing/2014/main" id="{D7536ECD-91DF-98F7-EBC5-E0964E47C980}"/>
               </a:ext>
             </a:extLst>
           </p:cNvPr>
@@ -6380,7 +5299,7 @@
     </p:spTree>
     <p:extLst>
       <p:ext uri="{BB962C8B-B14F-4D97-AF65-F5344CB8AC3E}">
-        <p14:creationId xmlns:p14="http://schemas.microsoft.com/office/powerpoint/2010/main" val="609883148"/>
+        <p14:creationId xmlns:p14="http://schemas.microsoft.com/office/powerpoint/2010/main" val="438490619"/>
       </p:ext>
     </p:extLst>
   </p:cSld>
@@ -6412,7 +5331,7 @@
           <p:cNvPr id="2" name="Rectangle 1">
             <a:extLst>
               <a:ext uri="{FF2B5EF4-FFF2-40B4-BE49-F238E27FC236}">
-                <a16:creationId xmlns:a16="http://schemas.microsoft.com/office/drawing/2014/main" id="{137EA012-F995-93BF-86D4-E8911BBF1232}"/>
+                <a16:creationId xmlns:a16="http://schemas.microsoft.com/office/drawing/2014/main" id="{6F7333A2-B01F-0D09-59CE-B167C6021881}"/>
               </a:ext>
             </a:extLst>
           </p:cNvPr>
@@ -6480,7 +5399,7 @@
           <p:cNvPr id="3" name="Rectangle 2">
             <a:extLst>
               <a:ext uri="{FF2B5EF4-FFF2-40B4-BE49-F238E27FC236}">
-                <a16:creationId xmlns:a16="http://schemas.microsoft.com/office/drawing/2014/main" id="{3CC9F9C7-0FAD-489F-5BDA-358860912C09}"/>
+                <a16:creationId xmlns:a16="http://schemas.microsoft.com/office/drawing/2014/main" id="{027C1179-5DDA-BEE3-44A8-7093FB1A22A5}"/>
               </a:ext>
             </a:extLst>
           </p:cNvPr>
@@ -6534,7 +5453,7 @@
           <p:cNvPr id="4" name="Rectangle: Rounded Corners 3">
             <a:extLst>
               <a:ext uri="{FF2B5EF4-FFF2-40B4-BE49-F238E27FC236}">
-                <a16:creationId xmlns:a16="http://schemas.microsoft.com/office/drawing/2014/main" id="{F6E7E8F9-56B0-1D8B-8238-911F02D013F6}"/>
+                <a16:creationId xmlns:a16="http://schemas.microsoft.com/office/drawing/2014/main" id="{D40CF04F-9775-EE45-7B5B-847EEACFC25B}"/>
               </a:ext>
             </a:extLst>
           </p:cNvPr>
@@ -6609,7 +5528,7 @@
           <p:cNvPr id="5" name="TextBox 4">
             <a:extLst>
               <a:ext uri="{FF2B5EF4-FFF2-40B4-BE49-F238E27FC236}">
-                <a16:creationId xmlns:a16="http://schemas.microsoft.com/office/drawing/2014/main" id="{D2C3DFCA-7D4B-D46D-7C43-89662F93A5E2}"/>
+                <a16:creationId xmlns:a16="http://schemas.microsoft.com/office/drawing/2014/main" id="{3DCD6433-64E9-92DE-9DCA-070A38DF5FD5}"/>
               </a:ext>
             </a:extLst>
           </p:cNvPr>
@@ -6648,7 +5567,7 @@
           <p:cNvPr id="6" name="Rectangle: Rounded Corners 5">
             <a:extLst>
               <a:ext uri="{FF2B5EF4-FFF2-40B4-BE49-F238E27FC236}">
-                <a16:creationId xmlns:a16="http://schemas.microsoft.com/office/drawing/2014/main" id="{BE78205D-7946-8E43-B20C-4337E1F011C2}"/>
+                <a16:creationId xmlns:a16="http://schemas.microsoft.com/office/drawing/2014/main" id="{BDA503D1-2642-E33E-AFEA-E92AAB0A5DBD}"/>
               </a:ext>
             </a:extLst>
           </p:cNvPr>
@@ -6704,73 +5623,48 @@
           </a:p>
         </p:txBody>
       </p:sp>
-      <p:sp>
-        <p:nvSpPr>
-          <p:cNvPr id="7" name="Rectangle: Rounded Corners 6">
-            <a:extLst>
-              <a:ext uri="{FF2B5EF4-FFF2-40B4-BE49-F238E27FC236}">
-                <a16:creationId xmlns:a16="http://schemas.microsoft.com/office/drawing/2014/main" id="{A7CFCA02-76DE-F0BA-66F8-6DEE39B535A4}"/>
-              </a:ext>
-            </a:extLst>
-          </p:cNvPr>
-          <p:cNvSpPr/>
-          <p:nvPr/>
-        </p:nvSpPr>
-        <p:spPr>
-          <a:xfrm>
-            <a:off x="11112500" y="88900"/>
-            <a:ext cx="825500" cy="431800"/>
-          </a:xfrm>
-          <a:prstGeom prst="roundRect">
-            <a:avLst/>
-          </a:prstGeom>
-          <a:solidFill>
-            <a:srgbClr val="FFFBEB"/>
-          </a:solidFill>
-          <a:ln w="19050">
-            <a:solidFill>
-              <a:srgbClr val="D97706"/>
-            </a:solidFill>
-          </a:ln>
-        </p:spPr>
-        <p:style>
-          <a:lnRef idx="2">
-            <a:schemeClr val="accent1">
-              <a:shade val="15000"/>
-            </a:schemeClr>
-          </a:lnRef>
-          <a:fillRef idx="1">
-            <a:schemeClr val="accent1"/>
-          </a:fillRef>
-          <a:effectRef idx="0">
-            <a:schemeClr val="accent1"/>
-          </a:effectRef>
-          <a:fontRef idx="minor">
-            <a:schemeClr val="lt1"/>
-          </a:fontRef>
-        </p:style>
-        <p:txBody>
-          <a:bodyPr rtlCol="0" anchor="ctr"/>
-          <a:lstStyle/>
-          <a:p>
-            <a:pPr algn="ctr"/>
-            <a:r>
-              <a:rPr lang="en-IN" sz="800" b="1">
-                <a:solidFill>
-                  <a:srgbClr val="D97706"/>
-                </a:solidFill>
-              </a:rPr>
-              <a:t>[SIH LOGO]</a:t>
-            </a:r>
-          </a:p>
-        </p:txBody>
-      </p:sp>
-      <p:sp>
-        <p:nvSpPr>
-          <p:cNvPr id="8" name="Rectangle: Rounded Corners 7">
-            <a:extLst>
-              <a:ext uri="{FF2B5EF4-FFF2-40B4-BE49-F238E27FC236}">
-                <a16:creationId xmlns:a16="http://schemas.microsoft.com/office/drawing/2014/main" id="{B641475B-FEF7-1058-98EE-93DC90191A75}"/>
+      <p:pic>
+        <p:nvPicPr>
+          <p:cNvPr id="8" name="Picture 7">
+            <a:extLst>
+              <a:ext uri="{FF2B5EF4-FFF2-40B4-BE49-F238E27FC236}">
+                <a16:creationId xmlns:a16="http://schemas.microsoft.com/office/drawing/2014/main" id="{EB4CEC91-9071-A377-E0E3-461D295640CA}"/>
+              </a:ext>
+            </a:extLst>
+          </p:cNvPr>
+          <p:cNvPicPr>
+            <a:picLocks/>
+          </p:cNvPicPr>
+          <p:nvPr/>
+        </p:nvPicPr>
+        <p:blipFill>
+          <a:blip r:embed="rId2">
+            <a:extLst>
+              <a:ext uri="{28A0092B-C50C-407E-A947-70E740481C1C}">
+                <a14:useLocalDpi xmlns:a14="http://schemas.microsoft.com/office/drawing/2010/main" val="0"/>
+              </a:ext>
+            </a:extLst>
+          </a:blip>
+          <a:stretch>
+            <a:fillRect/>
+          </a:stretch>
+        </p:blipFill>
+        <p:spPr>
+          <a:xfrm>
+            <a:off x="11023600" y="76200"/>
+            <a:ext cx="965200" cy="457200"/>
+          </a:xfrm>
+          <a:prstGeom prst="rect">
+            <a:avLst/>
+          </a:prstGeom>
+        </p:spPr>
+      </p:pic>
+      <p:sp>
+        <p:nvSpPr>
+          <p:cNvPr id="9" name="Rectangle: Rounded Corners 8">
+            <a:extLst>
+              <a:ext uri="{FF2B5EF4-FFF2-40B4-BE49-F238E27FC236}">
+                <a16:creationId xmlns:a16="http://schemas.microsoft.com/office/drawing/2014/main" id="{C70367D8-9C8A-5C53-8F40-DF37AFB78284}"/>
               </a:ext>
             </a:extLst>
           </p:cNvPr>
@@ -6821,10 +5715,10 @@
       </p:sp>
       <p:sp>
         <p:nvSpPr>
-          <p:cNvPr id="9" name="TextBox 8">
-            <a:extLst>
-              <a:ext uri="{FF2B5EF4-FFF2-40B4-BE49-F238E27FC236}">
-                <a16:creationId xmlns:a16="http://schemas.microsoft.com/office/drawing/2014/main" id="{46BAEE82-85BF-CB5D-D23E-E5E6296A4C7C}"/>
+          <p:cNvPr id="10" name="TextBox 9">
+            <a:extLst>
+              <a:ext uri="{FF2B5EF4-FFF2-40B4-BE49-F238E27FC236}">
+                <a16:creationId xmlns:a16="http://schemas.microsoft.com/office/drawing/2014/main" id="{F8192A28-2CE9-53D9-E0A6-59A62400A02E}"/>
               </a:ext>
             </a:extLst>
           </p:cNvPr>
@@ -6897,10 +5791,10 @@
       </p:sp>
       <p:sp>
         <p:nvSpPr>
-          <p:cNvPr id="10" name="Rectangle: Rounded Corners 9">
-            <a:extLst>
-              <a:ext uri="{FF2B5EF4-FFF2-40B4-BE49-F238E27FC236}">
-                <a16:creationId xmlns:a16="http://schemas.microsoft.com/office/drawing/2014/main" id="{28D65D7B-46D1-B10D-7B6A-EFB91C6A2253}"/>
+          <p:cNvPr id="11" name="Rectangle: Rounded Corners 10">
+            <a:extLst>
+              <a:ext uri="{FF2B5EF4-FFF2-40B4-BE49-F238E27FC236}">
+                <a16:creationId xmlns:a16="http://schemas.microsoft.com/office/drawing/2014/main" id="{F0F9D8BF-01BF-7FA4-5684-D21F5DA43275}"/>
               </a:ext>
             </a:extLst>
           </p:cNvPr>
@@ -6951,10 +5845,10 @@
       </p:sp>
       <p:sp>
         <p:nvSpPr>
-          <p:cNvPr id="11" name="TextBox 10">
-            <a:extLst>
-              <a:ext uri="{FF2B5EF4-FFF2-40B4-BE49-F238E27FC236}">
-                <a16:creationId xmlns:a16="http://schemas.microsoft.com/office/drawing/2014/main" id="{4FA63FD9-49BD-44BB-7DB8-47F282B75C68}"/>
+          <p:cNvPr id="12" name="TextBox 11">
+            <a:extLst>
+              <a:ext uri="{FF2B5EF4-FFF2-40B4-BE49-F238E27FC236}">
+                <a16:creationId xmlns:a16="http://schemas.microsoft.com/office/drawing/2014/main" id="{8A101E50-4FD1-7BD9-3124-F7D68E874E2D}"/>
               </a:ext>
             </a:extLst>
           </p:cNvPr>
@@ -7027,10 +5921,10 @@
       </p:sp>
       <p:sp>
         <p:nvSpPr>
-          <p:cNvPr id="12" name="Rectangle: Rounded Corners 11">
-            <a:extLst>
-              <a:ext uri="{FF2B5EF4-FFF2-40B4-BE49-F238E27FC236}">
-                <a16:creationId xmlns:a16="http://schemas.microsoft.com/office/drawing/2014/main" id="{C48CD63D-4F17-1E8A-EF6B-E171C3332277}"/>
+          <p:cNvPr id="13" name="Rectangle: Rounded Corners 12">
+            <a:extLst>
+              <a:ext uri="{FF2B5EF4-FFF2-40B4-BE49-F238E27FC236}">
+                <a16:creationId xmlns:a16="http://schemas.microsoft.com/office/drawing/2014/main" id="{58884802-D97D-5F12-0A12-885F24A97248}"/>
               </a:ext>
             </a:extLst>
           </p:cNvPr>
@@ -7081,10 +5975,10 @@
       </p:sp>
       <p:sp>
         <p:nvSpPr>
-          <p:cNvPr id="13" name="TextBox 12">
-            <a:extLst>
-              <a:ext uri="{FF2B5EF4-FFF2-40B4-BE49-F238E27FC236}">
-                <a16:creationId xmlns:a16="http://schemas.microsoft.com/office/drawing/2014/main" id="{4FE73A7A-6EAB-4C89-86A8-B05AFDDD7038}"/>
+          <p:cNvPr id="14" name="TextBox 13">
+            <a:extLst>
+              <a:ext uri="{FF2B5EF4-FFF2-40B4-BE49-F238E27FC236}">
+                <a16:creationId xmlns:a16="http://schemas.microsoft.com/office/drawing/2014/main" id="{E7D809D1-CD90-1090-9C8E-B8E797B97B34}"/>
               </a:ext>
             </a:extLst>
           </p:cNvPr>
@@ -7157,10 +6051,10 @@
       </p:sp>
       <p:sp>
         <p:nvSpPr>
-          <p:cNvPr id="14" name="Rectangle: Rounded Corners 13">
-            <a:extLst>
-              <a:ext uri="{FF2B5EF4-FFF2-40B4-BE49-F238E27FC236}">
-                <a16:creationId xmlns:a16="http://schemas.microsoft.com/office/drawing/2014/main" id="{861CA2B2-9585-49C1-53D6-2E23D74D8030}"/>
+          <p:cNvPr id="15" name="Rectangle: Rounded Corners 14">
+            <a:extLst>
+              <a:ext uri="{FF2B5EF4-FFF2-40B4-BE49-F238E27FC236}">
+                <a16:creationId xmlns:a16="http://schemas.microsoft.com/office/drawing/2014/main" id="{E55D5806-C3EA-DBC9-E75E-32C264166338}"/>
               </a:ext>
             </a:extLst>
           </p:cNvPr>
@@ -7211,10 +6105,10 @@
       </p:sp>
       <p:sp>
         <p:nvSpPr>
-          <p:cNvPr id="15" name="TextBox 14">
-            <a:extLst>
-              <a:ext uri="{FF2B5EF4-FFF2-40B4-BE49-F238E27FC236}">
-                <a16:creationId xmlns:a16="http://schemas.microsoft.com/office/drawing/2014/main" id="{C4AE4F48-9D6E-51AC-A0D8-A69EBAFADE1D}"/>
+          <p:cNvPr id="16" name="TextBox 15">
+            <a:extLst>
+              <a:ext uri="{FF2B5EF4-FFF2-40B4-BE49-F238E27FC236}">
+                <a16:creationId xmlns:a16="http://schemas.microsoft.com/office/drawing/2014/main" id="{599DB9BC-B829-5D43-DB2D-DDBD3CD155AE}"/>
               </a:ext>
             </a:extLst>
           </p:cNvPr>
@@ -7255,10 +6149,10 @@
       </p:sp>
       <p:sp>
         <p:nvSpPr>
-          <p:cNvPr id="16" name="Rectangle: Rounded Corners 15">
-            <a:extLst>
-              <a:ext uri="{FF2B5EF4-FFF2-40B4-BE49-F238E27FC236}">
-                <a16:creationId xmlns:a16="http://schemas.microsoft.com/office/drawing/2014/main" id="{BA811D64-D09B-87E2-0EE6-13661CA5974C}"/>
+          <p:cNvPr id="17" name="Rectangle: Rounded Corners 16">
+            <a:extLst>
+              <a:ext uri="{FF2B5EF4-FFF2-40B4-BE49-F238E27FC236}">
+                <a16:creationId xmlns:a16="http://schemas.microsoft.com/office/drawing/2014/main" id="{A334E204-7BA0-CA93-269B-CCA38163D022}"/>
               </a:ext>
             </a:extLst>
           </p:cNvPr>
@@ -7327,10 +6221,10 @@
       </p:sp>
       <p:sp>
         <p:nvSpPr>
-          <p:cNvPr id="17" name="Cylinder 16">
-            <a:extLst>
-              <a:ext uri="{FF2B5EF4-FFF2-40B4-BE49-F238E27FC236}">
-                <a16:creationId xmlns:a16="http://schemas.microsoft.com/office/drawing/2014/main" id="{F7605646-7255-2660-43DE-C1EFD4844A19}"/>
+          <p:cNvPr id="18" name="Cylinder 17">
+            <a:extLst>
+              <a:ext uri="{FF2B5EF4-FFF2-40B4-BE49-F238E27FC236}">
+                <a16:creationId xmlns:a16="http://schemas.microsoft.com/office/drawing/2014/main" id="{EE92322F-E89F-9067-0D53-915DDB8059C2}"/>
               </a:ext>
             </a:extLst>
           </p:cNvPr>
@@ -7395,10 +6289,10 @@
       </p:sp>
       <p:sp>
         <p:nvSpPr>
-          <p:cNvPr id="18" name="Rectangle: Rounded Corners 17">
-            <a:extLst>
-              <a:ext uri="{FF2B5EF4-FFF2-40B4-BE49-F238E27FC236}">
-                <a16:creationId xmlns:a16="http://schemas.microsoft.com/office/drawing/2014/main" id="{AAF09057-E36A-FC07-1D74-8644FA51D1D5}"/>
+          <p:cNvPr id="19" name="Rectangle: Rounded Corners 18">
+            <a:extLst>
+              <a:ext uri="{FF2B5EF4-FFF2-40B4-BE49-F238E27FC236}">
+                <a16:creationId xmlns:a16="http://schemas.microsoft.com/office/drawing/2014/main" id="{B009953D-B641-5ED0-ED14-811DFF04941B}"/>
               </a:ext>
             </a:extLst>
           </p:cNvPr>
@@ -7472,10 +6366,10 @@
       </p:sp>
       <p:sp>
         <p:nvSpPr>
-          <p:cNvPr id="19" name="Cylinder 18">
-            <a:extLst>
-              <a:ext uri="{FF2B5EF4-FFF2-40B4-BE49-F238E27FC236}">
-                <a16:creationId xmlns:a16="http://schemas.microsoft.com/office/drawing/2014/main" id="{B8C681F0-349D-6F42-DAEE-5B9A98E0939C}"/>
+          <p:cNvPr id="20" name="Cylinder 19">
+            <a:extLst>
+              <a:ext uri="{FF2B5EF4-FFF2-40B4-BE49-F238E27FC236}">
+                <a16:creationId xmlns:a16="http://schemas.microsoft.com/office/drawing/2014/main" id="{3D43097C-A994-412A-E3E5-340E8FA0FB26}"/>
               </a:ext>
             </a:extLst>
           </p:cNvPr>
@@ -7540,10 +6434,10 @@
       </p:sp>
       <p:sp>
         <p:nvSpPr>
-          <p:cNvPr id="20" name="Rectangle: Rounded Corners 19">
-            <a:extLst>
-              <a:ext uri="{FF2B5EF4-FFF2-40B4-BE49-F238E27FC236}">
-                <a16:creationId xmlns:a16="http://schemas.microsoft.com/office/drawing/2014/main" id="{A08E50AD-B7C2-CCE6-D57C-8AEFF23ADF17}"/>
+          <p:cNvPr id="21" name="Rectangle: Rounded Corners 20">
+            <a:extLst>
+              <a:ext uri="{FF2B5EF4-FFF2-40B4-BE49-F238E27FC236}">
+                <a16:creationId xmlns:a16="http://schemas.microsoft.com/office/drawing/2014/main" id="{D49ED2DF-9234-D115-F2A5-2BF0B0BECD4A}"/>
               </a:ext>
             </a:extLst>
           </p:cNvPr>
@@ -7617,10 +6511,10 @@
       </p:sp>
       <p:sp>
         <p:nvSpPr>
-          <p:cNvPr id="21" name="Cylinder 20">
-            <a:extLst>
-              <a:ext uri="{FF2B5EF4-FFF2-40B4-BE49-F238E27FC236}">
-                <a16:creationId xmlns:a16="http://schemas.microsoft.com/office/drawing/2014/main" id="{BBDB6642-9B0B-3180-6C0E-E12BEA46499B}"/>
+          <p:cNvPr id="22" name="Cylinder 21">
+            <a:extLst>
+              <a:ext uri="{FF2B5EF4-FFF2-40B4-BE49-F238E27FC236}">
+                <a16:creationId xmlns:a16="http://schemas.microsoft.com/office/drawing/2014/main" id="{9D7F81EE-36D8-4F4A-829B-A792912F040A}"/>
               </a:ext>
             </a:extLst>
           </p:cNvPr>
@@ -7685,10 +6579,10 @@
       </p:sp>
       <p:sp>
         <p:nvSpPr>
-          <p:cNvPr id="22" name="Rectangle: Rounded Corners 21">
-            <a:extLst>
-              <a:ext uri="{FF2B5EF4-FFF2-40B4-BE49-F238E27FC236}">
-                <a16:creationId xmlns:a16="http://schemas.microsoft.com/office/drawing/2014/main" id="{328504C0-F924-09CC-CB50-BF87D20E020B}"/>
+          <p:cNvPr id="23" name="Rectangle: Rounded Corners 22">
+            <a:extLst>
+              <a:ext uri="{FF2B5EF4-FFF2-40B4-BE49-F238E27FC236}">
+                <a16:creationId xmlns:a16="http://schemas.microsoft.com/office/drawing/2014/main" id="{1DFC7883-A17C-2549-2A8C-9E080CE3E2FC}"/>
               </a:ext>
             </a:extLst>
           </p:cNvPr>
@@ -7757,10 +6651,10 @@
       </p:sp>
       <p:sp>
         <p:nvSpPr>
-          <p:cNvPr id="23" name="Rectangle 22">
-            <a:extLst>
-              <a:ext uri="{FF2B5EF4-FFF2-40B4-BE49-F238E27FC236}">
-                <a16:creationId xmlns:a16="http://schemas.microsoft.com/office/drawing/2014/main" id="{4A20CB87-31E4-664B-4EBC-C4CB4F946BC8}"/>
+          <p:cNvPr id="24" name="Rectangle 23">
+            <a:extLst>
+              <a:ext uri="{FF2B5EF4-FFF2-40B4-BE49-F238E27FC236}">
+                <a16:creationId xmlns:a16="http://schemas.microsoft.com/office/drawing/2014/main" id="{F4DADD03-73BD-519B-D147-30B496670405}"/>
               </a:ext>
             </a:extLst>
           </p:cNvPr>
@@ -7811,10 +6705,10 @@
       </p:sp>
       <p:sp>
         <p:nvSpPr>
-          <p:cNvPr id="24" name="TextBox 23">
-            <a:extLst>
-              <a:ext uri="{FF2B5EF4-FFF2-40B4-BE49-F238E27FC236}">
-                <a16:creationId xmlns:a16="http://schemas.microsoft.com/office/drawing/2014/main" id="{FB67BDFD-E9A7-592F-9DC9-632BB6EE5ED0}"/>
+          <p:cNvPr id="25" name="TextBox 24">
+            <a:extLst>
+              <a:ext uri="{FF2B5EF4-FFF2-40B4-BE49-F238E27FC236}">
+                <a16:creationId xmlns:a16="http://schemas.microsoft.com/office/drawing/2014/main" id="{8D0D122A-2F0B-1036-B22E-498433F0F288}"/>
               </a:ext>
             </a:extLst>
           </p:cNvPr>
@@ -7851,7 +6745,7 @@
     </p:spTree>
     <p:extLst>
       <p:ext uri="{BB962C8B-B14F-4D97-AF65-F5344CB8AC3E}">
-        <p14:creationId xmlns:p14="http://schemas.microsoft.com/office/powerpoint/2010/main" val="491264120"/>
+        <p14:creationId xmlns:p14="http://schemas.microsoft.com/office/powerpoint/2010/main" val="4079586724"/>
       </p:ext>
     </p:extLst>
   </p:cSld>
@@ -7883,7 +6777,7 @@
           <p:cNvPr id="2" name="Rectangle 1">
             <a:extLst>
               <a:ext uri="{FF2B5EF4-FFF2-40B4-BE49-F238E27FC236}">
-                <a16:creationId xmlns:a16="http://schemas.microsoft.com/office/drawing/2014/main" id="{76770A4D-A76C-0F9B-F972-847DE8028DA7}"/>
+                <a16:creationId xmlns:a16="http://schemas.microsoft.com/office/drawing/2014/main" id="{DCFDC805-2774-C6E7-BDBD-995BB3F48677}"/>
               </a:ext>
             </a:extLst>
           </p:cNvPr>
@@ -7951,7 +6845,7 @@
           <p:cNvPr id="3" name="Rectangle 2">
             <a:extLst>
               <a:ext uri="{FF2B5EF4-FFF2-40B4-BE49-F238E27FC236}">
-                <a16:creationId xmlns:a16="http://schemas.microsoft.com/office/drawing/2014/main" id="{4DEB9605-141D-C736-25D8-61924FCA0D9F}"/>
+                <a16:creationId xmlns:a16="http://schemas.microsoft.com/office/drawing/2014/main" id="{3426F493-173A-1599-F8F5-60ECE8A65581}"/>
               </a:ext>
             </a:extLst>
           </p:cNvPr>
@@ -8005,7 +6899,7 @@
           <p:cNvPr id="4" name="Rectangle: Rounded Corners 3">
             <a:extLst>
               <a:ext uri="{FF2B5EF4-FFF2-40B4-BE49-F238E27FC236}">
-                <a16:creationId xmlns:a16="http://schemas.microsoft.com/office/drawing/2014/main" id="{AD4EA20F-1E1E-267C-43E5-CD44A0B59093}"/>
+                <a16:creationId xmlns:a16="http://schemas.microsoft.com/office/drawing/2014/main" id="{489CE31F-F88E-E1BA-4C45-2703BA2B489C}"/>
               </a:ext>
             </a:extLst>
           </p:cNvPr>
@@ -8080,7 +6974,7 @@
           <p:cNvPr id="5" name="TextBox 4">
             <a:extLst>
               <a:ext uri="{FF2B5EF4-FFF2-40B4-BE49-F238E27FC236}">
-                <a16:creationId xmlns:a16="http://schemas.microsoft.com/office/drawing/2014/main" id="{003E48AE-7CF7-CED7-1915-26AE957795B9}"/>
+                <a16:creationId xmlns:a16="http://schemas.microsoft.com/office/drawing/2014/main" id="{8420F810-02DF-208E-2E79-BDCFFF27FC7C}"/>
               </a:ext>
             </a:extLst>
           </p:cNvPr>
@@ -8124,7 +7018,7 @@
           <p:cNvPr id="6" name="Rectangle: Rounded Corners 5">
             <a:extLst>
               <a:ext uri="{FF2B5EF4-FFF2-40B4-BE49-F238E27FC236}">
-                <a16:creationId xmlns:a16="http://schemas.microsoft.com/office/drawing/2014/main" id="{7E37EFCB-9751-C8F9-F0BF-0F94A8455981}"/>
+                <a16:creationId xmlns:a16="http://schemas.microsoft.com/office/drawing/2014/main" id="{69BC7192-1BBB-9C83-BA93-4EDC070A8D2A}"/>
               </a:ext>
             </a:extLst>
           </p:cNvPr>
@@ -8180,73 +7074,48 @@
           </a:p>
         </p:txBody>
       </p:sp>
-      <p:sp>
-        <p:nvSpPr>
-          <p:cNvPr id="7" name="Rectangle: Rounded Corners 6">
-            <a:extLst>
-              <a:ext uri="{FF2B5EF4-FFF2-40B4-BE49-F238E27FC236}">
-                <a16:creationId xmlns:a16="http://schemas.microsoft.com/office/drawing/2014/main" id="{A3FBA3E2-81D0-2F76-EA6A-4D4948ADBAE5}"/>
-              </a:ext>
-            </a:extLst>
-          </p:cNvPr>
-          <p:cNvSpPr/>
-          <p:nvPr/>
-        </p:nvSpPr>
-        <p:spPr>
-          <a:xfrm>
-            <a:off x="11112500" y="88900"/>
-            <a:ext cx="825500" cy="431800"/>
-          </a:xfrm>
-          <a:prstGeom prst="roundRect">
-            <a:avLst/>
-          </a:prstGeom>
-          <a:solidFill>
-            <a:srgbClr val="FFFBEB"/>
-          </a:solidFill>
-          <a:ln w="19050">
-            <a:solidFill>
-              <a:srgbClr val="D97706"/>
-            </a:solidFill>
-          </a:ln>
-        </p:spPr>
-        <p:style>
-          <a:lnRef idx="2">
-            <a:schemeClr val="accent1">
-              <a:shade val="15000"/>
-            </a:schemeClr>
-          </a:lnRef>
-          <a:fillRef idx="1">
-            <a:schemeClr val="accent1"/>
-          </a:fillRef>
-          <a:effectRef idx="0">
-            <a:schemeClr val="accent1"/>
-          </a:effectRef>
-          <a:fontRef idx="minor">
-            <a:schemeClr val="lt1"/>
-          </a:fontRef>
-        </p:style>
-        <p:txBody>
-          <a:bodyPr rtlCol="0" anchor="ctr"/>
-          <a:lstStyle/>
-          <a:p>
-            <a:pPr algn="ctr"/>
-            <a:r>
-              <a:rPr lang="en-IN" sz="800" b="1">
-                <a:solidFill>
-                  <a:srgbClr val="D97706"/>
-                </a:solidFill>
-              </a:rPr>
-              <a:t>[SIH LOGO]</a:t>
-            </a:r>
-          </a:p>
-        </p:txBody>
-      </p:sp>
-      <p:sp>
-        <p:nvSpPr>
-          <p:cNvPr id="8" name="Rectangle: Rounded Corners 7">
-            <a:extLst>
-              <a:ext uri="{FF2B5EF4-FFF2-40B4-BE49-F238E27FC236}">
-                <a16:creationId xmlns:a16="http://schemas.microsoft.com/office/drawing/2014/main" id="{B5574050-B542-C027-9FDF-DCE9DE51E134}"/>
+      <p:pic>
+        <p:nvPicPr>
+          <p:cNvPr id="8" name="Picture 7">
+            <a:extLst>
+              <a:ext uri="{FF2B5EF4-FFF2-40B4-BE49-F238E27FC236}">
+                <a16:creationId xmlns:a16="http://schemas.microsoft.com/office/drawing/2014/main" id="{F15A0755-7CB4-E94C-973B-5EB72A9970BE}"/>
+              </a:ext>
+            </a:extLst>
+          </p:cNvPr>
+          <p:cNvPicPr>
+            <a:picLocks/>
+          </p:cNvPicPr>
+          <p:nvPr/>
+        </p:nvPicPr>
+        <p:blipFill>
+          <a:blip r:embed="rId2">
+            <a:extLst>
+              <a:ext uri="{28A0092B-C50C-407E-A947-70E740481C1C}">
+                <a14:useLocalDpi xmlns:a14="http://schemas.microsoft.com/office/drawing/2010/main" val="0"/>
+              </a:ext>
+            </a:extLst>
+          </a:blip>
+          <a:stretch>
+            <a:fillRect/>
+          </a:stretch>
+        </p:blipFill>
+        <p:spPr>
+          <a:xfrm>
+            <a:off x="11023600" y="76200"/>
+            <a:ext cx="965200" cy="457200"/>
+          </a:xfrm>
+          <a:prstGeom prst="rect">
+            <a:avLst/>
+          </a:prstGeom>
+        </p:spPr>
+      </p:pic>
+      <p:sp>
+        <p:nvSpPr>
+          <p:cNvPr id="9" name="Rectangle: Rounded Corners 8">
+            <a:extLst>
+              <a:ext uri="{FF2B5EF4-FFF2-40B4-BE49-F238E27FC236}">
+                <a16:creationId xmlns:a16="http://schemas.microsoft.com/office/drawing/2014/main" id="{D634764A-028F-FA95-9017-BB68667C8928}"/>
               </a:ext>
             </a:extLst>
           </p:cNvPr>
@@ -8297,10 +7166,10 @@
       </p:sp>
       <p:sp>
         <p:nvSpPr>
-          <p:cNvPr id="9" name="Rectangle: Rounded Corners 8">
-            <a:extLst>
-              <a:ext uri="{FF2B5EF4-FFF2-40B4-BE49-F238E27FC236}">
-                <a16:creationId xmlns:a16="http://schemas.microsoft.com/office/drawing/2014/main" id="{446A6AC1-7A66-8A17-55AF-6B08CF088CFE}"/>
+          <p:cNvPr id="10" name="Rectangle: Rounded Corners 9">
+            <a:extLst>
+              <a:ext uri="{FF2B5EF4-FFF2-40B4-BE49-F238E27FC236}">
+                <a16:creationId xmlns:a16="http://schemas.microsoft.com/office/drawing/2014/main" id="{03AAB0F6-28C3-5BC9-4F9E-EED06712391D}"/>
               </a:ext>
             </a:extLst>
           </p:cNvPr>
@@ -8374,10 +7243,10 @@
       </p:sp>
       <p:sp>
         <p:nvSpPr>
-          <p:cNvPr id="10" name="Cylinder 9">
-            <a:extLst>
-              <a:ext uri="{FF2B5EF4-FFF2-40B4-BE49-F238E27FC236}">
-                <a16:creationId xmlns:a16="http://schemas.microsoft.com/office/drawing/2014/main" id="{954CE19F-AAC9-4346-6C05-F2490EA60F61}"/>
+          <p:cNvPr id="11" name="Cylinder 10">
+            <a:extLst>
+              <a:ext uri="{FF2B5EF4-FFF2-40B4-BE49-F238E27FC236}">
+                <a16:creationId xmlns:a16="http://schemas.microsoft.com/office/drawing/2014/main" id="{E6EA5D75-D581-1578-9FB5-D7CA5D1CF0A8}"/>
               </a:ext>
             </a:extLst>
           </p:cNvPr>
@@ -8442,10 +7311,10 @@
       </p:sp>
       <p:sp>
         <p:nvSpPr>
-          <p:cNvPr id="11" name="Rectangle: Rounded Corners 10">
-            <a:extLst>
-              <a:ext uri="{FF2B5EF4-FFF2-40B4-BE49-F238E27FC236}">
-                <a16:creationId xmlns:a16="http://schemas.microsoft.com/office/drawing/2014/main" id="{D8C9C552-F543-C947-7E9E-BB686F8F4EC8}"/>
+          <p:cNvPr id="12" name="Rectangle: Rounded Corners 11">
+            <a:extLst>
+              <a:ext uri="{FF2B5EF4-FFF2-40B4-BE49-F238E27FC236}">
+                <a16:creationId xmlns:a16="http://schemas.microsoft.com/office/drawing/2014/main" id="{AEE2423A-2272-E2C6-6DCE-967ECC5DFC35}"/>
               </a:ext>
             </a:extLst>
           </p:cNvPr>
@@ -8514,10 +7383,10 @@
       </p:sp>
       <p:sp>
         <p:nvSpPr>
-          <p:cNvPr id="12" name="Rectangle: Rounded Corners 11">
-            <a:extLst>
-              <a:ext uri="{FF2B5EF4-FFF2-40B4-BE49-F238E27FC236}">
-                <a16:creationId xmlns:a16="http://schemas.microsoft.com/office/drawing/2014/main" id="{DD4E951E-0558-8573-F1B0-9A054FBC5107}"/>
+          <p:cNvPr id="13" name="Rectangle: Rounded Corners 12">
+            <a:extLst>
+              <a:ext uri="{FF2B5EF4-FFF2-40B4-BE49-F238E27FC236}">
+                <a16:creationId xmlns:a16="http://schemas.microsoft.com/office/drawing/2014/main" id="{1DBA560F-3EA9-AB3B-E4F3-897A0B7F5DF9}"/>
               </a:ext>
             </a:extLst>
           </p:cNvPr>
@@ -8568,10 +7437,10 @@
       </p:sp>
       <p:sp>
         <p:nvSpPr>
-          <p:cNvPr id="13" name="Rectangle: Rounded Corners 12">
-            <a:extLst>
-              <a:ext uri="{FF2B5EF4-FFF2-40B4-BE49-F238E27FC236}">
-                <a16:creationId xmlns:a16="http://schemas.microsoft.com/office/drawing/2014/main" id="{FF42C675-DB34-E6D8-0E6B-2CA53F04C7F6}"/>
+          <p:cNvPr id="14" name="Rectangle: Rounded Corners 13">
+            <a:extLst>
+              <a:ext uri="{FF2B5EF4-FFF2-40B4-BE49-F238E27FC236}">
+                <a16:creationId xmlns:a16="http://schemas.microsoft.com/office/drawing/2014/main" id="{01509520-81BA-D70C-5E0B-AE86AD7F0BB6}"/>
               </a:ext>
             </a:extLst>
           </p:cNvPr>
@@ -8645,10 +7514,10 @@
       </p:sp>
       <p:sp>
         <p:nvSpPr>
-          <p:cNvPr id="14" name="Cylinder 13">
-            <a:extLst>
-              <a:ext uri="{FF2B5EF4-FFF2-40B4-BE49-F238E27FC236}">
-                <a16:creationId xmlns:a16="http://schemas.microsoft.com/office/drawing/2014/main" id="{FD027D3A-FD79-0A34-24A3-85E837B0B42D}"/>
+          <p:cNvPr id="15" name="Cylinder 14">
+            <a:extLst>
+              <a:ext uri="{FF2B5EF4-FFF2-40B4-BE49-F238E27FC236}">
+                <a16:creationId xmlns:a16="http://schemas.microsoft.com/office/drawing/2014/main" id="{663A4935-CFF9-C572-B587-CBAD52236C61}"/>
               </a:ext>
             </a:extLst>
           </p:cNvPr>
@@ -8713,10 +7582,10 @@
       </p:sp>
       <p:sp>
         <p:nvSpPr>
-          <p:cNvPr id="15" name="Rectangle: Rounded Corners 14">
-            <a:extLst>
-              <a:ext uri="{FF2B5EF4-FFF2-40B4-BE49-F238E27FC236}">
-                <a16:creationId xmlns:a16="http://schemas.microsoft.com/office/drawing/2014/main" id="{90B0596B-F433-7D58-CE74-5AA1EFCF315A}"/>
+          <p:cNvPr id="16" name="Rectangle: Rounded Corners 15">
+            <a:extLst>
+              <a:ext uri="{FF2B5EF4-FFF2-40B4-BE49-F238E27FC236}">
+                <a16:creationId xmlns:a16="http://schemas.microsoft.com/office/drawing/2014/main" id="{3737D5C7-95D6-B3B1-9223-FC81C443D933}"/>
               </a:ext>
             </a:extLst>
           </p:cNvPr>
@@ -8790,10 +7659,10 @@
       </p:sp>
       <p:sp>
         <p:nvSpPr>
-          <p:cNvPr id="16" name="Rectangle: Rounded Corners 15">
-            <a:extLst>
-              <a:ext uri="{FF2B5EF4-FFF2-40B4-BE49-F238E27FC236}">
-                <a16:creationId xmlns:a16="http://schemas.microsoft.com/office/drawing/2014/main" id="{F3E815B2-243B-D367-64D0-20A05FCEF4C5}"/>
+          <p:cNvPr id="17" name="Rectangle: Rounded Corners 16">
+            <a:extLst>
+              <a:ext uri="{FF2B5EF4-FFF2-40B4-BE49-F238E27FC236}">
+                <a16:creationId xmlns:a16="http://schemas.microsoft.com/office/drawing/2014/main" id="{A4DB9A95-0121-89EA-EF8A-5BBDF1EBC6C3}"/>
               </a:ext>
             </a:extLst>
           </p:cNvPr>
@@ -8844,10 +7713,10 @@
       </p:sp>
       <p:sp>
         <p:nvSpPr>
-          <p:cNvPr id="17" name="Rectangle: Rounded Corners 16">
-            <a:extLst>
-              <a:ext uri="{FF2B5EF4-FFF2-40B4-BE49-F238E27FC236}">
-                <a16:creationId xmlns:a16="http://schemas.microsoft.com/office/drawing/2014/main" id="{9223D6F3-5241-CC31-B607-0F46B721A048}"/>
+          <p:cNvPr id="18" name="Rectangle: Rounded Corners 17">
+            <a:extLst>
+              <a:ext uri="{FF2B5EF4-FFF2-40B4-BE49-F238E27FC236}">
+                <a16:creationId xmlns:a16="http://schemas.microsoft.com/office/drawing/2014/main" id="{CCF0E516-C89A-4C68-68DC-5FEAC2671ABA}"/>
               </a:ext>
             </a:extLst>
           </p:cNvPr>
@@ -8921,10 +7790,10 @@
       </p:sp>
       <p:sp>
         <p:nvSpPr>
-          <p:cNvPr id="18" name="Cylinder 17">
-            <a:extLst>
-              <a:ext uri="{FF2B5EF4-FFF2-40B4-BE49-F238E27FC236}">
-                <a16:creationId xmlns:a16="http://schemas.microsoft.com/office/drawing/2014/main" id="{6476A197-591F-90C3-4713-85FA9BFCCE57}"/>
+          <p:cNvPr id="19" name="Cylinder 18">
+            <a:extLst>
+              <a:ext uri="{FF2B5EF4-FFF2-40B4-BE49-F238E27FC236}">
+                <a16:creationId xmlns:a16="http://schemas.microsoft.com/office/drawing/2014/main" id="{12680A62-411E-C63D-BE6B-B48DF168E997}"/>
               </a:ext>
             </a:extLst>
           </p:cNvPr>
@@ -8989,10 +7858,10 @@
       </p:sp>
       <p:sp>
         <p:nvSpPr>
-          <p:cNvPr id="19" name="Rectangle: Rounded Corners 18">
-            <a:extLst>
-              <a:ext uri="{FF2B5EF4-FFF2-40B4-BE49-F238E27FC236}">
-                <a16:creationId xmlns:a16="http://schemas.microsoft.com/office/drawing/2014/main" id="{C8753E6B-75A2-A638-D0E8-DAC30F0F9136}"/>
+          <p:cNvPr id="20" name="Rectangle: Rounded Corners 19">
+            <a:extLst>
+              <a:ext uri="{FF2B5EF4-FFF2-40B4-BE49-F238E27FC236}">
+                <a16:creationId xmlns:a16="http://schemas.microsoft.com/office/drawing/2014/main" id="{D2530AE8-59ED-73B0-12BD-356B85725FCD}"/>
               </a:ext>
             </a:extLst>
           </p:cNvPr>
@@ -9061,10 +7930,10 @@
       </p:sp>
       <p:sp>
         <p:nvSpPr>
-          <p:cNvPr id="20" name="Rectangle: Rounded Corners 19">
-            <a:extLst>
-              <a:ext uri="{FF2B5EF4-FFF2-40B4-BE49-F238E27FC236}">
-                <a16:creationId xmlns:a16="http://schemas.microsoft.com/office/drawing/2014/main" id="{7A954996-FBA4-F7C6-DA8E-612F947BAD87}"/>
+          <p:cNvPr id="21" name="Rectangle: Rounded Corners 20">
+            <a:extLst>
+              <a:ext uri="{FF2B5EF4-FFF2-40B4-BE49-F238E27FC236}">
+                <a16:creationId xmlns:a16="http://schemas.microsoft.com/office/drawing/2014/main" id="{7CCE21BE-1358-FF39-FBFC-D5750E7C74B8}"/>
               </a:ext>
             </a:extLst>
           </p:cNvPr>
@@ -9115,10 +7984,10 @@
       </p:sp>
       <p:sp>
         <p:nvSpPr>
-          <p:cNvPr id="21" name="Rectangle: Rounded Corners 20">
-            <a:extLst>
-              <a:ext uri="{FF2B5EF4-FFF2-40B4-BE49-F238E27FC236}">
-                <a16:creationId xmlns:a16="http://schemas.microsoft.com/office/drawing/2014/main" id="{9FE405C1-9596-19BF-966F-E2FBF7F0E7CB}"/>
+          <p:cNvPr id="22" name="Rectangle: Rounded Corners 21">
+            <a:extLst>
+              <a:ext uri="{FF2B5EF4-FFF2-40B4-BE49-F238E27FC236}">
+                <a16:creationId xmlns:a16="http://schemas.microsoft.com/office/drawing/2014/main" id="{BC077B59-662E-5A27-DA34-E8E5072E3BB4}"/>
               </a:ext>
             </a:extLst>
           </p:cNvPr>
@@ -9187,10 +8056,10 @@
       </p:sp>
       <p:sp>
         <p:nvSpPr>
-          <p:cNvPr id="22" name="Cylinder 21">
-            <a:extLst>
-              <a:ext uri="{FF2B5EF4-FFF2-40B4-BE49-F238E27FC236}">
-                <a16:creationId xmlns:a16="http://schemas.microsoft.com/office/drawing/2014/main" id="{F975E04E-8AE6-9CB7-C157-09547687B885}"/>
+          <p:cNvPr id="23" name="Cylinder 22">
+            <a:extLst>
+              <a:ext uri="{FF2B5EF4-FFF2-40B4-BE49-F238E27FC236}">
+                <a16:creationId xmlns:a16="http://schemas.microsoft.com/office/drawing/2014/main" id="{91CB2F28-C8FD-0E08-3367-11B67D6E57BD}"/>
               </a:ext>
             </a:extLst>
           </p:cNvPr>
@@ -9255,10 +8124,10 @@
       </p:sp>
       <p:sp>
         <p:nvSpPr>
-          <p:cNvPr id="23" name="Rectangle: Rounded Corners 22">
-            <a:extLst>
-              <a:ext uri="{FF2B5EF4-FFF2-40B4-BE49-F238E27FC236}">
-                <a16:creationId xmlns:a16="http://schemas.microsoft.com/office/drawing/2014/main" id="{93AB68EE-C1F6-0AF7-4935-638F7B7C5EA2}"/>
+          <p:cNvPr id="24" name="Rectangle: Rounded Corners 23">
+            <a:extLst>
+              <a:ext uri="{FF2B5EF4-FFF2-40B4-BE49-F238E27FC236}">
+                <a16:creationId xmlns:a16="http://schemas.microsoft.com/office/drawing/2014/main" id="{E6DF1E37-C3F5-9958-6940-794887F59B62}"/>
               </a:ext>
             </a:extLst>
           </p:cNvPr>
@@ -9332,10 +8201,10 @@
       </p:sp>
       <p:sp>
         <p:nvSpPr>
-          <p:cNvPr id="24" name="Rectangle: Rounded Corners 23">
-            <a:extLst>
-              <a:ext uri="{FF2B5EF4-FFF2-40B4-BE49-F238E27FC236}">
-                <a16:creationId xmlns:a16="http://schemas.microsoft.com/office/drawing/2014/main" id="{2F9E0DBA-12FC-A6C9-D784-7B1A6086DBBC}"/>
+          <p:cNvPr id="25" name="Rectangle: Rounded Corners 24">
+            <a:extLst>
+              <a:ext uri="{FF2B5EF4-FFF2-40B4-BE49-F238E27FC236}">
+                <a16:creationId xmlns:a16="http://schemas.microsoft.com/office/drawing/2014/main" id="{E7FA68BD-0F6A-824C-3D8F-F3A57B5083BB}"/>
               </a:ext>
             </a:extLst>
           </p:cNvPr>
@@ -9415,10 +8284,10 @@
       </p:sp>
       <p:sp>
         <p:nvSpPr>
-          <p:cNvPr id="25" name="Rectangle: Rounded Corners 24">
-            <a:extLst>
-              <a:ext uri="{FF2B5EF4-FFF2-40B4-BE49-F238E27FC236}">
-                <a16:creationId xmlns:a16="http://schemas.microsoft.com/office/drawing/2014/main" id="{5FE9C27B-8B7B-ED52-E1F5-5B05FC4C09D2}"/>
+          <p:cNvPr id="26" name="Rectangle: Rounded Corners 25">
+            <a:extLst>
+              <a:ext uri="{FF2B5EF4-FFF2-40B4-BE49-F238E27FC236}">
+                <a16:creationId xmlns:a16="http://schemas.microsoft.com/office/drawing/2014/main" id="{E379B5D8-7388-C7D3-1BE1-1B853418A9FE}"/>
               </a:ext>
             </a:extLst>
           </p:cNvPr>
@@ -9503,10 +8372,10 @@
       </p:sp>
       <p:sp>
         <p:nvSpPr>
-          <p:cNvPr id="26" name="Rectangle 25">
-            <a:extLst>
-              <a:ext uri="{FF2B5EF4-FFF2-40B4-BE49-F238E27FC236}">
-                <a16:creationId xmlns:a16="http://schemas.microsoft.com/office/drawing/2014/main" id="{1866684F-C0D9-0EEB-71BE-28D27121AB9F}"/>
+          <p:cNvPr id="27" name="Rectangle 26">
+            <a:extLst>
+              <a:ext uri="{FF2B5EF4-FFF2-40B4-BE49-F238E27FC236}">
+                <a16:creationId xmlns:a16="http://schemas.microsoft.com/office/drawing/2014/main" id="{4322099E-E256-E89E-F027-B4DDC118A854}"/>
               </a:ext>
             </a:extLst>
           </p:cNvPr>
@@ -9557,10 +8426,10 @@
       </p:sp>
       <p:sp>
         <p:nvSpPr>
-          <p:cNvPr id="27" name="TextBox 26">
-            <a:extLst>
-              <a:ext uri="{FF2B5EF4-FFF2-40B4-BE49-F238E27FC236}">
-                <a16:creationId xmlns:a16="http://schemas.microsoft.com/office/drawing/2014/main" id="{61CEA524-134D-2247-9497-CF7C71F23A67}"/>
+          <p:cNvPr id="28" name="TextBox 27">
+            <a:extLst>
+              <a:ext uri="{FF2B5EF4-FFF2-40B4-BE49-F238E27FC236}">
+                <a16:creationId xmlns:a16="http://schemas.microsoft.com/office/drawing/2014/main" id="{3AAED1EA-F808-7AC4-8528-DD43824B7606}"/>
               </a:ext>
             </a:extLst>
           </p:cNvPr>
@@ -9602,7 +8471,7 @@
     </p:spTree>
     <p:extLst>
       <p:ext uri="{BB962C8B-B14F-4D97-AF65-F5344CB8AC3E}">
-        <p14:creationId xmlns:p14="http://schemas.microsoft.com/office/powerpoint/2010/main" val="652655885"/>
+        <p14:creationId xmlns:p14="http://schemas.microsoft.com/office/powerpoint/2010/main" val="46332135"/>
       </p:ext>
     </p:extLst>
   </p:cSld>
@@ -9634,7 +8503,7 @@
           <p:cNvPr id="2" name="Rectangle 1">
             <a:extLst>
               <a:ext uri="{FF2B5EF4-FFF2-40B4-BE49-F238E27FC236}">
-                <a16:creationId xmlns:a16="http://schemas.microsoft.com/office/drawing/2014/main" id="{3B432D98-3687-0EE1-0C2E-CB09BDB0DF0B}"/>
+                <a16:creationId xmlns:a16="http://schemas.microsoft.com/office/drawing/2014/main" id="{DB000028-9567-9C27-C29D-B3FE2C122D47}"/>
               </a:ext>
             </a:extLst>
           </p:cNvPr>
@@ -9702,7 +8571,7 @@
           <p:cNvPr id="3" name="Rectangle 2">
             <a:extLst>
               <a:ext uri="{FF2B5EF4-FFF2-40B4-BE49-F238E27FC236}">
-                <a16:creationId xmlns:a16="http://schemas.microsoft.com/office/drawing/2014/main" id="{668416B7-CC42-3769-05B1-B6359E8BB75B}"/>
+                <a16:creationId xmlns:a16="http://schemas.microsoft.com/office/drawing/2014/main" id="{1B72B947-C8C3-5EE4-9980-A73CD53A5542}"/>
               </a:ext>
             </a:extLst>
           </p:cNvPr>
@@ -9756,7 +8625,7 @@
           <p:cNvPr id="4" name="Rectangle: Rounded Corners 3">
             <a:extLst>
               <a:ext uri="{FF2B5EF4-FFF2-40B4-BE49-F238E27FC236}">
-                <a16:creationId xmlns:a16="http://schemas.microsoft.com/office/drawing/2014/main" id="{458E03D6-2DEB-B74C-7DBD-8B29AFF77910}"/>
+                <a16:creationId xmlns:a16="http://schemas.microsoft.com/office/drawing/2014/main" id="{9AEA2B46-AFA0-B3DD-A22E-0DF6B47F654C}"/>
               </a:ext>
             </a:extLst>
           </p:cNvPr>
@@ -9831,7 +8700,7 @@
           <p:cNvPr id="5" name="TextBox 4">
             <a:extLst>
               <a:ext uri="{FF2B5EF4-FFF2-40B4-BE49-F238E27FC236}">
-                <a16:creationId xmlns:a16="http://schemas.microsoft.com/office/drawing/2014/main" id="{FB1596BA-EDAF-5143-25E1-97136295D7ED}"/>
+                <a16:creationId xmlns:a16="http://schemas.microsoft.com/office/drawing/2014/main" id="{1A2B272A-C59E-032B-B36D-D8EE3630F923}"/>
               </a:ext>
             </a:extLst>
           </p:cNvPr>
@@ -9870,7 +8739,7 @@
           <p:cNvPr id="6" name="Rectangle: Rounded Corners 5">
             <a:extLst>
               <a:ext uri="{FF2B5EF4-FFF2-40B4-BE49-F238E27FC236}">
-                <a16:creationId xmlns:a16="http://schemas.microsoft.com/office/drawing/2014/main" id="{588E8378-5ACB-00D2-C78D-51471C6EE74F}"/>
+                <a16:creationId xmlns:a16="http://schemas.microsoft.com/office/drawing/2014/main" id="{404FE68B-3966-FE5A-BF82-5CDAAC44887A}"/>
               </a:ext>
             </a:extLst>
           </p:cNvPr>
@@ -9926,12 +8795,48 @@
           </a:p>
         </p:txBody>
       </p:sp>
-      <p:sp>
-        <p:nvSpPr>
-          <p:cNvPr id="7" name="Rectangle: Rounded Corners 6">
-            <a:extLst>
-              <a:ext uri="{FF2B5EF4-FFF2-40B4-BE49-F238E27FC236}">
-                <a16:creationId xmlns:a16="http://schemas.microsoft.com/office/drawing/2014/main" id="{A9CD862A-063D-9148-8222-66EB3D51A066}"/>
+      <p:pic>
+        <p:nvPicPr>
+          <p:cNvPr id="8" name="Picture 7">
+            <a:extLst>
+              <a:ext uri="{FF2B5EF4-FFF2-40B4-BE49-F238E27FC236}">
+                <a16:creationId xmlns:a16="http://schemas.microsoft.com/office/drawing/2014/main" id="{33BCFF95-9A2E-7346-28DD-D66AA406FCD0}"/>
+              </a:ext>
+            </a:extLst>
+          </p:cNvPr>
+          <p:cNvPicPr>
+            <a:picLocks/>
+          </p:cNvPicPr>
+          <p:nvPr/>
+        </p:nvPicPr>
+        <p:blipFill>
+          <a:blip r:embed="rId2">
+            <a:extLst>
+              <a:ext uri="{28A0092B-C50C-407E-A947-70E740481C1C}">
+                <a14:useLocalDpi xmlns:a14="http://schemas.microsoft.com/office/drawing/2010/main" val="0"/>
+              </a:ext>
+            </a:extLst>
+          </a:blip>
+          <a:stretch>
+            <a:fillRect/>
+          </a:stretch>
+        </p:blipFill>
+        <p:spPr>
+          <a:xfrm>
+            <a:off x="11023600" y="76200"/>
+            <a:ext cx="965200" cy="457200"/>
+          </a:xfrm>
+          <a:prstGeom prst="rect">
+            <a:avLst/>
+          </a:prstGeom>
+        </p:spPr>
+      </p:pic>
+      <p:sp>
+        <p:nvSpPr>
+          <p:cNvPr id="9" name="Rectangle: Rounded Corners 8">
+            <a:extLst>
+              <a:ext uri="{FF2B5EF4-FFF2-40B4-BE49-F238E27FC236}">
+                <a16:creationId xmlns:a16="http://schemas.microsoft.com/office/drawing/2014/main" id="{E297A401-89C6-FDEC-793D-B7AC0BED86ED}"/>
               </a:ext>
             </a:extLst>
           </p:cNvPr>
@@ -9940,8 +8845,131 @@
         </p:nvSpPr>
         <p:spPr>
           <a:xfrm>
-            <a:off x="11112500" y="88900"/>
-            <a:ext cx="825500" cy="431800"/>
+            <a:off x="254000" y="736600"/>
+            <a:ext cx="6096000" cy="1193800"/>
+          </a:xfrm>
+          <a:prstGeom prst="roundRect">
+            <a:avLst/>
+          </a:prstGeom>
+          <a:solidFill>
+            <a:srgbClr val="FFF1F2"/>
+          </a:solidFill>
+          <a:ln w="19050">
+            <a:solidFill>
+              <a:srgbClr val="E11D48"/>
+            </a:solidFill>
+          </a:ln>
+        </p:spPr>
+        <p:style>
+          <a:lnRef idx="2">
+            <a:schemeClr val="accent1">
+              <a:shade val="15000"/>
+            </a:schemeClr>
+          </a:lnRef>
+          <a:fillRef idx="1">
+            <a:schemeClr val="accent1"/>
+          </a:fillRef>
+          <a:effectRef idx="0">
+            <a:schemeClr val="accent1"/>
+          </a:effectRef>
+          <a:fontRef idx="minor">
+            <a:schemeClr val="lt1"/>
+          </a:fontRef>
+        </p:style>
+        <p:txBody>
+          <a:bodyPr rtlCol="0" anchor="ctr"/>
+          <a:lstStyle/>
+          <a:p>
+            <a:pPr algn="ctr"/>
+            <a:endParaRPr lang="en-IN"/>
+          </a:p>
+        </p:txBody>
+      </p:sp>
+      <p:sp>
+        <p:nvSpPr>
+          <p:cNvPr id="10" name="TextBox 9">
+            <a:extLst>
+              <a:ext uri="{FF2B5EF4-FFF2-40B4-BE49-F238E27FC236}">
+                <a16:creationId xmlns:a16="http://schemas.microsoft.com/office/drawing/2014/main" id="{7C8D6279-246B-561D-8632-43BC70CD935A}"/>
+              </a:ext>
+            </a:extLst>
+          </p:cNvPr>
+          <p:cNvSpPr txBox="1"/>
+          <p:nvPr/>
+        </p:nvSpPr>
+        <p:spPr>
+          <a:xfrm>
+            <a:off x="355600" y="787400"/>
+            <a:ext cx="5892800" cy="661720"/>
+          </a:xfrm>
+          <a:prstGeom prst="rect">
+            <a:avLst/>
+          </a:prstGeom>
+          <a:noFill/>
+        </p:spPr>
+        <p:txBody>
+          <a:bodyPr vert="horz" rtlCol="0">
+            <a:spAutoFit/>
+          </a:bodyPr>
+          <a:lstStyle/>
+          <a:p>
+            <a:r>
+              <a:rPr lang="en-IN" sz="1150" b="1">
+                <a:solidFill>
+                  <a:srgbClr val="E11D48"/>
+                </a:solidFill>
+              </a:rPr>
+              <a:t>❤️ Social &amp; Life-Saving</a:t>
+            </a:r>
+          </a:p>
+          <a:p>
+            <a:r>
+              <a:rPr lang="en-IN" sz="850">
+                <a:solidFill>
+                  <a:srgbClr val="1E3347"/>
+                </a:solidFill>
+              </a:rPr>
+              <a:t>• Zero First-Responder Loss: Eliminates sniffer dog &amp; rescuer hazards.</a:t>
+            </a:r>
+          </a:p>
+          <a:p>
+            <a:r>
+              <a:rPr lang="en-IN" sz="850">
+                <a:solidFill>
+                  <a:srgbClr val="1E3347"/>
+                </a:solidFill>
+              </a:rPr>
+              <a:t>• Golden Hour Acceleration: Spots trapped survivors in minutes via thermal vision.</a:t>
+            </a:r>
+          </a:p>
+          <a:p>
+            <a:r>
+              <a:rPr lang="en-IN" sz="850">
+                <a:solidFill>
+                  <a:srgbClr val="1E3347"/>
+                </a:solidFill>
+              </a:rPr>
+              <a:t>• Pre-Staged Medical Triage: Medics receive SpO2 &amp; pulse before physical entry.</a:t>
+            </a:r>
+          </a:p>
+        </p:txBody>
+      </p:sp>
+      <p:sp>
+        <p:nvSpPr>
+          <p:cNvPr id="11" name="Rectangle: Rounded Corners 10">
+            <a:extLst>
+              <a:ext uri="{FF2B5EF4-FFF2-40B4-BE49-F238E27FC236}">
+                <a16:creationId xmlns:a16="http://schemas.microsoft.com/office/drawing/2014/main" id="{946C3F12-C936-CA98-1AB6-9BE31FC00160}"/>
+              </a:ext>
+            </a:extLst>
+          </p:cNvPr>
+          <p:cNvSpPr/>
+          <p:nvPr/>
+        </p:nvSpPr>
+        <p:spPr>
+          <a:xfrm>
+            <a:off x="254000" y="2032000"/>
+            <a:ext cx="6096000" cy="1193800"/>
           </a:xfrm>
           <a:prstGeom prst="roundRect">
             <a:avLst/>
@@ -9976,23 +9004,85 @@
           <a:lstStyle/>
           <a:p>
             <a:pPr algn="ctr"/>
-            <a:r>
-              <a:rPr lang="en-IN" sz="800" b="1">
+            <a:endParaRPr lang="en-IN"/>
+          </a:p>
+        </p:txBody>
+      </p:sp>
+      <p:sp>
+        <p:nvSpPr>
+          <p:cNvPr id="12" name="TextBox 11">
+            <a:extLst>
+              <a:ext uri="{FF2B5EF4-FFF2-40B4-BE49-F238E27FC236}">
+                <a16:creationId xmlns:a16="http://schemas.microsoft.com/office/drawing/2014/main" id="{A5845202-25E8-5704-A11E-CC1C2AB4D460}"/>
+              </a:ext>
+            </a:extLst>
+          </p:cNvPr>
+          <p:cNvSpPr txBox="1"/>
+          <p:nvPr/>
+        </p:nvSpPr>
+        <p:spPr>
+          <a:xfrm>
+            <a:off x="355600" y="2082800"/>
+            <a:ext cx="5892800" cy="661720"/>
+          </a:xfrm>
+          <a:prstGeom prst="rect">
+            <a:avLst/>
+          </a:prstGeom>
+          <a:noFill/>
+        </p:spPr>
+        <p:txBody>
+          <a:bodyPr vert="horz" rtlCol="0">
+            <a:spAutoFit/>
+          </a:bodyPr>
+          <a:lstStyle/>
+          <a:p>
+            <a:r>
+              <a:rPr lang="en-IN" sz="1150" b="1">
                 <a:solidFill>
                   <a:srgbClr val="D97706"/>
                 </a:solidFill>
               </a:rPr>
-              <a:t>[SIH LOGO]</a:t>
-            </a:r>
-          </a:p>
-        </p:txBody>
-      </p:sp>
-      <p:sp>
-        <p:nvSpPr>
-          <p:cNvPr id="8" name="Rectangle: Rounded Corners 7">
-            <a:extLst>
-              <a:ext uri="{FF2B5EF4-FFF2-40B4-BE49-F238E27FC236}">
-                <a16:creationId xmlns:a16="http://schemas.microsoft.com/office/drawing/2014/main" id="{2988E8ED-3017-06DA-58C0-DDE49E58C588}"/>
+              <a:t>💰 Economic Democratization</a:t>
+            </a:r>
+          </a:p>
+          <a:p>
+            <a:r>
+              <a:rPr lang="en-IN" sz="850">
+                <a:solidFill>
+                  <a:srgbClr val="1E3347"/>
+                </a:solidFill>
+              </a:rPr>
+              <a:t>• 10x-20x Cost Reduction: Under ₹50,000 INR vs ₹25-40 Lakhs imported robots.</a:t>
+            </a:r>
+          </a:p>
+          <a:p>
+            <a:r>
+              <a:rPr lang="en-IN" sz="850">
+                <a:solidFill>
+                  <a:srgbClr val="1E3347"/>
+                </a:solidFill>
+              </a:rPr>
+              <a:t>• COTS Modular Maintenance: Standard parts, zero foreign service lock-in.</a:t>
+            </a:r>
+          </a:p>
+          <a:p>
+            <a:r>
+              <a:rPr lang="en-IN" sz="850">
+                <a:solidFill>
+                  <a:srgbClr val="1E3347"/>
+                </a:solidFill>
+              </a:rPr>
+              <a:t>• Scalable Pan-India Outreach: Affordable for every municipal fire station.</a:t>
+            </a:r>
+          </a:p>
+        </p:txBody>
+      </p:sp>
+      <p:sp>
+        <p:nvSpPr>
+          <p:cNvPr id="13" name="Rectangle: Rounded Corners 12">
+            <a:extLst>
+              <a:ext uri="{FF2B5EF4-FFF2-40B4-BE49-F238E27FC236}">
+                <a16:creationId xmlns:a16="http://schemas.microsoft.com/office/drawing/2014/main" id="{9897CF09-2489-320C-1B2D-043A942CF065}"/>
               </a:ext>
             </a:extLst>
           </p:cNvPr>
@@ -10001,18 +9091,18 @@
         </p:nvSpPr>
         <p:spPr>
           <a:xfrm>
-            <a:off x="254000" y="736600"/>
+            <a:off x="254000" y="3327400"/>
             <a:ext cx="6096000" cy="1193800"/>
           </a:xfrm>
           <a:prstGeom prst="roundRect">
             <a:avLst/>
           </a:prstGeom>
           <a:solidFill>
-            <a:srgbClr val="FFF1F2"/>
+            <a:srgbClr val="ECFDF5"/>
           </a:solidFill>
           <a:ln w="19050">
             <a:solidFill>
-              <a:srgbClr val="E11D48"/>
+              <a:srgbClr val="059669"/>
             </a:solidFill>
           </a:ln>
         </p:spPr>
@@ -10043,10 +9133,10 @@
       </p:sp>
       <p:sp>
         <p:nvSpPr>
-          <p:cNvPr id="9" name="TextBox 8">
-            <a:extLst>
-              <a:ext uri="{FF2B5EF4-FFF2-40B4-BE49-F238E27FC236}">
-                <a16:creationId xmlns:a16="http://schemas.microsoft.com/office/drawing/2014/main" id="{172FAE1B-7D5F-C255-BD31-D37E21A5E6BE}"/>
+          <p:cNvPr id="14" name="TextBox 13">
+            <a:extLst>
+              <a:ext uri="{FF2B5EF4-FFF2-40B4-BE49-F238E27FC236}">
+                <a16:creationId xmlns:a16="http://schemas.microsoft.com/office/drawing/2014/main" id="{EE0E44B1-053F-D60B-3EB2-F37BF2F39648}"/>
               </a:ext>
             </a:extLst>
           </p:cNvPr>
@@ -10055,7 +9145,7 @@
         </p:nvSpPr>
         <p:spPr>
           <a:xfrm>
-            <a:off x="355600" y="787400"/>
+            <a:off x="355600" y="3378200"/>
             <a:ext cx="5892800" cy="661720"/>
           </a:xfrm>
           <a:prstGeom prst="rect">
@@ -10072,10 +9162,10 @@
             <a:r>
               <a:rPr lang="en-IN" sz="1150" b="1">
                 <a:solidFill>
-                  <a:srgbClr val="E11D48"/>
-                </a:solidFill>
-              </a:rPr>
-              <a:t>❤️ Social &amp; Life-Saving</a:t>
+                  <a:srgbClr val="059669"/>
+                </a:solidFill>
+              </a:rPr>
+              <a:t>🌱 Environmental &amp; Mine Safety</a:t>
             </a:r>
           </a:p>
           <a:p>
@@ -10085,7 +9175,7 @@
                   <a:srgbClr val="1E3347"/>
                 </a:solidFill>
               </a:rPr>
-              <a:t>• Zero First-Responder Loss: Eliminates sniffer dog &amp; rescuer hazards.</a:t>
+              <a:t>• Real-Time Hazard Containment: MQ-135 tracks gas diffusion before civilian impact.</a:t>
             </a:r>
           </a:p>
           <a:p>
@@ -10095,7 +9185,7 @@
                   <a:srgbClr val="1E3347"/>
                 </a:solidFill>
               </a:rPr>
-              <a:t>• Golden Hour Acceleration: Spots trapped survivors in minutes via thermal vision.</a:t>
+              <a:t>• Zero-Emission Electric Locomotion: Safe in combustible &amp; low-oxygen shafts.</a:t>
             </a:r>
           </a:p>
           <a:p>
@@ -10105,17 +9195,58 @@
                   <a:srgbClr val="1E3347"/>
                 </a:solidFill>
               </a:rPr>
-              <a:t>• Pre-Staged Medical Triage: Medics receive SpO2 &amp; pulse before physical entry.</a:t>
-            </a:r>
-          </a:p>
-        </p:txBody>
-      </p:sp>
-      <p:sp>
-        <p:nvSpPr>
-          <p:cNvPr id="10" name="Rectangle: Rounded Corners 9">
-            <a:extLst>
-              <a:ext uri="{FF2B5EF4-FFF2-40B4-BE49-F238E27FC236}">
-                <a16:creationId xmlns:a16="http://schemas.microsoft.com/office/drawing/2014/main" id="{2FB8F9CF-128A-56B4-8A91-A28295384EFE}"/>
+              <a:t>• Deep Underground Recon: Safe for subterranean tunnels and coal mines.</a:t>
+            </a:r>
+          </a:p>
+        </p:txBody>
+      </p:sp>
+      <p:pic>
+        <p:nvPicPr>
+          <p:cNvPr id="16" name="Picture 15">
+            <a:extLst>
+              <a:ext uri="{FF2B5EF4-FFF2-40B4-BE49-F238E27FC236}">
+                <a16:creationId xmlns:a16="http://schemas.microsoft.com/office/drawing/2014/main" id="{003A2C86-2A95-5D5B-FC8C-D6847519D646}"/>
+              </a:ext>
+            </a:extLst>
+          </p:cNvPr>
+          <p:cNvPicPr>
+            <a:picLocks/>
+          </p:cNvPicPr>
+          <p:nvPr/>
+        </p:nvPicPr>
+        <p:blipFill>
+          <a:blip r:embed="rId3">
+            <a:extLst>
+              <a:ext uri="{28A0092B-C50C-407E-A947-70E740481C1C}">
+                <a14:useLocalDpi xmlns:a14="http://schemas.microsoft.com/office/drawing/2010/main" val="0"/>
+              </a:ext>
+            </a:extLst>
+          </a:blip>
+          <a:stretch>
+            <a:fillRect/>
+          </a:stretch>
+        </p:blipFill>
+        <p:spPr>
+          <a:xfrm>
+            <a:off x="6540500" y="736600"/>
+            <a:ext cx="5397500" cy="3810000"/>
+          </a:xfrm>
+          <a:prstGeom prst="rect">
+            <a:avLst/>
+          </a:prstGeom>
+          <a:ln w="25400">
+            <a:solidFill>
+              <a:schemeClr val="tx1"/>
+            </a:solidFill>
+          </a:ln>
+        </p:spPr>
+      </p:pic>
+      <p:sp>
+        <p:nvSpPr>
+          <p:cNvPr id="17" name="Rectangle: Rounded Corners 16">
+            <a:extLst>
+              <a:ext uri="{FF2B5EF4-FFF2-40B4-BE49-F238E27FC236}">
+                <a16:creationId xmlns:a16="http://schemas.microsoft.com/office/drawing/2014/main" id="{4EF2AFE5-C9E5-51B6-48B1-D330A75BE3DA}"/>
               </a:ext>
             </a:extLst>
           </p:cNvPr>
@@ -10124,8 +9255,162 @@
         </p:nvSpPr>
         <p:spPr>
           <a:xfrm>
-            <a:off x="254000" y="2032000"/>
-            <a:ext cx="6096000" cy="1193800"/>
+            <a:off x="254000" y="4699000"/>
+            <a:ext cx="2819400" cy="1333500"/>
+          </a:xfrm>
+          <a:prstGeom prst="roundRect">
+            <a:avLst/>
+          </a:prstGeom>
+          <a:solidFill>
+            <a:srgbClr val="F0F9FF"/>
+          </a:solidFill>
+          <a:ln w="19050">
+            <a:solidFill>
+              <a:srgbClr val="0284C7"/>
+            </a:solidFill>
+          </a:ln>
+        </p:spPr>
+        <p:style>
+          <a:lnRef idx="2">
+            <a:schemeClr val="accent1">
+              <a:shade val="15000"/>
+            </a:schemeClr>
+          </a:lnRef>
+          <a:fillRef idx="1">
+            <a:schemeClr val="accent1"/>
+          </a:fillRef>
+          <a:effectRef idx="0">
+            <a:schemeClr val="accent1"/>
+          </a:effectRef>
+          <a:fontRef idx="minor">
+            <a:schemeClr val="lt1"/>
+          </a:fontRef>
+        </p:style>
+        <p:txBody>
+          <a:bodyPr rtlCol="0" anchor="ctr"/>
+          <a:lstStyle/>
+          <a:p>
+            <a:pPr algn="ctr"/>
+            <a:r>
+              <a:rPr lang="en-US" sz="1050" b="1">
+                <a:solidFill>
+                  <a:srgbClr val="0284C7"/>
+                </a:solidFill>
+              </a:rPr>
+              <a:t>🏛️ NDRF &amp; State SDRF</a:t>
+            </a:r>
+          </a:p>
+          <a:p>
+            <a:pPr algn="ctr"/>
+            <a:r>
+              <a:rPr lang="en-US" sz="850">
+                <a:solidFill>
+                  <a:srgbClr val="1E3347"/>
+                </a:solidFill>
+              </a:rPr>
+              <a:t>Earthquake &amp; building collapses</a:t>
+            </a:r>
+            <a:endParaRPr lang="en-IN" sz="850">
+              <a:solidFill>
+                <a:srgbClr val="1E3347"/>
+              </a:solidFill>
+            </a:endParaRPr>
+          </a:p>
+        </p:txBody>
+      </p:sp>
+      <p:sp>
+        <p:nvSpPr>
+          <p:cNvPr id="18" name="Rectangle: Rounded Corners 17">
+            <a:extLst>
+              <a:ext uri="{FF2B5EF4-FFF2-40B4-BE49-F238E27FC236}">
+                <a16:creationId xmlns:a16="http://schemas.microsoft.com/office/drawing/2014/main" id="{EFEDB085-7A41-3348-53F3-3BFDCF70A1D5}"/>
+              </a:ext>
+            </a:extLst>
+          </p:cNvPr>
+          <p:cNvSpPr/>
+          <p:nvPr/>
+        </p:nvSpPr>
+        <p:spPr>
+          <a:xfrm>
+            <a:off x="3200400" y="4699000"/>
+            <a:ext cx="2819400" cy="1333500"/>
+          </a:xfrm>
+          <a:prstGeom prst="roundRect">
+            <a:avLst/>
+          </a:prstGeom>
+          <a:solidFill>
+            <a:srgbClr val="FEF2F2"/>
+          </a:solidFill>
+          <a:ln w="19050">
+            <a:solidFill>
+              <a:srgbClr val="DC2626"/>
+            </a:solidFill>
+          </a:ln>
+        </p:spPr>
+        <p:style>
+          <a:lnRef idx="2">
+            <a:schemeClr val="accent1">
+              <a:shade val="15000"/>
+            </a:schemeClr>
+          </a:lnRef>
+          <a:fillRef idx="1">
+            <a:schemeClr val="accent1"/>
+          </a:fillRef>
+          <a:effectRef idx="0">
+            <a:schemeClr val="accent1"/>
+          </a:effectRef>
+          <a:fontRef idx="minor">
+            <a:schemeClr val="lt1"/>
+          </a:fontRef>
+        </p:style>
+        <p:txBody>
+          <a:bodyPr rtlCol="0" anchor="ctr"/>
+          <a:lstStyle/>
+          <a:p>
+            <a:pPr algn="ctr"/>
+            <a:r>
+              <a:rPr lang="en-US" sz="1050" b="1">
+                <a:solidFill>
+                  <a:srgbClr val="DC2626"/>
+                </a:solidFill>
+              </a:rPr>
+              <a:t>🚒 Fire &amp; Emergency</a:t>
+            </a:r>
+          </a:p>
+          <a:p>
+            <a:pPr algn="ctr"/>
+            <a:r>
+              <a:rPr lang="en-US" sz="850">
+                <a:solidFill>
+                  <a:srgbClr val="1E3347"/>
+                </a:solidFill>
+              </a:rPr>
+              <a:t>Basement fires &amp; chemical leaks</a:t>
+            </a:r>
+            <a:endParaRPr lang="en-IN" sz="850">
+              <a:solidFill>
+                <a:srgbClr val="1E3347"/>
+              </a:solidFill>
+            </a:endParaRPr>
+          </a:p>
+        </p:txBody>
+      </p:sp>
+      <p:sp>
+        <p:nvSpPr>
+          <p:cNvPr id="19" name="Rectangle: Rounded Corners 18">
+            <a:extLst>
+              <a:ext uri="{FF2B5EF4-FFF2-40B4-BE49-F238E27FC236}">
+                <a16:creationId xmlns:a16="http://schemas.microsoft.com/office/drawing/2014/main" id="{5CB3D0BE-6B3C-84E3-967A-EC06D554CBC8}"/>
+              </a:ext>
+            </a:extLst>
+          </p:cNvPr>
+          <p:cNvSpPr/>
+          <p:nvPr/>
+        </p:nvSpPr>
+        <p:spPr>
+          <a:xfrm>
+            <a:off x="6146800" y="4699000"/>
+            <a:ext cx="2819400" cy="1333500"/>
           </a:xfrm>
           <a:prstGeom prst="roundRect">
             <a:avLst/>
@@ -10160,311 +9445,24 @@
           <a:lstStyle/>
           <a:p>
             <a:pPr algn="ctr"/>
-            <a:endParaRPr lang="en-IN"/>
-          </a:p>
-        </p:txBody>
-      </p:sp>
-      <p:sp>
-        <p:nvSpPr>
-          <p:cNvPr id="11" name="TextBox 10">
-            <a:extLst>
-              <a:ext uri="{FF2B5EF4-FFF2-40B4-BE49-F238E27FC236}">
-                <a16:creationId xmlns:a16="http://schemas.microsoft.com/office/drawing/2014/main" id="{79443D46-4E10-90DF-EFB9-FAB81274B957}"/>
-              </a:ext>
-            </a:extLst>
-          </p:cNvPr>
-          <p:cNvSpPr txBox="1"/>
-          <p:nvPr/>
-        </p:nvSpPr>
-        <p:spPr>
-          <a:xfrm>
-            <a:off x="355600" y="2082800"/>
-            <a:ext cx="5892800" cy="661720"/>
-          </a:xfrm>
-          <a:prstGeom prst="rect">
-            <a:avLst/>
-          </a:prstGeom>
-          <a:noFill/>
-        </p:spPr>
-        <p:txBody>
-          <a:bodyPr vert="horz" rtlCol="0">
-            <a:spAutoFit/>
-          </a:bodyPr>
-          <a:lstStyle/>
-          <a:p>
-            <a:r>
-              <a:rPr lang="en-IN" sz="1150" b="1">
+            <a:r>
+              <a:rPr lang="en-US" sz="1050" b="1">
                 <a:solidFill>
                   <a:srgbClr val="D97706"/>
                 </a:solidFill>
               </a:rPr>
-              <a:t>💰 Economic Democratization</a:t>
-            </a:r>
-          </a:p>
-          <a:p>
-            <a:r>
-              <a:rPr lang="en-IN" sz="850">
+              <a:t>⛏️ Mining Authorities</a:t>
+            </a:r>
+          </a:p>
+          <a:p>
+            <a:pPr algn="ctr"/>
+            <a:r>
+              <a:rPr lang="en-US" sz="850">
                 <a:solidFill>
                   <a:srgbClr val="1E3347"/>
                 </a:solidFill>
               </a:rPr>
-              <a:t>• 10x-20x Cost Reduction: Under ₹50,000 INR vs ₹25-40 Lakhs imported robots.</a:t>
-            </a:r>
-          </a:p>
-          <a:p>
-            <a:r>
-              <a:rPr lang="en-IN" sz="850">
-                <a:solidFill>
-                  <a:srgbClr val="1E3347"/>
-                </a:solidFill>
-              </a:rPr>
-              <a:t>• COTS Modular Maintenance: Standard parts, zero foreign service lock-in.</a:t>
-            </a:r>
-          </a:p>
-          <a:p>
-            <a:r>
-              <a:rPr lang="en-IN" sz="850">
-                <a:solidFill>
-                  <a:srgbClr val="1E3347"/>
-                </a:solidFill>
-              </a:rPr>
-              <a:t>• Scalable Pan-India Outreach: Affordable for every municipal fire station.</a:t>
-            </a:r>
-          </a:p>
-        </p:txBody>
-      </p:sp>
-      <p:sp>
-        <p:nvSpPr>
-          <p:cNvPr id="12" name="Rectangle: Rounded Corners 11">
-            <a:extLst>
-              <a:ext uri="{FF2B5EF4-FFF2-40B4-BE49-F238E27FC236}">
-                <a16:creationId xmlns:a16="http://schemas.microsoft.com/office/drawing/2014/main" id="{C1099044-332E-0033-6570-5FA551F3CE5C}"/>
-              </a:ext>
-            </a:extLst>
-          </p:cNvPr>
-          <p:cNvSpPr/>
-          <p:nvPr/>
-        </p:nvSpPr>
-        <p:spPr>
-          <a:xfrm>
-            <a:off x="254000" y="3327400"/>
-            <a:ext cx="6096000" cy="1193800"/>
-          </a:xfrm>
-          <a:prstGeom prst="roundRect">
-            <a:avLst/>
-          </a:prstGeom>
-          <a:solidFill>
-            <a:srgbClr val="ECFDF5"/>
-          </a:solidFill>
-          <a:ln w="19050">
-            <a:solidFill>
-              <a:srgbClr val="059669"/>
-            </a:solidFill>
-          </a:ln>
-        </p:spPr>
-        <p:style>
-          <a:lnRef idx="2">
-            <a:schemeClr val="accent1">
-              <a:shade val="15000"/>
-            </a:schemeClr>
-          </a:lnRef>
-          <a:fillRef idx="1">
-            <a:schemeClr val="accent1"/>
-          </a:fillRef>
-          <a:effectRef idx="0">
-            <a:schemeClr val="accent1"/>
-          </a:effectRef>
-          <a:fontRef idx="minor">
-            <a:schemeClr val="lt1"/>
-          </a:fontRef>
-        </p:style>
-        <p:txBody>
-          <a:bodyPr rtlCol="0" anchor="ctr"/>
-          <a:lstStyle/>
-          <a:p>
-            <a:pPr algn="ctr"/>
-            <a:endParaRPr lang="en-IN"/>
-          </a:p>
-        </p:txBody>
-      </p:sp>
-      <p:sp>
-        <p:nvSpPr>
-          <p:cNvPr id="13" name="TextBox 12">
-            <a:extLst>
-              <a:ext uri="{FF2B5EF4-FFF2-40B4-BE49-F238E27FC236}">
-                <a16:creationId xmlns:a16="http://schemas.microsoft.com/office/drawing/2014/main" id="{19FCE2B7-D925-1691-040E-4934CC18E7FD}"/>
-              </a:ext>
-            </a:extLst>
-          </p:cNvPr>
-          <p:cNvSpPr txBox="1"/>
-          <p:nvPr/>
-        </p:nvSpPr>
-        <p:spPr>
-          <a:xfrm>
-            <a:off x="355600" y="3378200"/>
-            <a:ext cx="5892800" cy="661720"/>
-          </a:xfrm>
-          <a:prstGeom prst="rect">
-            <a:avLst/>
-          </a:prstGeom>
-          <a:noFill/>
-        </p:spPr>
-        <p:txBody>
-          <a:bodyPr vert="horz" rtlCol="0">
-            <a:spAutoFit/>
-          </a:bodyPr>
-          <a:lstStyle/>
-          <a:p>
-            <a:r>
-              <a:rPr lang="en-IN" sz="1150" b="1">
-                <a:solidFill>
-                  <a:srgbClr val="059669"/>
-                </a:solidFill>
-              </a:rPr>
-              <a:t>🌱 Environmental &amp; Mine Safety</a:t>
-            </a:r>
-          </a:p>
-          <a:p>
-            <a:r>
-              <a:rPr lang="en-IN" sz="850">
-                <a:solidFill>
-                  <a:srgbClr val="1E3347"/>
-                </a:solidFill>
-              </a:rPr>
-              <a:t>• Real-Time Hazard Containment: MQ-135 tracks gas diffusion before civilian impact.</a:t>
-            </a:r>
-          </a:p>
-          <a:p>
-            <a:r>
-              <a:rPr lang="en-IN" sz="850">
-                <a:solidFill>
-                  <a:srgbClr val="1E3347"/>
-                </a:solidFill>
-              </a:rPr>
-              <a:t>• Zero-Emission Electric Locomotion: Safe in combustible &amp; low-oxygen shafts.</a:t>
-            </a:r>
-          </a:p>
-          <a:p>
-            <a:r>
-              <a:rPr lang="en-IN" sz="850">
-                <a:solidFill>
-                  <a:srgbClr val="1E3347"/>
-                </a:solidFill>
-              </a:rPr>
-              <a:t>• Deep Underground Recon: Safe for subterranean tunnels and coal mines.</a:t>
-            </a:r>
-          </a:p>
-        </p:txBody>
-      </p:sp>
-      <p:pic>
-        <p:nvPicPr>
-          <p:cNvPr id="15" name="Picture 14">
-            <a:extLst>
-              <a:ext uri="{FF2B5EF4-FFF2-40B4-BE49-F238E27FC236}">
-                <a16:creationId xmlns:a16="http://schemas.microsoft.com/office/drawing/2014/main" id="{1786D0F3-EB6A-09BE-2404-4D4E94AEC6DA}"/>
-              </a:ext>
-            </a:extLst>
-          </p:cNvPr>
-          <p:cNvPicPr>
-            <a:picLocks/>
-          </p:cNvPicPr>
-          <p:nvPr/>
-        </p:nvPicPr>
-        <p:blipFill>
-          <a:blip r:embed="rId2">
-            <a:extLst>
-              <a:ext uri="{28A0092B-C50C-407E-A947-70E740481C1C}">
-                <a14:useLocalDpi xmlns:a14="http://schemas.microsoft.com/office/drawing/2010/main" val="0"/>
-              </a:ext>
-            </a:extLst>
-          </a:blip>
-          <a:stretch>
-            <a:fillRect/>
-          </a:stretch>
-        </p:blipFill>
-        <p:spPr>
-          <a:xfrm>
-            <a:off x="6540500" y="736600"/>
-            <a:ext cx="5397500" cy="3810000"/>
-          </a:xfrm>
-          <a:prstGeom prst="rect">
-            <a:avLst/>
-          </a:prstGeom>
-          <a:ln w="25400">
-            <a:solidFill>
-              <a:schemeClr val="tx1"/>
-            </a:solidFill>
-          </a:ln>
-        </p:spPr>
-      </p:pic>
-      <p:sp>
-        <p:nvSpPr>
-          <p:cNvPr id="16" name="Rectangle: Rounded Corners 15">
-            <a:extLst>
-              <a:ext uri="{FF2B5EF4-FFF2-40B4-BE49-F238E27FC236}">
-                <a16:creationId xmlns:a16="http://schemas.microsoft.com/office/drawing/2014/main" id="{77403B8B-5412-8418-02F9-1B3525597598}"/>
-              </a:ext>
-            </a:extLst>
-          </p:cNvPr>
-          <p:cNvSpPr/>
-          <p:nvPr/>
-        </p:nvSpPr>
-        <p:spPr>
-          <a:xfrm>
-            <a:off x="254000" y="4699000"/>
-            <a:ext cx="2819400" cy="1333500"/>
-          </a:xfrm>
-          <a:prstGeom prst="roundRect">
-            <a:avLst/>
-          </a:prstGeom>
-          <a:solidFill>
-            <a:srgbClr val="F0F9FF"/>
-          </a:solidFill>
-          <a:ln w="19050">
-            <a:solidFill>
-              <a:srgbClr val="0284C7"/>
-            </a:solidFill>
-          </a:ln>
-        </p:spPr>
-        <p:style>
-          <a:lnRef idx="2">
-            <a:schemeClr val="accent1">
-              <a:shade val="15000"/>
-            </a:schemeClr>
-          </a:lnRef>
-          <a:fillRef idx="1">
-            <a:schemeClr val="accent1"/>
-          </a:fillRef>
-          <a:effectRef idx="0">
-            <a:schemeClr val="accent1"/>
-          </a:effectRef>
-          <a:fontRef idx="minor">
-            <a:schemeClr val="lt1"/>
-          </a:fontRef>
-        </p:style>
-        <p:txBody>
-          <a:bodyPr rtlCol="0" anchor="ctr"/>
-          <a:lstStyle/>
-          <a:p>
-            <a:pPr algn="ctr"/>
-            <a:r>
-              <a:rPr lang="en-US" sz="1050" b="1">
-                <a:solidFill>
-                  <a:srgbClr val="0284C7"/>
-                </a:solidFill>
-              </a:rPr>
-              <a:t>🏛️ NDRF &amp; State SDRF</a:t>
-            </a:r>
-          </a:p>
-          <a:p>
-            <a:pPr algn="ctr"/>
-            <a:r>
-              <a:rPr lang="en-US" sz="850">
-                <a:solidFill>
-                  <a:srgbClr val="1E3347"/>
-                </a:solidFill>
-              </a:rPr>
-              <a:t>Earthquake &amp; building collapses</a:t>
+              <a:t>Deep coal mine &amp; tunnel collapse</a:t>
             </a:r>
             <a:endParaRPr lang="en-IN" sz="850">
               <a:solidFill>
@@ -10476,164 +9474,10 @@
       </p:sp>
       <p:sp>
         <p:nvSpPr>
-          <p:cNvPr id="17" name="Rectangle: Rounded Corners 16">
-            <a:extLst>
-              <a:ext uri="{FF2B5EF4-FFF2-40B4-BE49-F238E27FC236}">
-                <a16:creationId xmlns:a16="http://schemas.microsoft.com/office/drawing/2014/main" id="{5C4EBCC8-1303-E46A-80B6-F75F94FC876B}"/>
-              </a:ext>
-            </a:extLst>
-          </p:cNvPr>
-          <p:cNvSpPr/>
-          <p:nvPr/>
-        </p:nvSpPr>
-        <p:spPr>
-          <a:xfrm>
-            <a:off x="3200400" y="4699000"/>
-            <a:ext cx="2819400" cy="1333500"/>
-          </a:xfrm>
-          <a:prstGeom prst="roundRect">
-            <a:avLst/>
-          </a:prstGeom>
-          <a:solidFill>
-            <a:srgbClr val="FEF2F2"/>
-          </a:solidFill>
-          <a:ln w="19050">
-            <a:solidFill>
-              <a:srgbClr val="DC2626"/>
-            </a:solidFill>
-          </a:ln>
-        </p:spPr>
-        <p:style>
-          <a:lnRef idx="2">
-            <a:schemeClr val="accent1">
-              <a:shade val="15000"/>
-            </a:schemeClr>
-          </a:lnRef>
-          <a:fillRef idx="1">
-            <a:schemeClr val="accent1"/>
-          </a:fillRef>
-          <a:effectRef idx="0">
-            <a:schemeClr val="accent1"/>
-          </a:effectRef>
-          <a:fontRef idx="minor">
-            <a:schemeClr val="lt1"/>
-          </a:fontRef>
-        </p:style>
-        <p:txBody>
-          <a:bodyPr rtlCol="0" anchor="ctr"/>
-          <a:lstStyle/>
-          <a:p>
-            <a:pPr algn="ctr"/>
-            <a:r>
-              <a:rPr lang="en-US" sz="1050" b="1">
-                <a:solidFill>
-                  <a:srgbClr val="DC2626"/>
-                </a:solidFill>
-              </a:rPr>
-              <a:t>🚒 Fire &amp; Emergency</a:t>
-            </a:r>
-          </a:p>
-          <a:p>
-            <a:pPr algn="ctr"/>
-            <a:r>
-              <a:rPr lang="en-US" sz="850">
-                <a:solidFill>
-                  <a:srgbClr val="1E3347"/>
-                </a:solidFill>
-              </a:rPr>
-              <a:t>Basement fires &amp; chemical leaks</a:t>
-            </a:r>
-            <a:endParaRPr lang="en-IN" sz="850">
-              <a:solidFill>
-                <a:srgbClr val="1E3347"/>
-              </a:solidFill>
-            </a:endParaRPr>
-          </a:p>
-        </p:txBody>
-      </p:sp>
-      <p:sp>
-        <p:nvSpPr>
-          <p:cNvPr id="18" name="Rectangle: Rounded Corners 17">
-            <a:extLst>
-              <a:ext uri="{FF2B5EF4-FFF2-40B4-BE49-F238E27FC236}">
-                <a16:creationId xmlns:a16="http://schemas.microsoft.com/office/drawing/2014/main" id="{A2EBD739-88D9-6FAB-5AFD-7E7F485B81BE}"/>
-              </a:ext>
-            </a:extLst>
-          </p:cNvPr>
-          <p:cNvSpPr/>
-          <p:nvPr/>
-        </p:nvSpPr>
-        <p:spPr>
-          <a:xfrm>
-            <a:off x="6146800" y="4699000"/>
-            <a:ext cx="2819400" cy="1333500"/>
-          </a:xfrm>
-          <a:prstGeom prst="roundRect">
-            <a:avLst/>
-          </a:prstGeom>
-          <a:solidFill>
-            <a:srgbClr val="FFFBEB"/>
-          </a:solidFill>
-          <a:ln w="19050">
-            <a:solidFill>
-              <a:srgbClr val="D97706"/>
-            </a:solidFill>
-          </a:ln>
-        </p:spPr>
-        <p:style>
-          <a:lnRef idx="2">
-            <a:schemeClr val="accent1">
-              <a:shade val="15000"/>
-            </a:schemeClr>
-          </a:lnRef>
-          <a:fillRef idx="1">
-            <a:schemeClr val="accent1"/>
-          </a:fillRef>
-          <a:effectRef idx="0">
-            <a:schemeClr val="accent1"/>
-          </a:effectRef>
-          <a:fontRef idx="minor">
-            <a:schemeClr val="lt1"/>
-          </a:fontRef>
-        </p:style>
-        <p:txBody>
-          <a:bodyPr rtlCol="0" anchor="ctr"/>
-          <a:lstStyle/>
-          <a:p>
-            <a:pPr algn="ctr"/>
-            <a:r>
-              <a:rPr lang="en-US" sz="1050" b="1">
-                <a:solidFill>
-                  <a:srgbClr val="D97706"/>
-                </a:solidFill>
-              </a:rPr>
-              <a:t>⛏️ Mining Authorities</a:t>
-            </a:r>
-          </a:p>
-          <a:p>
-            <a:pPr algn="ctr"/>
-            <a:r>
-              <a:rPr lang="en-US" sz="850">
-                <a:solidFill>
-                  <a:srgbClr val="1E3347"/>
-                </a:solidFill>
-              </a:rPr>
-              <a:t>Deep coal mine &amp; tunnel collapse</a:t>
-            </a:r>
-            <a:endParaRPr lang="en-IN" sz="850">
-              <a:solidFill>
-                <a:srgbClr val="1E3347"/>
-              </a:solidFill>
-            </a:endParaRPr>
-          </a:p>
-        </p:txBody>
-      </p:sp>
-      <p:sp>
-        <p:nvSpPr>
-          <p:cNvPr id="19" name="Rectangle: Rounded Corners 18">
-            <a:extLst>
-              <a:ext uri="{FF2B5EF4-FFF2-40B4-BE49-F238E27FC236}">
-                <a16:creationId xmlns:a16="http://schemas.microsoft.com/office/drawing/2014/main" id="{9A845662-7DD0-DCEE-A0A0-4613F3ACAC97}"/>
+          <p:cNvPr id="20" name="Rectangle: Rounded Corners 19">
+            <a:extLst>
+              <a:ext uri="{FF2B5EF4-FFF2-40B4-BE49-F238E27FC236}">
+                <a16:creationId xmlns:a16="http://schemas.microsoft.com/office/drawing/2014/main" id="{6D726934-4752-3C2C-A1A4-C5C125743BE4}"/>
               </a:ext>
             </a:extLst>
           </p:cNvPr>
@@ -10702,10 +9546,10 @@
       </p:sp>
       <p:sp>
         <p:nvSpPr>
-          <p:cNvPr id="20" name="Rectangle 19">
-            <a:extLst>
-              <a:ext uri="{FF2B5EF4-FFF2-40B4-BE49-F238E27FC236}">
-                <a16:creationId xmlns:a16="http://schemas.microsoft.com/office/drawing/2014/main" id="{39FF4D41-2FA4-4A3A-CC6E-F3D05E62D2B6}"/>
+          <p:cNvPr id="21" name="Rectangle 20">
+            <a:extLst>
+              <a:ext uri="{FF2B5EF4-FFF2-40B4-BE49-F238E27FC236}">
+                <a16:creationId xmlns:a16="http://schemas.microsoft.com/office/drawing/2014/main" id="{CD0CE386-2348-1837-827C-35E494062E95}"/>
               </a:ext>
             </a:extLst>
           </p:cNvPr>
@@ -10756,10 +9600,10 @@
       </p:sp>
       <p:sp>
         <p:nvSpPr>
-          <p:cNvPr id="21" name="TextBox 20">
-            <a:extLst>
-              <a:ext uri="{FF2B5EF4-FFF2-40B4-BE49-F238E27FC236}">
-                <a16:creationId xmlns:a16="http://schemas.microsoft.com/office/drawing/2014/main" id="{EE5EB6C6-0DB5-6CD4-EC0F-279D6CC691D7}"/>
+          <p:cNvPr id="22" name="TextBox 21">
+            <a:extLst>
+              <a:ext uri="{FF2B5EF4-FFF2-40B4-BE49-F238E27FC236}">
+                <a16:creationId xmlns:a16="http://schemas.microsoft.com/office/drawing/2014/main" id="{42886A8A-F672-11DF-D030-748B59661A60}"/>
               </a:ext>
             </a:extLst>
           </p:cNvPr>
@@ -10801,7 +9645,7 @@
     </p:spTree>
     <p:extLst>
       <p:ext uri="{BB962C8B-B14F-4D97-AF65-F5344CB8AC3E}">
-        <p14:creationId xmlns:p14="http://schemas.microsoft.com/office/powerpoint/2010/main" val="4283101889"/>
+        <p14:creationId xmlns:p14="http://schemas.microsoft.com/office/powerpoint/2010/main" val="707329760"/>
       </p:ext>
     </p:extLst>
   </p:cSld>
@@ -10833,7 +9677,7 @@
           <p:cNvPr id="2" name="Rectangle 1">
             <a:extLst>
               <a:ext uri="{FF2B5EF4-FFF2-40B4-BE49-F238E27FC236}">
-                <a16:creationId xmlns:a16="http://schemas.microsoft.com/office/drawing/2014/main" id="{F41D28D4-632B-DBF5-AEB5-77897738AB5A}"/>
+                <a16:creationId xmlns:a16="http://schemas.microsoft.com/office/drawing/2014/main" id="{8EDC5344-BE9F-9FD4-C49D-04C2920C2ADC}"/>
               </a:ext>
             </a:extLst>
           </p:cNvPr>
@@ -10901,7 +9745,7 @@
           <p:cNvPr id="3" name="Rectangle 2">
             <a:extLst>
               <a:ext uri="{FF2B5EF4-FFF2-40B4-BE49-F238E27FC236}">
-                <a16:creationId xmlns:a16="http://schemas.microsoft.com/office/drawing/2014/main" id="{FE4AF228-068A-E0F1-8051-4506C774F9AB}"/>
+                <a16:creationId xmlns:a16="http://schemas.microsoft.com/office/drawing/2014/main" id="{5C6D3F2F-DCA7-2942-8031-92C4931D356A}"/>
               </a:ext>
             </a:extLst>
           </p:cNvPr>
@@ -10955,7 +9799,7 @@
           <p:cNvPr id="4" name="Rectangle: Rounded Corners 3">
             <a:extLst>
               <a:ext uri="{FF2B5EF4-FFF2-40B4-BE49-F238E27FC236}">
-                <a16:creationId xmlns:a16="http://schemas.microsoft.com/office/drawing/2014/main" id="{8AF8A4E9-B619-1D36-6E25-F6CE296BD414}"/>
+                <a16:creationId xmlns:a16="http://schemas.microsoft.com/office/drawing/2014/main" id="{F194B7A8-F91E-A828-D178-73AC6847FE84}"/>
               </a:ext>
             </a:extLst>
           </p:cNvPr>
@@ -11030,7 +9874,7 @@
           <p:cNvPr id="5" name="TextBox 4">
             <a:extLst>
               <a:ext uri="{FF2B5EF4-FFF2-40B4-BE49-F238E27FC236}">
-                <a16:creationId xmlns:a16="http://schemas.microsoft.com/office/drawing/2014/main" id="{3B7D794A-F989-E4C3-A652-CB7347AE73C9}"/>
+                <a16:creationId xmlns:a16="http://schemas.microsoft.com/office/drawing/2014/main" id="{C25748B4-7AE4-00F9-E477-F7FE2AC8AB1E}"/>
               </a:ext>
             </a:extLst>
           </p:cNvPr>
@@ -11074,7 +9918,7 @@
           <p:cNvPr id="6" name="Rectangle: Rounded Corners 5">
             <a:extLst>
               <a:ext uri="{FF2B5EF4-FFF2-40B4-BE49-F238E27FC236}">
-                <a16:creationId xmlns:a16="http://schemas.microsoft.com/office/drawing/2014/main" id="{AF199952-97F6-D368-2747-26B7917237B7}"/>
+                <a16:creationId xmlns:a16="http://schemas.microsoft.com/office/drawing/2014/main" id="{3A3B905D-A3C8-546B-9BEB-0852E146AEC7}"/>
               </a:ext>
             </a:extLst>
           </p:cNvPr>
@@ -11130,73 +9974,48 @@
           </a:p>
         </p:txBody>
       </p:sp>
-      <p:sp>
-        <p:nvSpPr>
-          <p:cNvPr id="7" name="Rectangle: Rounded Corners 6">
-            <a:extLst>
-              <a:ext uri="{FF2B5EF4-FFF2-40B4-BE49-F238E27FC236}">
-                <a16:creationId xmlns:a16="http://schemas.microsoft.com/office/drawing/2014/main" id="{44924C84-6E6C-2D0A-CDEC-2802234E24BC}"/>
-              </a:ext>
-            </a:extLst>
-          </p:cNvPr>
-          <p:cNvSpPr/>
-          <p:nvPr/>
-        </p:nvSpPr>
-        <p:spPr>
-          <a:xfrm>
-            <a:off x="11112500" y="88900"/>
-            <a:ext cx="825500" cy="431800"/>
-          </a:xfrm>
-          <a:prstGeom prst="roundRect">
-            <a:avLst/>
-          </a:prstGeom>
-          <a:solidFill>
-            <a:srgbClr val="FFFBEB"/>
-          </a:solidFill>
-          <a:ln w="19050">
-            <a:solidFill>
-              <a:srgbClr val="D97706"/>
-            </a:solidFill>
-          </a:ln>
-        </p:spPr>
-        <p:style>
-          <a:lnRef idx="2">
-            <a:schemeClr val="accent1">
-              <a:shade val="15000"/>
-            </a:schemeClr>
-          </a:lnRef>
-          <a:fillRef idx="1">
-            <a:schemeClr val="accent1"/>
-          </a:fillRef>
-          <a:effectRef idx="0">
-            <a:schemeClr val="accent1"/>
-          </a:effectRef>
-          <a:fontRef idx="minor">
-            <a:schemeClr val="lt1"/>
-          </a:fontRef>
-        </p:style>
-        <p:txBody>
-          <a:bodyPr rtlCol="0" anchor="ctr"/>
-          <a:lstStyle/>
-          <a:p>
-            <a:pPr algn="ctr"/>
-            <a:r>
-              <a:rPr lang="en-IN" sz="800" b="1">
-                <a:solidFill>
-                  <a:srgbClr val="D97706"/>
-                </a:solidFill>
-              </a:rPr>
-              <a:t>[SIH LOGO]</a:t>
-            </a:r>
-          </a:p>
-        </p:txBody>
-      </p:sp>
-      <p:sp>
-        <p:nvSpPr>
-          <p:cNvPr id="8" name="Rectangle: Rounded Corners 7">
-            <a:extLst>
-              <a:ext uri="{FF2B5EF4-FFF2-40B4-BE49-F238E27FC236}">
-                <a16:creationId xmlns:a16="http://schemas.microsoft.com/office/drawing/2014/main" id="{DC074134-92EC-AE66-59D3-82468FE626A3}"/>
+      <p:pic>
+        <p:nvPicPr>
+          <p:cNvPr id="8" name="Picture 7">
+            <a:extLst>
+              <a:ext uri="{FF2B5EF4-FFF2-40B4-BE49-F238E27FC236}">
+                <a16:creationId xmlns:a16="http://schemas.microsoft.com/office/drawing/2014/main" id="{536CB183-07CC-AA54-284D-587F969C0CD0}"/>
+              </a:ext>
+            </a:extLst>
+          </p:cNvPr>
+          <p:cNvPicPr>
+            <a:picLocks/>
+          </p:cNvPicPr>
+          <p:nvPr/>
+        </p:nvPicPr>
+        <p:blipFill>
+          <a:blip r:embed="rId2">
+            <a:extLst>
+              <a:ext uri="{28A0092B-C50C-407E-A947-70E740481C1C}">
+                <a14:useLocalDpi xmlns:a14="http://schemas.microsoft.com/office/drawing/2010/main" val="0"/>
+              </a:ext>
+            </a:extLst>
+          </a:blip>
+          <a:stretch>
+            <a:fillRect/>
+          </a:stretch>
+        </p:blipFill>
+        <p:spPr>
+          <a:xfrm>
+            <a:off x="11023600" y="76200"/>
+            <a:ext cx="965200" cy="457200"/>
+          </a:xfrm>
+          <a:prstGeom prst="rect">
+            <a:avLst/>
+          </a:prstGeom>
+        </p:spPr>
+      </p:pic>
+      <p:sp>
+        <p:nvSpPr>
+          <p:cNvPr id="9" name="Rectangle: Rounded Corners 8">
+            <a:extLst>
+              <a:ext uri="{FF2B5EF4-FFF2-40B4-BE49-F238E27FC236}">
+                <a16:creationId xmlns:a16="http://schemas.microsoft.com/office/drawing/2014/main" id="{F8D0E093-E8F8-5DF0-D6BF-9CE1CE5BCD85}"/>
               </a:ext>
             </a:extLst>
           </p:cNvPr>
@@ -11247,10 +10066,10 @@
       </p:sp>
       <p:sp>
         <p:nvSpPr>
-          <p:cNvPr id="9" name="TextBox 8">
-            <a:extLst>
-              <a:ext uri="{FF2B5EF4-FFF2-40B4-BE49-F238E27FC236}">
-                <a16:creationId xmlns:a16="http://schemas.microsoft.com/office/drawing/2014/main" id="{669292D7-75E6-0C1B-FC4E-843B98A38C5B}"/>
+          <p:cNvPr id="10" name="TextBox 9">
+            <a:extLst>
+              <a:ext uri="{FF2B5EF4-FFF2-40B4-BE49-F238E27FC236}">
+                <a16:creationId xmlns:a16="http://schemas.microsoft.com/office/drawing/2014/main" id="{48E21499-136C-0D80-CDD3-20B94DC0D7A6}"/>
               </a:ext>
             </a:extLst>
           </p:cNvPr>
@@ -11326,10 +10145,10 @@
       </p:sp>
       <p:sp>
         <p:nvSpPr>
-          <p:cNvPr id="10" name="Rectangle: Rounded Corners 9">
-            <a:extLst>
-              <a:ext uri="{FF2B5EF4-FFF2-40B4-BE49-F238E27FC236}">
-                <a16:creationId xmlns:a16="http://schemas.microsoft.com/office/drawing/2014/main" id="{4491E3B3-9AAF-439D-C87A-5CDF48B74E90}"/>
+          <p:cNvPr id="11" name="Rectangle: Rounded Corners 10">
+            <a:extLst>
+              <a:ext uri="{FF2B5EF4-FFF2-40B4-BE49-F238E27FC236}">
+                <a16:creationId xmlns:a16="http://schemas.microsoft.com/office/drawing/2014/main" id="{6A629932-754B-6C64-B4CC-73B3D86532BC}"/>
               </a:ext>
             </a:extLst>
           </p:cNvPr>
@@ -11380,10 +10199,10 @@
       </p:sp>
       <p:sp>
         <p:nvSpPr>
-          <p:cNvPr id="11" name="TextBox 10">
-            <a:extLst>
-              <a:ext uri="{FF2B5EF4-FFF2-40B4-BE49-F238E27FC236}">
-                <a16:creationId xmlns:a16="http://schemas.microsoft.com/office/drawing/2014/main" id="{9DE38308-0DAA-CC66-D602-9A0C14EAC9FA}"/>
+          <p:cNvPr id="12" name="TextBox 11">
+            <a:extLst>
+              <a:ext uri="{FF2B5EF4-FFF2-40B4-BE49-F238E27FC236}">
+                <a16:creationId xmlns:a16="http://schemas.microsoft.com/office/drawing/2014/main" id="{ECD9E380-98CA-F9AC-1160-437BF2C1AC96}"/>
               </a:ext>
             </a:extLst>
           </p:cNvPr>
@@ -11459,10 +10278,10 @@
       </p:sp>
       <p:sp>
         <p:nvSpPr>
-          <p:cNvPr id="12" name="Rectangle: Rounded Corners 11">
-            <a:extLst>
-              <a:ext uri="{FF2B5EF4-FFF2-40B4-BE49-F238E27FC236}">
-                <a16:creationId xmlns:a16="http://schemas.microsoft.com/office/drawing/2014/main" id="{609A4393-918E-A32B-7E3A-107A881C0C7B}"/>
+          <p:cNvPr id="13" name="Rectangle: Rounded Corners 12">
+            <a:extLst>
+              <a:ext uri="{FF2B5EF4-FFF2-40B4-BE49-F238E27FC236}">
+                <a16:creationId xmlns:a16="http://schemas.microsoft.com/office/drawing/2014/main" id="{4D2DE0CB-4046-87CE-3099-8AEA7058A401}"/>
               </a:ext>
             </a:extLst>
           </p:cNvPr>
@@ -11513,10 +10332,10 @@
       </p:sp>
       <p:sp>
         <p:nvSpPr>
-          <p:cNvPr id="13" name="TextBox 12">
-            <a:extLst>
-              <a:ext uri="{FF2B5EF4-FFF2-40B4-BE49-F238E27FC236}">
-                <a16:creationId xmlns:a16="http://schemas.microsoft.com/office/drawing/2014/main" id="{B2A4A16A-ECDA-AF22-4B11-41CE3A6357DE}"/>
+          <p:cNvPr id="14" name="TextBox 13">
+            <a:extLst>
+              <a:ext uri="{FF2B5EF4-FFF2-40B4-BE49-F238E27FC236}">
+                <a16:creationId xmlns:a16="http://schemas.microsoft.com/office/drawing/2014/main" id="{E9AA07B3-BD4B-D8AE-17F3-F138FAF0959F}"/>
               </a:ext>
             </a:extLst>
           </p:cNvPr>
@@ -11592,10 +10411,10 @@
       </p:sp>
       <p:sp>
         <p:nvSpPr>
-          <p:cNvPr id="14" name="Rectangle: Rounded Corners 13">
-            <a:extLst>
-              <a:ext uri="{FF2B5EF4-FFF2-40B4-BE49-F238E27FC236}">
-                <a16:creationId xmlns:a16="http://schemas.microsoft.com/office/drawing/2014/main" id="{83F54840-5C82-09EE-943C-C2F978AA527C}"/>
+          <p:cNvPr id="15" name="Rectangle: Rounded Corners 14">
+            <a:extLst>
+              <a:ext uri="{FF2B5EF4-FFF2-40B4-BE49-F238E27FC236}">
+                <a16:creationId xmlns:a16="http://schemas.microsoft.com/office/drawing/2014/main" id="{E692EF52-4A42-2391-D73C-15FA3C9F608A}"/>
               </a:ext>
             </a:extLst>
           </p:cNvPr>
@@ -11646,10 +10465,10 @@
       </p:sp>
       <p:sp>
         <p:nvSpPr>
-          <p:cNvPr id="15" name="TextBox 14">
-            <a:extLst>
-              <a:ext uri="{FF2B5EF4-FFF2-40B4-BE49-F238E27FC236}">
-                <a16:creationId xmlns:a16="http://schemas.microsoft.com/office/drawing/2014/main" id="{6C9008F7-F6F1-4B97-B842-596D43480D60}"/>
+          <p:cNvPr id="16" name="TextBox 15">
+            <a:extLst>
+              <a:ext uri="{FF2B5EF4-FFF2-40B4-BE49-F238E27FC236}">
+                <a16:creationId xmlns:a16="http://schemas.microsoft.com/office/drawing/2014/main" id="{D806FCC4-D59F-95F3-CCFE-957D52D4B2BA}"/>
               </a:ext>
             </a:extLst>
           </p:cNvPr>
@@ -11725,10 +10544,10 @@
       </p:sp>
       <p:sp>
         <p:nvSpPr>
-          <p:cNvPr id="16" name="Rectangle: Rounded Corners 15">
-            <a:extLst>
-              <a:ext uri="{FF2B5EF4-FFF2-40B4-BE49-F238E27FC236}">
-                <a16:creationId xmlns:a16="http://schemas.microsoft.com/office/drawing/2014/main" id="{CCC8D79A-37DC-8291-76EB-B20EE731FCDB}"/>
+          <p:cNvPr id="17" name="Rectangle: Rounded Corners 16">
+            <a:extLst>
+              <a:ext uri="{FF2B5EF4-FFF2-40B4-BE49-F238E27FC236}">
+                <a16:creationId xmlns:a16="http://schemas.microsoft.com/office/drawing/2014/main" id="{6953360F-BEFD-D2CC-25C6-D4A3CCA89682}"/>
               </a:ext>
             </a:extLst>
           </p:cNvPr>
@@ -11779,10 +10598,10 @@
       </p:sp>
       <p:sp>
         <p:nvSpPr>
-          <p:cNvPr id="17" name="TextBox 16">
-            <a:extLst>
-              <a:ext uri="{FF2B5EF4-FFF2-40B4-BE49-F238E27FC236}">
-                <a16:creationId xmlns:a16="http://schemas.microsoft.com/office/drawing/2014/main" id="{A472E4D4-1994-BCCA-4A13-30118390BB79}"/>
+          <p:cNvPr id="18" name="TextBox 17">
+            <a:extLst>
+              <a:ext uri="{FF2B5EF4-FFF2-40B4-BE49-F238E27FC236}">
+                <a16:creationId xmlns:a16="http://schemas.microsoft.com/office/drawing/2014/main" id="{067EA0AF-4578-8111-DEBA-7E4168BE42E6}"/>
               </a:ext>
             </a:extLst>
           </p:cNvPr>
@@ -11843,10 +10662,10 @@
       </p:sp>
       <p:sp>
         <p:nvSpPr>
-          <p:cNvPr id="18" name="Rectangle 17">
-            <a:extLst>
-              <a:ext uri="{FF2B5EF4-FFF2-40B4-BE49-F238E27FC236}">
-                <a16:creationId xmlns:a16="http://schemas.microsoft.com/office/drawing/2014/main" id="{D21F1AE9-05FB-4FDC-B31E-3CE7759F9362}"/>
+          <p:cNvPr id="19" name="Rectangle 18">
+            <a:extLst>
+              <a:ext uri="{FF2B5EF4-FFF2-40B4-BE49-F238E27FC236}">
+                <a16:creationId xmlns:a16="http://schemas.microsoft.com/office/drawing/2014/main" id="{460A833E-4620-BBE4-637D-8FBA8287FF49}"/>
               </a:ext>
             </a:extLst>
           </p:cNvPr>
@@ -11897,10 +10716,10 @@
       </p:sp>
       <p:sp>
         <p:nvSpPr>
-          <p:cNvPr id="19" name="TextBox 18">
-            <a:extLst>
-              <a:ext uri="{FF2B5EF4-FFF2-40B4-BE49-F238E27FC236}">
-                <a16:creationId xmlns:a16="http://schemas.microsoft.com/office/drawing/2014/main" id="{7F67F483-D1BF-9650-036B-EB76275D339F}"/>
+          <p:cNvPr id="20" name="TextBox 19">
+            <a:extLst>
+              <a:ext uri="{FF2B5EF4-FFF2-40B4-BE49-F238E27FC236}">
+                <a16:creationId xmlns:a16="http://schemas.microsoft.com/office/drawing/2014/main" id="{F870D525-0EFF-12B6-B9BF-894F123F29AA}"/>
               </a:ext>
             </a:extLst>
           </p:cNvPr>
@@ -11937,7 +10756,7 @@
     </p:spTree>
     <p:extLst>
       <p:ext uri="{BB962C8B-B14F-4D97-AF65-F5344CB8AC3E}">
-        <p14:creationId xmlns:p14="http://schemas.microsoft.com/office/powerpoint/2010/main" val="1660450914"/>
+        <p14:creationId xmlns:p14="http://schemas.microsoft.com/office/powerpoint/2010/main" val="3542036788"/>
       </p:ext>
     </p:extLst>
   </p:cSld>

</xml_diff>